<commit_message>
fix related to rubric
</commit_message>
<xml_diff>
--- a/tools/llm-as-a-judge/readme.pptx
+++ b/tools/llm-as-a-judge/readme.pptx
@@ -6,24 +6,24 @@
   </p:sldMasterIdLst>
   <p:sldIdLst>
     <p:sldId id="257" r:id="rId2"/>
-    <p:sldId id="295" r:id="rId3"/>
+    <p:sldId id="311" r:id="rId3"/>
     <p:sldId id="258" r:id="rId4"/>
     <p:sldId id="273" r:id="rId5"/>
-    <p:sldId id="303" r:id="rId6"/>
+    <p:sldId id="312" r:id="rId6"/>
     <p:sldId id="309" r:id="rId7"/>
     <p:sldId id="262" r:id="rId8"/>
-    <p:sldId id="304" r:id="rId9"/>
+    <p:sldId id="313" r:id="rId9"/>
     <p:sldId id="264" r:id="rId10"/>
-    <p:sldId id="305" r:id="rId11"/>
+    <p:sldId id="314" r:id="rId11"/>
     <p:sldId id="301" r:id="rId12"/>
-    <p:sldId id="306" r:id="rId13"/>
+    <p:sldId id="315" r:id="rId13"/>
     <p:sldId id="310" r:id="rId14"/>
     <p:sldId id="266" r:id="rId15"/>
     <p:sldId id="259" r:id="rId16"/>
-    <p:sldId id="307" r:id="rId17"/>
+    <p:sldId id="316" r:id="rId17"/>
     <p:sldId id="268" r:id="rId18"/>
     <p:sldId id="270" r:id="rId19"/>
-    <p:sldId id="308" r:id="rId20"/>
+    <p:sldId id="317" r:id="rId20"/>
     <p:sldId id="272" r:id="rId21"/>
   </p:sldIdLst>
   <p:sldSz cx="12192000" cy="6858000"/>
@@ -1434,7 +1434,7 @@
         </p:nvGraphicFramePr>
         <p:xfrm>
           <a:off x="1236000" y="274320"/>
-          <a:ext cx="9720000" cy="6309360"/>
+          <a:ext cx="9720000" cy="6461760"/>
         </p:xfrm>
         <a:graphic>
           <a:graphicData uri="http://schemas.openxmlformats.org/drawingml/2006/table">
@@ -2269,7 +2269,7 @@
                           <a:ea typeface="Cascadia Mono" panose="020B0609020000020004" pitchFamily="49" charset="0"/>
                           <a:cs typeface="Cascadia Mono" panose="020B0609020000020004" pitchFamily="49" charset="0"/>
                         </a:rPr>
-                        <a:t>work/*.xlsx</a:t>
+                        <a:t>work/*.work.xlsx</a:t>
                       </a:r>
                       <a:r>
                         <a:rPr kumimoji="1" lang="en-US" altLang="ja-JP" sz="1000">
@@ -2468,7 +2468,7 @@
                           <a:ea typeface="Cascadia Mono" panose="020B0609020000020004" pitchFamily="49" charset="0"/>
                           <a:cs typeface="Cascadia Mono" panose="020B0609020000020004" pitchFamily="49" charset="0"/>
                         </a:rPr>
-                        <a:t>work/*.xlsx</a:t>
+                        <a:t>work/*.work.xlsx</a:t>
                       </a:r>
                       <a:r>
                         <a:rPr kumimoji="1" lang="en-US" altLang="ja-JP" sz="1000">
@@ -2487,7 +2487,7 @@
                           <a:ea typeface="Cascadia Mono" panose="020B0609020000020004" pitchFamily="49" charset="0"/>
                           <a:cs typeface="Cascadia Mono" panose="020B0609020000020004" pitchFamily="49" charset="0"/>
                         </a:rPr>
-                        <a:t>rubric/*.json</a:t>
+                        <a:t>rubric/*.criteria.txt</a:t>
                       </a:r>
                       <a:r>
                         <a:rPr kumimoji="1" lang="en-US" altLang="ja-JP" sz="1000">
@@ -2506,7 +2506,7 @@
                           <a:ea typeface="Cascadia Mono" panose="020B0609020000020004" pitchFamily="49" charset="0"/>
                           <a:cs typeface="Cascadia Mono" panose="020B0609020000020004" pitchFamily="49" charset="0"/>
                         </a:rPr>
-                        <a:t>work/*.xlsx</a:t>
+                        <a:t>work/*.work.xlsx</a:t>
                       </a:r>
                       <a:r>
                         <a:rPr kumimoji="1" lang="en-US" altLang="ja-JP" sz="1000" b="0" i="0">
@@ -3547,7 +3547,7 @@
                           <a:ea typeface="Cascadia Mono" panose="020B0609020000020004" pitchFamily="49" charset="0"/>
                           <a:cs typeface="Cascadia Mono" panose="020B0609020000020004" pitchFamily="49" charset="0"/>
                         </a:rPr>
-                        <a:t>rubric/*.json</a:t>
+                        <a:t>rubric/*.criteria.txt</a:t>
                       </a:r>
                       <a:r>
                         <a:rPr kumimoji="1" lang="en-US" altLang="ja-JP" sz="1000">
@@ -3816,7 +3816,7 @@
                           <a:ea typeface="Cascadia Mono" panose="020B0609020000020004" pitchFamily="49" charset="0"/>
                           <a:cs typeface="Cascadia Mono" panose="020B0609020000020004" pitchFamily="49" charset="0"/>
                         </a:rPr>
-                        <a:t>rubric/*.json</a:t>
+                        <a:t>rubric/*.criteria.txt</a:t>
                       </a:r>
                       <a:r>
                         <a:rPr kumimoji="1" lang="en-US" altLang="ja-JP" sz="1000">
@@ -3835,7 +3835,7 @@
                           <a:ea typeface="Cascadia Mono" panose="020B0609020000020004" pitchFamily="49" charset="0"/>
                           <a:cs typeface="Cascadia Mono" panose="020B0609020000020004" pitchFamily="49" charset="0"/>
                         </a:rPr>
-                        <a:t>work/*.xlsx </a:t>
+                        <a:t>work/*.work.xlsx </a:t>
                       </a:r>
                       <a:r>
                         <a:rPr kumimoji="1" lang="en-US" altLang="ja-JP" sz="1000">
@@ -16714,6 +16714,3214 @@
 </p:sldLayout>
 </file>
 
+<file path=ppt/slideLayouts/slideLayout6.xml><?xml version="1.0" encoding="utf-8"?>
+<p:sldLayout xmlns:a="http://schemas.openxmlformats.org/drawingml/2006/main" xmlns:r="http://schemas.openxmlformats.org/officeDocument/2006/relationships" xmlns:p="http://schemas.openxmlformats.org/presentationml/2006/main" preserve="1" userDrawn="1">
+  <p:cSld name="3_ユーザー設定レイアウト">
+    <p:spTree>
+      <p:nvGrpSpPr>
+        <p:cNvPr id="1" name=""/>
+        <p:cNvGrpSpPr/>
+        <p:nvPr/>
+      </p:nvGrpSpPr>
+      <p:grpSpPr>
+        <a:xfrm>
+          <a:off x="0" y="0"/>
+          <a:ext cx="0" cy="0"/>
+          <a:chOff x="0" y="0"/>
+          <a:chExt cx="0" cy="0"/>
+        </a:xfrm>
+      </p:grpSpPr>
+      <p:graphicFrame>
+        <p:nvGraphicFramePr>
+          <p:cNvPr id="4" name="表 3">
+            <a:extLst>
+              <a:ext uri="{FF2B5EF4-FFF2-40B4-BE49-F238E27FC236}">
+                <a16:creationId xmlns:a16="http://schemas.microsoft.com/office/drawing/2014/main" id="{DD0C8013-3BEB-6A20-D00B-6B26DC112FEB}"/>
+              </a:ext>
+            </a:extLst>
+          </p:cNvPr>
+          <p:cNvGraphicFramePr>
+            <a:graphicFrameLocks noGrp="1"/>
+          </p:cNvGraphicFramePr>
+          <p:nvPr userDrawn="1">
+            <p:extLst>
+              <p:ext uri="{D42A27DB-BD31-4B8C-83A1-F6EECF244321}">
+                <p14:modId xmlns:p14="http://schemas.microsoft.com/office/powerpoint/2010/main" val="2826744638"/>
+              </p:ext>
+            </p:extLst>
+          </p:nvPr>
+        </p:nvGraphicFramePr>
+        <p:xfrm>
+          <a:off x="133350" y="128455"/>
+          <a:ext cx="11925300" cy="6601090"/>
+        </p:xfrm>
+        <a:graphic>
+          <a:graphicData uri="http://schemas.openxmlformats.org/drawingml/2006/table">
+            <a:tbl>
+              <a:tblPr firstRow="1" bandRow="1">
+                <a:effectLst>
+                  <a:outerShdw blurRad="50800" dist="38100" dir="2700000" algn="tl" rotWithShape="0">
+                    <a:prstClr val="black">
+                      <a:alpha val="40000"/>
+                    </a:prstClr>
+                  </a:outerShdw>
+                </a:effectLst>
+                <a:tableStyleId>{5C22544A-7EE6-4342-B048-85BDC9FD1C3A}</a:tableStyleId>
+              </a:tblPr>
+              <a:tblGrid>
+                <a:gridCol w="1023028">
+                  <a:extLst>
+                    <a:ext uri="{9D8B030D-6E8A-4147-A177-3AD203B41FA5}">
+                      <a16:colId xmlns:a16="http://schemas.microsoft.com/office/drawing/2014/main" val="2777621706"/>
+                    </a:ext>
+                  </a:extLst>
+                </a:gridCol>
+                <a:gridCol w="2318342">
+                  <a:extLst>
+                    <a:ext uri="{9D8B030D-6E8A-4147-A177-3AD203B41FA5}">
+                      <a16:colId xmlns:a16="http://schemas.microsoft.com/office/drawing/2014/main" val="308123450"/>
+                    </a:ext>
+                  </a:extLst>
+                </a:gridCol>
+                <a:gridCol w="8583930">
+                  <a:extLst>
+                    <a:ext uri="{9D8B030D-6E8A-4147-A177-3AD203B41FA5}">
+                      <a16:colId xmlns:a16="http://schemas.microsoft.com/office/drawing/2014/main" val="2952094520"/>
+                    </a:ext>
+                  </a:extLst>
+                </a:gridCol>
+              </a:tblGrid>
+              <a:tr h="437987">
+                <a:tc gridSpan="2">
+                  <a:txBody>
+                    <a:bodyPr/>
+                    <a:lstStyle/>
+                    <a:p>
+                      <a:r>
+                        <a:rPr kumimoji="1" lang="en-US" altLang="ja-JP" sz="1000">
+                          <a:solidFill>
+                            <a:schemeClr val="bg1"/>
+                          </a:solidFill>
+                          <a:latin typeface="Cascadia Mono" panose="020B0609020000020004" pitchFamily="49" charset="0"/>
+                          <a:ea typeface="Cascadia Mono" panose="020B0609020000020004" pitchFamily="49" charset="0"/>
+                          <a:cs typeface="Cascadia Mono" panose="020B0609020000020004" pitchFamily="49" charset="0"/>
+                        </a:rPr>
+                        <a:t>resource</a:t>
+                      </a:r>
+                      <a:endParaRPr kumimoji="1" lang="ja-JP" altLang="en-US" sz="1000">
+                        <a:solidFill>
+                          <a:schemeClr val="bg1"/>
+                        </a:solidFill>
+                        <a:latin typeface="Cascadia Mono" panose="020B0609020000020004" pitchFamily="49" charset="0"/>
+                        <a:ea typeface="BIZ UDゴシック" panose="020B0400000000000000" pitchFamily="49" charset="-128"/>
+                        <a:cs typeface="Cascadia Mono" panose="020B0609020000020004" pitchFamily="49" charset="0"/>
+                      </a:endParaRPr>
+                    </a:p>
+                  </a:txBody>
+                  <a:tcPr marL="137160" marR="137160" marT="137160" marB="137160">
+                    <a:lnL w="12700" cap="flat" cmpd="sng" algn="ctr">
+                      <a:solidFill>
+                        <a:schemeClr val="tx1"/>
+                      </a:solidFill>
+                      <a:prstDash val="solid"/>
+                      <a:round/>
+                      <a:headEnd type="none" w="med" len="med"/>
+                      <a:tailEnd type="none" w="med" len="med"/>
+                    </a:lnL>
+                    <a:lnR w="12700" cap="flat" cmpd="sng" algn="ctr">
+                      <a:solidFill>
+                        <a:schemeClr val="tx1"/>
+                      </a:solidFill>
+                      <a:prstDash val="solid"/>
+                      <a:round/>
+                      <a:headEnd type="none" w="med" len="med"/>
+                      <a:tailEnd type="none" w="med" len="med"/>
+                    </a:lnR>
+                    <a:lnT w="12700" cap="flat" cmpd="sng" algn="ctr">
+                      <a:solidFill>
+                        <a:schemeClr val="tx1"/>
+                      </a:solidFill>
+                      <a:prstDash val="solid"/>
+                      <a:round/>
+                      <a:headEnd type="none" w="med" len="med"/>
+                      <a:tailEnd type="none" w="med" len="med"/>
+                    </a:lnT>
+                    <a:lnB w="12700" cap="flat" cmpd="sng" algn="ctr">
+                      <a:solidFill>
+                        <a:schemeClr val="tx1"/>
+                      </a:solidFill>
+                      <a:prstDash val="solid"/>
+                      <a:round/>
+                      <a:headEnd type="none" w="med" len="med"/>
+                      <a:tailEnd type="none" w="med" len="med"/>
+                    </a:lnB>
+                    <a:solidFill>
+                      <a:schemeClr val="tx1">
+                        <a:lumMod val="65000"/>
+                        <a:lumOff val="35000"/>
+                      </a:schemeClr>
+                    </a:solidFill>
+                  </a:tcPr>
+                </a:tc>
+                <a:tc hMerge="1">
+                  <a:txBody>
+                    <a:bodyPr/>
+                    <a:lstStyle/>
+                    <a:p>
+                      <a:endParaRPr kumimoji="1" lang="ja-JP" altLang="en-US" sz="1000">
+                        <a:solidFill>
+                          <a:schemeClr val="bg1"/>
+                        </a:solidFill>
+                        <a:latin typeface="Cascadia Code SemiBold" panose="020B0609020000020004" pitchFamily="49" charset="0"/>
+                        <a:ea typeface="BIZ UDゴシック" panose="020B0400000000000000" pitchFamily="49" charset="-128"/>
+                        <a:cs typeface="Cascadia Code SemiBold" panose="020B0609020000020004" pitchFamily="49" charset="0"/>
+                      </a:endParaRPr>
+                    </a:p>
+                  </a:txBody>
+                  <a:tcPr marL="137160" marR="137160" marT="137160" marB="137160">
+                    <a:lnL w="12700" cap="flat" cmpd="sng" algn="ctr">
+                      <a:solidFill>
+                        <a:schemeClr val="tx1"/>
+                      </a:solidFill>
+                      <a:prstDash val="solid"/>
+                      <a:round/>
+                      <a:headEnd type="none" w="med" len="med"/>
+                      <a:tailEnd type="none" w="med" len="med"/>
+                    </a:lnL>
+                    <a:lnR w="12700" cap="flat" cmpd="sng" algn="ctr">
+                      <a:solidFill>
+                        <a:schemeClr val="tx1"/>
+                      </a:solidFill>
+                      <a:prstDash val="solid"/>
+                      <a:round/>
+                      <a:headEnd type="none" w="med" len="med"/>
+                      <a:tailEnd type="none" w="med" len="med"/>
+                    </a:lnR>
+                    <a:lnT w="12700" cap="flat" cmpd="sng" algn="ctr">
+                      <a:solidFill>
+                        <a:schemeClr val="tx1"/>
+                      </a:solidFill>
+                      <a:prstDash val="solid"/>
+                      <a:round/>
+                      <a:headEnd type="none" w="med" len="med"/>
+                      <a:tailEnd type="none" w="med" len="med"/>
+                    </a:lnT>
+                    <a:lnB w="12700" cap="flat" cmpd="sng" algn="ctr">
+                      <a:solidFill>
+                        <a:schemeClr val="tx1"/>
+                      </a:solidFill>
+                      <a:prstDash val="solid"/>
+                      <a:round/>
+                      <a:headEnd type="none" w="med" len="med"/>
+                      <a:tailEnd type="none" w="med" len="med"/>
+                    </a:lnB>
+                    <a:solidFill>
+                      <a:schemeClr val="tx1">
+                        <a:lumMod val="65000"/>
+                        <a:lumOff val="35000"/>
+                      </a:schemeClr>
+                    </a:solidFill>
+                  </a:tcPr>
+                </a:tc>
+                <a:tc>
+                  <a:txBody>
+                    <a:bodyPr/>
+                    <a:lstStyle/>
+                    <a:p>
+                      <a:r>
+                        <a:rPr kumimoji="1" lang="en-US" altLang="ja-JP" sz="1000">
+                          <a:solidFill>
+                            <a:schemeClr val="bg1"/>
+                          </a:solidFill>
+                          <a:latin typeface="Cascadia Mono" panose="020B0609020000020004" pitchFamily="49" charset="0"/>
+                          <a:ea typeface="Cascadia Mono" panose="020B0609020000020004" pitchFamily="49" charset="0"/>
+                          <a:cs typeface="Cascadia Mono" panose="020B0609020000020004" pitchFamily="49" charset="0"/>
+                        </a:rPr>
+                        <a:t>note</a:t>
+                      </a:r>
+                      <a:endParaRPr kumimoji="1" lang="ja-JP" altLang="en-US" sz="1000">
+                        <a:solidFill>
+                          <a:schemeClr val="bg1"/>
+                        </a:solidFill>
+                        <a:latin typeface="Cascadia Mono" panose="020B0609020000020004" pitchFamily="49" charset="0"/>
+                        <a:ea typeface="BIZ UDゴシック" panose="020B0400000000000000" pitchFamily="49" charset="-128"/>
+                        <a:cs typeface="Cascadia Mono" panose="020B0609020000020004" pitchFamily="49" charset="0"/>
+                      </a:endParaRPr>
+                    </a:p>
+                  </a:txBody>
+                  <a:tcPr marL="137160" marR="137160" marT="137160" marB="137160">
+                    <a:lnL w="12700" cap="flat" cmpd="sng" algn="ctr">
+                      <a:solidFill>
+                        <a:schemeClr val="tx1"/>
+                      </a:solidFill>
+                      <a:prstDash val="solid"/>
+                      <a:round/>
+                      <a:headEnd type="none" w="med" len="med"/>
+                      <a:tailEnd type="none" w="med" len="med"/>
+                    </a:lnL>
+                    <a:lnR w="12700" cap="flat" cmpd="sng" algn="ctr">
+                      <a:solidFill>
+                        <a:schemeClr val="tx1"/>
+                      </a:solidFill>
+                      <a:prstDash val="solid"/>
+                      <a:round/>
+                      <a:headEnd type="none" w="med" len="med"/>
+                      <a:tailEnd type="none" w="med" len="med"/>
+                    </a:lnR>
+                    <a:lnT w="12700" cap="flat" cmpd="sng" algn="ctr">
+                      <a:solidFill>
+                        <a:schemeClr val="tx1"/>
+                      </a:solidFill>
+                      <a:prstDash val="solid"/>
+                      <a:round/>
+                      <a:headEnd type="none" w="med" len="med"/>
+                      <a:tailEnd type="none" w="med" len="med"/>
+                    </a:lnT>
+                    <a:lnB w="12700" cap="flat" cmpd="sng" algn="ctr">
+                      <a:solidFill>
+                        <a:schemeClr val="tx1"/>
+                      </a:solidFill>
+                      <a:prstDash val="solid"/>
+                      <a:round/>
+                      <a:headEnd type="none" w="med" len="med"/>
+                      <a:tailEnd type="none" w="med" len="med"/>
+                    </a:lnB>
+                    <a:solidFill>
+                      <a:schemeClr val="tx1">
+                        <a:lumMod val="65000"/>
+                        <a:lumOff val="35000"/>
+                      </a:schemeClr>
+                    </a:solidFill>
+                  </a:tcPr>
+                </a:tc>
+                <a:extLst>
+                  <a:ext uri="{0D108BD9-81ED-4DB2-BD59-A6C34878D82A}">
+                    <a16:rowId xmlns:a16="http://schemas.microsoft.com/office/drawing/2014/main" val="526102552"/>
+                  </a:ext>
+                </a:extLst>
+              </a:tr>
+              <a:tr h="437987">
+                <a:tc gridSpan="2">
+                  <a:txBody>
+                    <a:bodyPr/>
+                    <a:lstStyle/>
+                    <a:p>
+                      <a:r>
+                        <a:rPr kumimoji="1" lang="en-US" altLang="ja-JP" sz="1000">
+                          <a:latin typeface="Cascadia Mono" panose="020B0609020000020004" pitchFamily="49" charset="0"/>
+                          <a:ea typeface="Cascadia Mono" panose="020B0609020000020004" pitchFamily="49" charset="0"/>
+                          <a:cs typeface="Cascadia Mono" panose="020B0609020000020004" pitchFamily="49" charset="0"/>
+                        </a:rPr>
+                        <a:t>.env</a:t>
+                      </a:r>
+                      <a:endParaRPr kumimoji="1" lang="ja-JP" altLang="en-US" sz="1000">
+                        <a:latin typeface="Cascadia Mono" panose="020B0609020000020004" pitchFamily="49" charset="0"/>
+                        <a:ea typeface="BIZ UDゴシック" panose="020B0400000000000000" pitchFamily="49" charset="-128"/>
+                        <a:cs typeface="Cascadia Mono" panose="020B0609020000020004" pitchFamily="49" charset="0"/>
+                      </a:endParaRPr>
+                    </a:p>
+                  </a:txBody>
+                  <a:tcPr marL="137160" marR="137160" marT="137160" marB="137160">
+                    <a:lnL w="12700" cap="flat" cmpd="sng" algn="ctr">
+                      <a:solidFill>
+                        <a:schemeClr val="tx1"/>
+                      </a:solidFill>
+                      <a:prstDash val="solid"/>
+                      <a:round/>
+                      <a:headEnd type="none" w="med" len="med"/>
+                      <a:tailEnd type="none" w="med" len="med"/>
+                    </a:lnL>
+                    <a:lnR w="12700" cap="flat" cmpd="sng" algn="ctr">
+                      <a:solidFill>
+                        <a:schemeClr val="tx1"/>
+                      </a:solidFill>
+                      <a:prstDash val="solid"/>
+                      <a:round/>
+                      <a:headEnd type="none" w="med" len="med"/>
+                      <a:tailEnd type="none" w="med" len="med"/>
+                    </a:lnR>
+                    <a:lnT w="12700" cap="flat" cmpd="sng" algn="ctr">
+                      <a:solidFill>
+                        <a:schemeClr val="tx1"/>
+                      </a:solidFill>
+                      <a:prstDash val="solid"/>
+                      <a:round/>
+                      <a:headEnd type="none" w="med" len="med"/>
+                      <a:tailEnd type="none" w="med" len="med"/>
+                    </a:lnT>
+                    <a:lnB w="12700" cap="flat" cmpd="sng" algn="ctr">
+                      <a:solidFill>
+                        <a:schemeClr val="tx1"/>
+                      </a:solidFill>
+                      <a:prstDash val="solid"/>
+                      <a:round/>
+                      <a:headEnd type="none" w="med" len="med"/>
+                      <a:tailEnd type="none" w="med" len="med"/>
+                    </a:lnB>
+                    <a:solidFill>
+                      <a:schemeClr val="bg1"/>
+                    </a:solidFill>
+                  </a:tcPr>
+                </a:tc>
+                <a:tc hMerge="1">
+                  <a:txBody>
+                    <a:bodyPr/>
+                    <a:lstStyle/>
+                    <a:p>
+                      <a:endParaRPr kumimoji="1" lang="ja-JP" altLang="en-US" sz="1000">
+                        <a:latin typeface="Cascadia Code SemiBold" panose="020B0609020000020004" pitchFamily="49" charset="0"/>
+                        <a:ea typeface="BIZ UDゴシック" panose="020B0400000000000000" pitchFamily="49" charset="-128"/>
+                        <a:cs typeface="Cascadia Code SemiBold" panose="020B0609020000020004" pitchFamily="49" charset="0"/>
+                      </a:endParaRPr>
+                    </a:p>
+                  </a:txBody>
+                  <a:tcPr marL="137160" marR="137160" marT="137160" marB="137160">
+                    <a:lnL w="12700" cap="flat" cmpd="sng" algn="ctr">
+                      <a:solidFill>
+                        <a:schemeClr val="tx1"/>
+                      </a:solidFill>
+                      <a:prstDash val="solid"/>
+                      <a:round/>
+                      <a:headEnd type="none" w="med" len="med"/>
+                      <a:tailEnd type="none" w="med" len="med"/>
+                    </a:lnL>
+                    <a:lnR w="12700" cap="flat" cmpd="sng" algn="ctr">
+                      <a:solidFill>
+                        <a:schemeClr val="tx1"/>
+                      </a:solidFill>
+                      <a:prstDash val="solid"/>
+                      <a:round/>
+                      <a:headEnd type="none" w="med" len="med"/>
+                      <a:tailEnd type="none" w="med" len="med"/>
+                    </a:lnR>
+                    <a:lnT w="12700" cap="flat" cmpd="sng" algn="ctr">
+                      <a:solidFill>
+                        <a:schemeClr val="tx1"/>
+                      </a:solidFill>
+                      <a:prstDash val="solid"/>
+                      <a:round/>
+                      <a:headEnd type="none" w="med" len="med"/>
+                      <a:tailEnd type="none" w="med" len="med"/>
+                    </a:lnT>
+                    <a:lnB w="12700" cap="flat" cmpd="sng" algn="ctr">
+                      <a:solidFill>
+                        <a:schemeClr val="tx1"/>
+                      </a:solidFill>
+                      <a:prstDash val="solid"/>
+                      <a:round/>
+                      <a:headEnd type="none" w="med" len="med"/>
+                      <a:tailEnd type="none" w="med" len="med"/>
+                    </a:lnB>
+                    <a:solidFill>
+                      <a:schemeClr val="bg1"/>
+                    </a:solidFill>
+                  </a:tcPr>
+                </a:tc>
+                <a:tc>
+                  <a:txBody>
+                    <a:bodyPr/>
+                    <a:lstStyle/>
+                    <a:p>
+                      <a:r>
+                        <a:rPr kumimoji="1" lang="en-US" altLang="ja-JP" sz="1000">
+                          <a:latin typeface="Cascadia Mono" panose="020B0609020000020004" pitchFamily="49" charset="0"/>
+                          <a:ea typeface="Cascadia Mono" panose="020B0609020000020004" pitchFamily="49" charset="0"/>
+                          <a:cs typeface="Cascadia Mono" panose="020B0609020000020004" pitchFamily="49" charset="0"/>
+                        </a:rPr>
+                        <a:t>This file containing LLM API credentials</a:t>
+                      </a:r>
+                    </a:p>
+                  </a:txBody>
+                  <a:tcPr marL="137160" marR="137160" marT="137160" marB="137160">
+                    <a:lnL w="12700" cap="flat" cmpd="sng" algn="ctr">
+                      <a:solidFill>
+                        <a:schemeClr val="tx1"/>
+                      </a:solidFill>
+                      <a:prstDash val="solid"/>
+                      <a:round/>
+                      <a:headEnd type="none" w="med" len="med"/>
+                      <a:tailEnd type="none" w="med" len="med"/>
+                    </a:lnL>
+                    <a:lnR w="12700" cap="flat" cmpd="sng" algn="ctr">
+                      <a:solidFill>
+                        <a:schemeClr val="tx1"/>
+                      </a:solidFill>
+                      <a:prstDash val="solid"/>
+                      <a:round/>
+                      <a:headEnd type="none" w="med" len="med"/>
+                      <a:tailEnd type="none" w="med" len="med"/>
+                    </a:lnR>
+                    <a:lnT w="12700" cap="flat" cmpd="sng" algn="ctr">
+                      <a:solidFill>
+                        <a:schemeClr val="tx1"/>
+                      </a:solidFill>
+                      <a:prstDash val="solid"/>
+                      <a:round/>
+                      <a:headEnd type="none" w="med" len="med"/>
+                      <a:tailEnd type="none" w="med" len="med"/>
+                    </a:lnT>
+                    <a:lnB w="12700" cap="flat" cmpd="sng" algn="ctr">
+                      <a:solidFill>
+                        <a:schemeClr val="tx1"/>
+                      </a:solidFill>
+                      <a:prstDash val="solid"/>
+                      <a:round/>
+                      <a:headEnd type="none" w="med" len="med"/>
+                      <a:tailEnd type="none" w="med" len="med"/>
+                    </a:lnB>
+                    <a:solidFill>
+                      <a:schemeClr val="bg1"/>
+                    </a:solidFill>
+                  </a:tcPr>
+                </a:tc>
+                <a:extLst>
+                  <a:ext uri="{0D108BD9-81ED-4DB2-BD59-A6C34878D82A}">
+                    <a16:rowId xmlns:a16="http://schemas.microsoft.com/office/drawing/2014/main" val="1660497218"/>
+                  </a:ext>
+                </a:extLst>
+              </a:tr>
+              <a:tr h="437987">
+                <a:tc gridSpan="2">
+                  <a:txBody>
+                    <a:bodyPr/>
+                    <a:lstStyle/>
+                    <a:p>
+                      <a:r>
+                        <a:rPr kumimoji="1" lang="en-US" altLang="ja-JP" sz="1000">
+                          <a:latin typeface="Cascadia Mono" panose="020B0609020000020004" pitchFamily="49" charset="0"/>
+                          <a:ea typeface="Cascadia Mono" panose="020B0609020000020004" pitchFamily="49" charset="0"/>
+                          <a:cs typeface="Cascadia Mono" panose="020B0609020000020004" pitchFamily="49" charset="0"/>
+                        </a:rPr>
+                        <a:t>llmj.py</a:t>
+                      </a:r>
+                      <a:endParaRPr kumimoji="1" lang="ja-JP" altLang="en-US" sz="1000">
+                        <a:latin typeface="Cascadia Mono" panose="020B0609020000020004" pitchFamily="49" charset="0"/>
+                        <a:ea typeface="BIZ UDゴシック" panose="020B0400000000000000" pitchFamily="49" charset="-128"/>
+                        <a:cs typeface="Cascadia Mono" panose="020B0609020000020004" pitchFamily="49" charset="0"/>
+                      </a:endParaRPr>
+                    </a:p>
+                  </a:txBody>
+                  <a:tcPr marL="137160" marR="137160" marT="137160" marB="137160">
+                    <a:lnL w="12700" cap="flat" cmpd="sng" algn="ctr">
+                      <a:solidFill>
+                        <a:schemeClr val="tx1"/>
+                      </a:solidFill>
+                      <a:prstDash val="solid"/>
+                      <a:round/>
+                      <a:headEnd type="none" w="med" len="med"/>
+                      <a:tailEnd type="none" w="med" len="med"/>
+                    </a:lnL>
+                    <a:lnR w="12700" cap="flat" cmpd="sng" algn="ctr">
+                      <a:solidFill>
+                        <a:schemeClr val="tx1"/>
+                      </a:solidFill>
+                      <a:prstDash val="solid"/>
+                      <a:round/>
+                      <a:headEnd type="none" w="med" len="med"/>
+                      <a:tailEnd type="none" w="med" len="med"/>
+                    </a:lnR>
+                    <a:lnT w="12700" cap="flat" cmpd="sng" algn="ctr">
+                      <a:solidFill>
+                        <a:schemeClr val="tx1"/>
+                      </a:solidFill>
+                      <a:prstDash val="solid"/>
+                      <a:round/>
+                      <a:headEnd type="none" w="med" len="med"/>
+                      <a:tailEnd type="none" w="med" len="med"/>
+                    </a:lnT>
+                    <a:lnB w="12700" cap="flat" cmpd="sng" algn="ctr">
+                      <a:solidFill>
+                        <a:schemeClr val="tx1"/>
+                      </a:solidFill>
+                      <a:prstDash val="solid"/>
+                      <a:round/>
+                      <a:headEnd type="none" w="med" len="med"/>
+                      <a:tailEnd type="none" w="med" len="med"/>
+                    </a:lnB>
+                    <a:solidFill>
+                      <a:schemeClr val="bg1"/>
+                    </a:solidFill>
+                  </a:tcPr>
+                </a:tc>
+                <a:tc hMerge="1">
+                  <a:txBody>
+                    <a:bodyPr/>
+                    <a:lstStyle/>
+                    <a:p>
+                      <a:endParaRPr kumimoji="1" lang="ja-JP" altLang="en-US" sz="1000">
+                        <a:latin typeface="Cascadia Code SemiBold" panose="020B0609020000020004" pitchFamily="49" charset="0"/>
+                        <a:ea typeface="BIZ UDゴシック" panose="020B0400000000000000" pitchFamily="49" charset="-128"/>
+                        <a:cs typeface="Cascadia Code SemiBold" panose="020B0609020000020004" pitchFamily="49" charset="0"/>
+                      </a:endParaRPr>
+                    </a:p>
+                  </a:txBody>
+                  <a:tcPr marL="137160" marR="137160" marT="137160" marB="137160">
+                    <a:lnL w="12700" cap="flat" cmpd="sng" algn="ctr">
+                      <a:solidFill>
+                        <a:schemeClr val="tx1"/>
+                      </a:solidFill>
+                      <a:prstDash val="solid"/>
+                      <a:round/>
+                      <a:headEnd type="none" w="med" len="med"/>
+                      <a:tailEnd type="none" w="med" len="med"/>
+                    </a:lnL>
+                    <a:lnR w="12700" cap="flat" cmpd="sng" algn="ctr">
+                      <a:solidFill>
+                        <a:schemeClr val="tx1"/>
+                      </a:solidFill>
+                      <a:prstDash val="solid"/>
+                      <a:round/>
+                      <a:headEnd type="none" w="med" len="med"/>
+                      <a:tailEnd type="none" w="med" len="med"/>
+                    </a:lnR>
+                    <a:lnT w="12700" cap="flat" cmpd="sng" algn="ctr">
+                      <a:solidFill>
+                        <a:schemeClr val="tx1"/>
+                      </a:solidFill>
+                      <a:prstDash val="solid"/>
+                      <a:round/>
+                      <a:headEnd type="none" w="med" len="med"/>
+                      <a:tailEnd type="none" w="med" len="med"/>
+                    </a:lnT>
+                    <a:lnB w="12700" cap="flat" cmpd="sng" algn="ctr">
+                      <a:solidFill>
+                        <a:schemeClr val="tx1"/>
+                      </a:solidFill>
+                      <a:prstDash val="solid"/>
+                      <a:round/>
+                      <a:headEnd type="none" w="med" len="med"/>
+                      <a:tailEnd type="none" w="med" len="med"/>
+                    </a:lnB>
+                    <a:solidFill>
+                      <a:schemeClr val="bg1"/>
+                    </a:solidFill>
+                  </a:tcPr>
+                </a:tc>
+                <a:tc>
+                  <a:txBody>
+                    <a:bodyPr/>
+                    <a:lstStyle/>
+                    <a:p>
+                      <a:r>
+                        <a:rPr kumimoji="1" lang="en-US" altLang="ja-JP" sz="1000">
+                          <a:latin typeface="Cascadia Mono" panose="020B0609020000020004" pitchFamily="49" charset="0"/>
+                          <a:ea typeface="Cascadia Mono" panose="020B0609020000020004" pitchFamily="49" charset="0"/>
+                          <a:cs typeface="Cascadia Mono" panose="020B0609020000020004" pitchFamily="49" charset="0"/>
+                        </a:rPr>
+                        <a:t>Common definitions and common processing</a:t>
+                      </a:r>
+                    </a:p>
+                  </a:txBody>
+                  <a:tcPr marL="137160" marR="137160" marT="137160" marB="137160">
+                    <a:lnL w="12700" cap="flat" cmpd="sng" algn="ctr">
+                      <a:solidFill>
+                        <a:schemeClr val="tx1"/>
+                      </a:solidFill>
+                      <a:prstDash val="solid"/>
+                      <a:round/>
+                      <a:headEnd type="none" w="med" len="med"/>
+                      <a:tailEnd type="none" w="med" len="med"/>
+                    </a:lnL>
+                    <a:lnR w="12700" cap="flat" cmpd="sng" algn="ctr">
+                      <a:solidFill>
+                        <a:schemeClr val="tx1"/>
+                      </a:solidFill>
+                      <a:prstDash val="solid"/>
+                      <a:round/>
+                      <a:headEnd type="none" w="med" len="med"/>
+                      <a:tailEnd type="none" w="med" len="med"/>
+                    </a:lnR>
+                    <a:lnT w="12700" cap="flat" cmpd="sng" algn="ctr">
+                      <a:solidFill>
+                        <a:schemeClr val="tx1"/>
+                      </a:solidFill>
+                      <a:prstDash val="solid"/>
+                      <a:round/>
+                      <a:headEnd type="none" w="med" len="med"/>
+                      <a:tailEnd type="none" w="med" len="med"/>
+                    </a:lnT>
+                    <a:lnB w="12700" cap="flat" cmpd="sng" algn="ctr">
+                      <a:solidFill>
+                        <a:schemeClr val="tx1"/>
+                      </a:solidFill>
+                      <a:prstDash val="solid"/>
+                      <a:round/>
+                      <a:headEnd type="none" w="med" len="med"/>
+                      <a:tailEnd type="none" w="med" len="med"/>
+                    </a:lnB>
+                    <a:solidFill>
+                      <a:schemeClr val="bg1"/>
+                    </a:solidFill>
+                  </a:tcPr>
+                </a:tc>
+                <a:extLst>
+                  <a:ext uri="{0D108BD9-81ED-4DB2-BD59-A6C34878D82A}">
+                    <a16:rowId xmlns:a16="http://schemas.microsoft.com/office/drawing/2014/main" val="1288496352"/>
+                  </a:ext>
+                </a:extLst>
+              </a:tr>
+              <a:tr h="437987">
+                <a:tc gridSpan="2">
+                  <a:txBody>
+                    <a:bodyPr/>
+                    <a:lstStyle/>
+                    <a:p>
+                      <a:pPr marL="0" marR="0" lvl="0" indent="0" algn="l" defTabSz="914400" rtl="0" eaLnBrk="1" fontAlgn="auto" latinLnBrk="0" hangingPunct="1">
+                        <a:lnSpc>
+                          <a:spcPct val="100000"/>
+                        </a:lnSpc>
+                        <a:spcBef>
+                          <a:spcPts val="0"/>
+                        </a:spcBef>
+                        <a:spcAft>
+                          <a:spcPts val="0"/>
+                        </a:spcAft>
+                        <a:buClrTx/>
+                        <a:buSzTx/>
+                        <a:buFontTx/>
+                        <a:buNone/>
+                        <a:tabLst/>
+                        <a:defRPr/>
+                      </a:pPr>
+                      <a:r>
+                        <a:rPr kumimoji="1" lang="en-US" altLang="ja-JP" sz="1000">
+                          <a:latin typeface="Cascadia Mono" panose="020B0609020000020004" pitchFamily="49" charset="0"/>
+                          <a:ea typeface="Cascadia Mono" panose="020B0609020000020004" pitchFamily="49" charset="0"/>
+                          <a:cs typeface="Cascadia Mono" panose="020B0609020000020004" pitchFamily="49" charset="0"/>
+                        </a:rPr>
+                        <a:t>llmj-generate.py</a:t>
+                      </a:r>
+                      <a:endParaRPr kumimoji="1" lang="ja-JP" altLang="en-US" sz="1000">
+                        <a:latin typeface="Cascadia Mono" panose="020B0609020000020004" pitchFamily="49" charset="0"/>
+                        <a:ea typeface="BIZ UDゴシック" panose="020B0400000000000000" pitchFamily="49" charset="-128"/>
+                        <a:cs typeface="Cascadia Mono" panose="020B0609020000020004" pitchFamily="49" charset="0"/>
+                      </a:endParaRPr>
+                    </a:p>
+                  </a:txBody>
+                  <a:tcPr marL="137160" marR="137160" marT="137160" marB="137160">
+                    <a:lnL w="12700" cap="flat" cmpd="sng" algn="ctr">
+                      <a:solidFill>
+                        <a:schemeClr val="tx1"/>
+                      </a:solidFill>
+                      <a:prstDash val="solid"/>
+                      <a:round/>
+                      <a:headEnd type="none" w="med" len="med"/>
+                      <a:tailEnd type="none" w="med" len="med"/>
+                    </a:lnL>
+                    <a:lnR w="12700" cap="flat" cmpd="sng" algn="ctr">
+                      <a:solidFill>
+                        <a:schemeClr val="tx1"/>
+                      </a:solidFill>
+                      <a:prstDash val="solid"/>
+                      <a:round/>
+                      <a:headEnd type="none" w="med" len="med"/>
+                      <a:tailEnd type="none" w="med" len="med"/>
+                    </a:lnR>
+                    <a:lnT w="12700" cap="flat" cmpd="sng" algn="ctr">
+                      <a:solidFill>
+                        <a:schemeClr val="tx1"/>
+                      </a:solidFill>
+                      <a:prstDash val="solid"/>
+                      <a:round/>
+                      <a:headEnd type="none" w="med" len="med"/>
+                      <a:tailEnd type="none" w="med" len="med"/>
+                    </a:lnT>
+                    <a:lnB w="12700" cap="flat" cmpd="sng" algn="ctr">
+                      <a:solidFill>
+                        <a:schemeClr val="tx1"/>
+                      </a:solidFill>
+                      <a:prstDash val="solid"/>
+                      <a:round/>
+                      <a:headEnd type="none" w="med" len="med"/>
+                      <a:tailEnd type="none" w="med" len="med"/>
+                    </a:lnB>
+                    <a:solidFill>
+                      <a:schemeClr val="bg1"/>
+                    </a:solidFill>
+                  </a:tcPr>
+                </a:tc>
+                <a:tc hMerge="1">
+                  <a:txBody>
+                    <a:bodyPr/>
+                    <a:lstStyle/>
+                    <a:p>
+                      <a:pPr marL="0" marR="0" lvl="0" indent="0" algn="l" defTabSz="914400" rtl="0" eaLnBrk="1" fontAlgn="auto" latinLnBrk="0" hangingPunct="1">
+                        <a:lnSpc>
+                          <a:spcPct val="100000"/>
+                        </a:lnSpc>
+                        <a:spcBef>
+                          <a:spcPts val="0"/>
+                        </a:spcBef>
+                        <a:spcAft>
+                          <a:spcPts val="0"/>
+                        </a:spcAft>
+                        <a:buClrTx/>
+                        <a:buSzTx/>
+                        <a:buFontTx/>
+                        <a:buNone/>
+                        <a:tabLst/>
+                        <a:defRPr/>
+                      </a:pPr>
+                      <a:endParaRPr kumimoji="1" lang="ja-JP" altLang="en-US" sz="1000">
+                        <a:latin typeface="Cascadia Code SemiBold" panose="020B0609020000020004" pitchFamily="49" charset="0"/>
+                        <a:ea typeface="BIZ UDゴシック" panose="020B0400000000000000" pitchFamily="49" charset="-128"/>
+                        <a:cs typeface="Cascadia Code SemiBold" panose="020B0609020000020004" pitchFamily="49" charset="0"/>
+                      </a:endParaRPr>
+                    </a:p>
+                  </a:txBody>
+                  <a:tcPr marL="137160" marR="137160" marT="137160" marB="137160">
+                    <a:lnL w="12700" cap="flat" cmpd="sng" algn="ctr">
+                      <a:solidFill>
+                        <a:schemeClr val="tx1"/>
+                      </a:solidFill>
+                      <a:prstDash val="solid"/>
+                      <a:round/>
+                      <a:headEnd type="none" w="med" len="med"/>
+                      <a:tailEnd type="none" w="med" len="med"/>
+                    </a:lnL>
+                    <a:lnR w="12700" cap="flat" cmpd="sng" algn="ctr">
+                      <a:solidFill>
+                        <a:schemeClr val="tx1"/>
+                      </a:solidFill>
+                      <a:prstDash val="solid"/>
+                      <a:round/>
+                      <a:headEnd type="none" w="med" len="med"/>
+                      <a:tailEnd type="none" w="med" len="med"/>
+                    </a:lnR>
+                    <a:lnT w="12700" cap="flat" cmpd="sng" algn="ctr">
+                      <a:solidFill>
+                        <a:schemeClr val="tx1"/>
+                      </a:solidFill>
+                      <a:prstDash val="solid"/>
+                      <a:round/>
+                      <a:headEnd type="none" w="med" len="med"/>
+                      <a:tailEnd type="none" w="med" len="med"/>
+                    </a:lnT>
+                    <a:lnB w="12700" cap="flat" cmpd="sng" algn="ctr">
+                      <a:solidFill>
+                        <a:schemeClr val="tx1"/>
+                      </a:solidFill>
+                      <a:prstDash val="solid"/>
+                      <a:round/>
+                      <a:headEnd type="none" w="med" len="med"/>
+                      <a:tailEnd type="none" w="med" len="med"/>
+                    </a:lnB>
+                    <a:solidFill>
+                      <a:schemeClr val="bg1"/>
+                    </a:solidFill>
+                  </a:tcPr>
+                </a:tc>
+                <a:tc>
+                  <a:txBody>
+                    <a:bodyPr/>
+                    <a:lstStyle/>
+                    <a:p>
+                      <a:pPr marL="0" marR="0" lvl="0" indent="0" algn="l" defTabSz="914400" rtl="0" eaLnBrk="1" fontAlgn="auto" latinLnBrk="0" hangingPunct="1">
+                        <a:lnSpc>
+                          <a:spcPct val="100000"/>
+                        </a:lnSpc>
+                        <a:spcBef>
+                          <a:spcPts val="0"/>
+                        </a:spcBef>
+                        <a:spcAft>
+                          <a:spcPts val="0"/>
+                        </a:spcAft>
+                        <a:buClrTx/>
+                        <a:buSzTx/>
+                        <a:buFontTx/>
+                        <a:buNone/>
+                        <a:tabLst/>
+                        <a:defRPr/>
+                      </a:pPr>
+                      <a:r>
+                        <a:rPr kumimoji="1" lang="en-US" altLang="ja-JP" sz="1000">
+                          <a:latin typeface="Cascadia Mono" panose="020B0609020000020004" pitchFamily="49" charset="0"/>
+                          <a:ea typeface="Cascadia Mono" panose="020B0609020000020004" pitchFamily="49" charset="0"/>
+                          <a:cs typeface="Cascadia Mono" panose="020B0609020000020004" pitchFamily="49" charset="0"/>
+                        </a:rPr>
+                        <a:t>This SCRIPT uses </a:t>
+                      </a:r>
+                      <a:r>
+                        <a:rPr kumimoji="1" lang="en-US" altLang="ja-JP" sz="1000" b="1" i="1">
+                          <a:solidFill>
+                            <a:srgbClr val="FF0000"/>
+                          </a:solidFill>
+                          <a:latin typeface="Cascadia Mono" panose="020B0609020000020004" pitchFamily="49" charset="0"/>
+                          <a:ea typeface="Cascadia Mono" panose="020B0609020000020004" pitchFamily="49" charset="0"/>
+                          <a:cs typeface="Cascadia Mono" panose="020B0609020000020004" pitchFamily="49" charset="0"/>
+                        </a:rPr>
+                        <a:t>work/*.txt</a:t>
+                      </a:r>
+                      <a:r>
+                        <a:rPr kumimoji="1" lang="en-US" altLang="ja-JP" sz="1000">
+                          <a:latin typeface="Cascadia Mono" panose="020B0609020000020004" pitchFamily="49" charset="0"/>
+                          <a:ea typeface="Cascadia Mono" panose="020B0609020000020004" pitchFamily="49" charset="0"/>
+                          <a:cs typeface="Cascadia Mono" panose="020B0609020000020004" pitchFamily="49" charset="0"/>
+                        </a:rPr>
+                        <a:t> to transform </a:t>
+                      </a:r>
+                      <a:r>
+                        <a:rPr kumimoji="1" lang="en-US" altLang="ja-JP" sz="1000" b="1" i="1">
+                          <a:solidFill>
+                            <a:srgbClr val="FF0000"/>
+                          </a:solidFill>
+                          <a:latin typeface="Cascadia Mono" panose="020B0609020000020004" pitchFamily="49" charset="0"/>
+                          <a:ea typeface="Cascadia Mono" panose="020B0609020000020004" pitchFamily="49" charset="0"/>
+                          <a:cs typeface="Cascadia Mono" panose="020B0609020000020004" pitchFamily="49" charset="0"/>
+                        </a:rPr>
+                        <a:t>source/*.txt</a:t>
+                      </a:r>
+                      <a:r>
+                        <a:rPr kumimoji="1" lang="en-US" altLang="ja-JP" sz="1000">
+                          <a:latin typeface="Cascadia Mono" panose="020B0609020000020004" pitchFamily="49" charset="0"/>
+                          <a:ea typeface="Cascadia Mono" panose="020B0609020000020004" pitchFamily="49" charset="0"/>
+                          <a:cs typeface="Cascadia Mono" panose="020B0609020000020004" pitchFamily="49" charset="0"/>
+                        </a:rPr>
+                        <a:t> and generates </a:t>
+                      </a:r>
+                      <a:r>
+                        <a:rPr kumimoji="1" lang="en-US" altLang="ja-JP" sz="1000" b="1" i="1">
+                          <a:solidFill>
+                            <a:srgbClr val="FF0000"/>
+                          </a:solidFill>
+                          <a:latin typeface="Cascadia Mono" panose="020B0609020000020004" pitchFamily="49" charset="0"/>
+                          <a:ea typeface="Cascadia Mono" panose="020B0609020000020004" pitchFamily="49" charset="0"/>
+                          <a:cs typeface="Cascadia Mono" panose="020B0609020000020004" pitchFamily="49" charset="0"/>
+                        </a:rPr>
+                        <a:t>work/*.work.xlsx</a:t>
+                      </a:r>
+                      <a:r>
+                        <a:rPr kumimoji="1" lang="en-US" altLang="ja-JP" sz="1000">
+                          <a:latin typeface="Cascadia Mono" panose="020B0609020000020004" pitchFamily="49" charset="0"/>
+                          <a:ea typeface="Cascadia Mono" panose="020B0609020000020004" pitchFamily="49" charset="0"/>
+                          <a:cs typeface="Cascadia Mono" panose="020B0609020000020004" pitchFamily="49" charset="0"/>
+                        </a:rPr>
+                        <a:t>.</a:t>
+                      </a:r>
+                    </a:p>
+                  </a:txBody>
+                  <a:tcPr marL="137160" marR="137160" marT="137160" marB="137160">
+                    <a:lnL w="12700" cap="flat" cmpd="sng" algn="ctr">
+                      <a:solidFill>
+                        <a:schemeClr val="tx1"/>
+                      </a:solidFill>
+                      <a:prstDash val="solid"/>
+                      <a:round/>
+                      <a:headEnd type="none" w="med" len="med"/>
+                      <a:tailEnd type="none" w="med" len="med"/>
+                    </a:lnL>
+                    <a:lnR w="12700" cap="flat" cmpd="sng" algn="ctr">
+                      <a:solidFill>
+                        <a:schemeClr val="tx1"/>
+                      </a:solidFill>
+                      <a:prstDash val="solid"/>
+                      <a:round/>
+                      <a:headEnd type="none" w="med" len="med"/>
+                      <a:tailEnd type="none" w="med" len="med"/>
+                    </a:lnR>
+                    <a:lnT w="12700" cap="flat" cmpd="sng" algn="ctr">
+                      <a:solidFill>
+                        <a:schemeClr val="tx1"/>
+                      </a:solidFill>
+                      <a:prstDash val="solid"/>
+                      <a:round/>
+                      <a:headEnd type="none" w="med" len="med"/>
+                      <a:tailEnd type="none" w="med" len="med"/>
+                    </a:lnT>
+                    <a:lnB w="12700" cap="flat" cmpd="sng" algn="ctr">
+                      <a:solidFill>
+                        <a:schemeClr val="tx1"/>
+                      </a:solidFill>
+                      <a:prstDash val="solid"/>
+                      <a:round/>
+                      <a:headEnd type="none" w="med" len="med"/>
+                      <a:tailEnd type="none" w="med" len="med"/>
+                    </a:lnB>
+                    <a:solidFill>
+                      <a:schemeClr val="bg1"/>
+                    </a:solidFill>
+                  </a:tcPr>
+                </a:tc>
+                <a:extLst>
+                  <a:ext uri="{0D108BD9-81ED-4DB2-BD59-A6C34878D82A}">
+                    <a16:rowId xmlns:a16="http://schemas.microsoft.com/office/drawing/2014/main" val="2978836238"/>
+                  </a:ext>
+                </a:extLst>
+              </a:tr>
+              <a:tr h="594411">
+                <a:tc gridSpan="2">
+                  <a:txBody>
+                    <a:bodyPr/>
+                    <a:lstStyle/>
+                    <a:p>
+                      <a:r>
+                        <a:rPr kumimoji="1" lang="en-US" altLang="ja-JP" sz="1000">
+                          <a:latin typeface="Cascadia Mono" panose="020B0609020000020004" pitchFamily="49" charset="0"/>
+                          <a:ea typeface="Cascadia Mono" panose="020B0609020000020004" pitchFamily="49" charset="0"/>
+                          <a:cs typeface="Cascadia Mono" panose="020B0609020000020004" pitchFamily="49" charset="0"/>
+                        </a:rPr>
+                        <a:t>llmj-judge.py</a:t>
+                      </a:r>
+                      <a:endParaRPr kumimoji="1" lang="ja-JP" altLang="en-US" sz="1000">
+                        <a:latin typeface="Cascadia Mono" panose="020B0609020000020004" pitchFamily="49" charset="0"/>
+                        <a:ea typeface="BIZ UDゴシック" panose="020B0400000000000000" pitchFamily="49" charset="-128"/>
+                        <a:cs typeface="Cascadia Mono" panose="020B0609020000020004" pitchFamily="49" charset="0"/>
+                      </a:endParaRPr>
+                    </a:p>
+                  </a:txBody>
+                  <a:tcPr marL="137160" marR="137160" marT="137160" marB="137160">
+                    <a:lnL w="12700" cap="flat" cmpd="sng" algn="ctr">
+                      <a:solidFill>
+                        <a:schemeClr val="tx1"/>
+                      </a:solidFill>
+                      <a:prstDash val="solid"/>
+                      <a:round/>
+                      <a:headEnd type="none" w="med" len="med"/>
+                      <a:tailEnd type="none" w="med" len="med"/>
+                    </a:lnL>
+                    <a:lnR w="12700" cap="flat" cmpd="sng" algn="ctr">
+                      <a:solidFill>
+                        <a:schemeClr val="tx1"/>
+                      </a:solidFill>
+                      <a:prstDash val="solid"/>
+                      <a:round/>
+                      <a:headEnd type="none" w="med" len="med"/>
+                      <a:tailEnd type="none" w="med" len="med"/>
+                    </a:lnR>
+                    <a:lnT w="12700" cap="flat" cmpd="sng" algn="ctr">
+                      <a:solidFill>
+                        <a:schemeClr val="tx1"/>
+                      </a:solidFill>
+                      <a:prstDash val="solid"/>
+                      <a:round/>
+                      <a:headEnd type="none" w="med" len="med"/>
+                      <a:tailEnd type="none" w="med" len="med"/>
+                    </a:lnT>
+                    <a:lnB w="12700" cap="flat" cmpd="sng" algn="ctr">
+                      <a:solidFill>
+                        <a:schemeClr val="tx1"/>
+                      </a:solidFill>
+                      <a:prstDash val="solid"/>
+                      <a:round/>
+                      <a:headEnd type="none" w="med" len="med"/>
+                      <a:tailEnd type="none" w="med" len="med"/>
+                    </a:lnB>
+                    <a:solidFill>
+                      <a:schemeClr val="bg1"/>
+                    </a:solidFill>
+                  </a:tcPr>
+                </a:tc>
+                <a:tc hMerge="1">
+                  <a:txBody>
+                    <a:bodyPr/>
+                    <a:lstStyle/>
+                    <a:p>
+                      <a:endParaRPr kumimoji="1" lang="ja-JP" altLang="en-US" sz="1000">
+                        <a:latin typeface="Cascadia Code SemiBold" panose="020B0609020000020004" pitchFamily="49" charset="0"/>
+                        <a:ea typeface="BIZ UDゴシック" panose="020B0400000000000000" pitchFamily="49" charset="-128"/>
+                        <a:cs typeface="Cascadia Code SemiBold" panose="020B0609020000020004" pitchFamily="49" charset="0"/>
+                      </a:endParaRPr>
+                    </a:p>
+                  </a:txBody>
+                  <a:tcPr marL="137160" marR="137160" marT="137160" marB="137160">
+                    <a:lnL w="12700" cap="flat" cmpd="sng" algn="ctr">
+                      <a:solidFill>
+                        <a:schemeClr val="tx1"/>
+                      </a:solidFill>
+                      <a:prstDash val="solid"/>
+                      <a:round/>
+                      <a:headEnd type="none" w="med" len="med"/>
+                      <a:tailEnd type="none" w="med" len="med"/>
+                    </a:lnL>
+                    <a:lnR w="12700" cap="flat" cmpd="sng" algn="ctr">
+                      <a:solidFill>
+                        <a:schemeClr val="tx1"/>
+                      </a:solidFill>
+                      <a:prstDash val="solid"/>
+                      <a:round/>
+                      <a:headEnd type="none" w="med" len="med"/>
+                      <a:tailEnd type="none" w="med" len="med"/>
+                    </a:lnR>
+                    <a:lnT w="12700" cap="flat" cmpd="sng" algn="ctr">
+                      <a:solidFill>
+                        <a:schemeClr val="tx1"/>
+                      </a:solidFill>
+                      <a:prstDash val="solid"/>
+                      <a:round/>
+                      <a:headEnd type="none" w="med" len="med"/>
+                      <a:tailEnd type="none" w="med" len="med"/>
+                    </a:lnT>
+                    <a:lnB w="12700" cap="flat" cmpd="sng" algn="ctr">
+                      <a:solidFill>
+                        <a:schemeClr val="tx1"/>
+                      </a:solidFill>
+                      <a:prstDash val="solid"/>
+                      <a:round/>
+                      <a:headEnd type="none" w="med" len="med"/>
+                      <a:tailEnd type="none" w="med" len="med"/>
+                    </a:lnB>
+                    <a:solidFill>
+                      <a:schemeClr val="bg1"/>
+                    </a:solidFill>
+                  </a:tcPr>
+                </a:tc>
+                <a:tc>
+                  <a:txBody>
+                    <a:bodyPr/>
+                    <a:lstStyle/>
+                    <a:p>
+                      <a:r>
+                        <a:rPr kumimoji="1" lang="en-US" altLang="ja-JP" sz="1000">
+                          <a:latin typeface="Cascadia Mono" panose="020B0609020000020004" pitchFamily="49" charset="0"/>
+                          <a:ea typeface="Cascadia Mono" panose="020B0609020000020004" pitchFamily="49" charset="0"/>
+                          <a:cs typeface="Cascadia Mono" panose="020B0609020000020004" pitchFamily="49" charset="0"/>
+                        </a:rPr>
+                        <a:t>This SCRIPT evaluates the contents of </a:t>
+                      </a:r>
+                      <a:r>
+                        <a:rPr kumimoji="1" lang="en-US" altLang="ja-JP" sz="1000" b="1" i="1">
+                          <a:solidFill>
+                            <a:srgbClr val="FF0000"/>
+                          </a:solidFill>
+                          <a:latin typeface="Cascadia Mono" panose="020B0609020000020004" pitchFamily="49" charset="0"/>
+                          <a:ea typeface="Cascadia Mono" panose="020B0609020000020004" pitchFamily="49" charset="0"/>
+                          <a:cs typeface="Cascadia Mono" panose="020B0609020000020004" pitchFamily="49" charset="0"/>
+                        </a:rPr>
+                        <a:t>work/*.work.xlsx</a:t>
+                      </a:r>
+                      <a:r>
+                        <a:rPr kumimoji="1" lang="en-US" altLang="ja-JP" sz="1000">
+                          <a:latin typeface="Cascadia Mono" panose="020B0609020000020004" pitchFamily="49" charset="0"/>
+                          <a:ea typeface="Cascadia Mono" panose="020B0609020000020004" pitchFamily="49" charset="0"/>
+                          <a:cs typeface="Cascadia Mono" panose="020B0609020000020004" pitchFamily="49" charset="0"/>
+                        </a:rPr>
+                        <a:t> against </a:t>
+                      </a:r>
+                      <a:r>
+                        <a:rPr kumimoji="1" lang="en-US" altLang="ja-JP" sz="1000" b="1" i="1">
+                          <a:solidFill>
+                            <a:srgbClr val="FF0000"/>
+                          </a:solidFill>
+                          <a:latin typeface="Cascadia Mono" panose="020B0609020000020004" pitchFamily="49" charset="0"/>
+                          <a:ea typeface="Cascadia Mono" panose="020B0609020000020004" pitchFamily="49" charset="0"/>
+                          <a:cs typeface="Cascadia Mono" panose="020B0609020000020004" pitchFamily="49" charset="0"/>
+                        </a:rPr>
+                        <a:t>rubric/*.criteria.txt</a:t>
+                      </a:r>
+                      <a:r>
+                        <a:rPr kumimoji="1" lang="en-US" altLang="ja-JP" sz="1000">
+                          <a:latin typeface="Cascadia Mono" panose="020B0609020000020004" pitchFamily="49" charset="0"/>
+                          <a:ea typeface="Cascadia Mono" panose="020B0609020000020004" pitchFamily="49" charset="0"/>
+                          <a:cs typeface="Cascadia Mono" panose="020B0609020000020004" pitchFamily="49" charset="0"/>
+                        </a:rPr>
+                        <a:t>, writes the results to </a:t>
+                      </a:r>
+                      <a:r>
+                        <a:rPr kumimoji="1" lang="en-US" altLang="ja-JP" sz="1000" b="1" i="1">
+                          <a:solidFill>
+                            <a:srgbClr val="FF0000"/>
+                          </a:solidFill>
+                          <a:latin typeface="Cascadia Mono" panose="020B0609020000020004" pitchFamily="49" charset="0"/>
+                          <a:ea typeface="Cascadia Mono" panose="020B0609020000020004" pitchFamily="49" charset="0"/>
+                          <a:cs typeface="Cascadia Mono" panose="020B0609020000020004" pitchFamily="49" charset="0"/>
+                        </a:rPr>
+                        <a:t>work/*.work.xlsx</a:t>
+                      </a:r>
+                      <a:r>
+                        <a:rPr kumimoji="1" lang="en-US" altLang="ja-JP" sz="1000">
+                          <a:latin typeface="Cascadia Mono" panose="020B0609020000020004" pitchFamily="49" charset="0"/>
+                          <a:ea typeface="Cascadia Mono" panose="020B0609020000020004" pitchFamily="49" charset="0"/>
+                          <a:cs typeface="Cascadia Mono" panose="020B0609020000020004" pitchFamily="49" charset="0"/>
+                        </a:rPr>
+                        <a:t>, and generates </a:t>
+                      </a:r>
+                      <a:r>
+                        <a:rPr kumimoji="1" lang="en-US" altLang="ja-JP" sz="1000" b="1" i="1">
+                          <a:solidFill>
+                            <a:srgbClr val="FF0000"/>
+                          </a:solidFill>
+                          <a:latin typeface="Cascadia Mono" panose="020B0609020000020004" pitchFamily="49" charset="0"/>
+                          <a:ea typeface="Cascadia Mono" panose="020B0609020000020004" pitchFamily="49" charset="0"/>
+                          <a:cs typeface="Cascadia Mono" panose="020B0609020000020004" pitchFamily="49" charset="0"/>
+                        </a:rPr>
+                        <a:t>work/report.html</a:t>
+                      </a:r>
+                      <a:r>
+                        <a:rPr kumimoji="1" lang="en-US" altLang="ja-JP" sz="1000">
+                          <a:latin typeface="Cascadia Mono" panose="020B0609020000020004" pitchFamily="49" charset="0"/>
+                          <a:ea typeface="Cascadia Mono" panose="020B0609020000020004" pitchFamily="49" charset="0"/>
+                          <a:cs typeface="Cascadia Mono" panose="020B0609020000020004" pitchFamily="49" charset="0"/>
+                        </a:rPr>
+                        <a:t> based on the evaluation results.</a:t>
+                      </a:r>
+                    </a:p>
+                  </a:txBody>
+                  <a:tcPr marL="137160" marR="137160" marT="137160" marB="137160">
+                    <a:lnL w="12700" cap="flat" cmpd="sng" algn="ctr">
+                      <a:solidFill>
+                        <a:schemeClr val="tx1"/>
+                      </a:solidFill>
+                      <a:prstDash val="solid"/>
+                      <a:round/>
+                      <a:headEnd type="none" w="med" len="med"/>
+                      <a:tailEnd type="none" w="med" len="med"/>
+                    </a:lnL>
+                    <a:lnR w="12700" cap="flat" cmpd="sng" algn="ctr">
+                      <a:solidFill>
+                        <a:schemeClr val="tx1"/>
+                      </a:solidFill>
+                      <a:prstDash val="solid"/>
+                      <a:round/>
+                      <a:headEnd type="none" w="med" len="med"/>
+                      <a:tailEnd type="none" w="med" len="med"/>
+                    </a:lnR>
+                    <a:lnT w="12700" cap="flat" cmpd="sng" algn="ctr">
+                      <a:solidFill>
+                        <a:schemeClr val="tx1"/>
+                      </a:solidFill>
+                      <a:prstDash val="solid"/>
+                      <a:round/>
+                      <a:headEnd type="none" w="med" len="med"/>
+                      <a:tailEnd type="none" w="med" len="med"/>
+                    </a:lnT>
+                    <a:lnB w="12700" cap="flat" cmpd="sng" algn="ctr">
+                      <a:solidFill>
+                        <a:schemeClr val="tx1"/>
+                      </a:solidFill>
+                      <a:prstDash val="solid"/>
+                      <a:round/>
+                      <a:headEnd type="none" w="med" len="med"/>
+                      <a:tailEnd type="none" w="med" len="med"/>
+                    </a:lnB>
+                    <a:solidFill>
+                      <a:schemeClr val="bg1"/>
+                    </a:solidFill>
+                  </a:tcPr>
+                </a:tc>
+                <a:extLst>
+                  <a:ext uri="{0D108BD9-81ED-4DB2-BD59-A6C34878D82A}">
+                    <a16:rowId xmlns:a16="http://schemas.microsoft.com/office/drawing/2014/main" val="4198762670"/>
+                  </a:ext>
+                </a:extLst>
+              </a:tr>
+              <a:tr h="437987">
+                <a:tc rowSpan="2">
+                  <a:txBody>
+                    <a:bodyPr/>
+                    <a:lstStyle/>
+                    <a:p>
+                      <a:r>
+                        <a:rPr kumimoji="1" lang="en-US" altLang="ja-JP" sz="1000">
+                          <a:latin typeface="Cascadia Mono" panose="020B0609020000020004" pitchFamily="49" charset="0"/>
+                          <a:ea typeface="Cascadia Mono" panose="020B0609020000020004" pitchFamily="49" charset="0"/>
+                          <a:cs typeface="Cascadia Mono" panose="020B0609020000020004" pitchFamily="49" charset="0"/>
+                        </a:rPr>
+                        <a:t>rubric/</a:t>
+                      </a:r>
+                      <a:endParaRPr kumimoji="1" lang="ja-JP" altLang="en-US" sz="1000">
+                        <a:latin typeface="Cascadia Mono" panose="020B0609020000020004" pitchFamily="49" charset="0"/>
+                        <a:ea typeface="BIZ UDゴシック" panose="020B0400000000000000" pitchFamily="49" charset="-128"/>
+                        <a:cs typeface="Cascadia Mono" panose="020B0609020000020004" pitchFamily="49" charset="0"/>
+                      </a:endParaRPr>
+                    </a:p>
+                  </a:txBody>
+                  <a:tcPr marL="137160" marR="137160" marT="137160" marB="137160">
+                    <a:lnL w="12700" cap="flat" cmpd="sng" algn="ctr">
+                      <a:solidFill>
+                        <a:schemeClr val="tx1"/>
+                      </a:solidFill>
+                      <a:prstDash val="solid"/>
+                      <a:round/>
+                      <a:headEnd type="none" w="med" len="med"/>
+                      <a:tailEnd type="none" w="med" len="med"/>
+                    </a:lnL>
+                    <a:lnR w="12700" cap="flat" cmpd="sng" algn="ctr">
+                      <a:solidFill>
+                        <a:schemeClr val="tx1"/>
+                      </a:solidFill>
+                      <a:prstDash val="solid"/>
+                      <a:round/>
+                      <a:headEnd type="none" w="med" len="med"/>
+                      <a:tailEnd type="none" w="med" len="med"/>
+                    </a:lnR>
+                    <a:lnT w="12700" cap="flat" cmpd="sng" algn="ctr">
+                      <a:solidFill>
+                        <a:schemeClr val="tx1"/>
+                      </a:solidFill>
+                      <a:prstDash val="solid"/>
+                      <a:round/>
+                      <a:headEnd type="none" w="med" len="med"/>
+                      <a:tailEnd type="none" w="med" len="med"/>
+                    </a:lnT>
+                    <a:lnB w="12700" cap="flat" cmpd="sng" algn="ctr">
+                      <a:solidFill>
+                        <a:schemeClr val="tx1"/>
+                      </a:solidFill>
+                      <a:prstDash val="solid"/>
+                      <a:round/>
+                      <a:headEnd type="none" w="med" len="med"/>
+                      <a:tailEnd type="none" w="med" len="med"/>
+                    </a:lnB>
+                    <a:solidFill>
+                      <a:schemeClr val="bg1"/>
+                    </a:solidFill>
+                  </a:tcPr>
+                </a:tc>
+                <a:tc>
+                  <a:txBody>
+                    <a:bodyPr/>
+                    <a:lstStyle/>
+                    <a:p>
+                      <a:r>
+                        <a:rPr kumimoji="1" lang="en-US" altLang="ja-JP" sz="1000">
+                          <a:latin typeface="Cascadia Mono" panose="020B0609020000020004" pitchFamily="49" charset="0"/>
+                          <a:ea typeface="Cascadia Mono" panose="020B0609020000020004" pitchFamily="49" charset="0"/>
+                          <a:cs typeface="Cascadia Mono" panose="020B0609020000020004" pitchFamily="49" charset="0"/>
+                        </a:rPr>
+                        <a:t>*.criteria.txt</a:t>
+                      </a:r>
+                      <a:endParaRPr kumimoji="1" lang="ja-JP" altLang="en-US" sz="1000">
+                        <a:latin typeface="Cascadia Mono" panose="020B0609020000020004" pitchFamily="49" charset="0"/>
+                        <a:ea typeface="BIZ UDゴシック" panose="020B0400000000000000" pitchFamily="49" charset="-128"/>
+                        <a:cs typeface="Cascadia Mono" panose="020B0609020000020004" pitchFamily="49" charset="0"/>
+                      </a:endParaRPr>
+                    </a:p>
+                  </a:txBody>
+                  <a:tcPr marL="137160" marR="137160" marT="137160" marB="137160">
+                    <a:lnL w="12700" cap="flat" cmpd="sng" algn="ctr">
+                      <a:solidFill>
+                        <a:schemeClr val="tx1"/>
+                      </a:solidFill>
+                      <a:prstDash val="solid"/>
+                      <a:round/>
+                      <a:headEnd type="none" w="med" len="med"/>
+                      <a:tailEnd type="none" w="med" len="med"/>
+                    </a:lnL>
+                    <a:lnR w="12700" cap="flat" cmpd="sng" algn="ctr">
+                      <a:solidFill>
+                        <a:schemeClr val="tx1"/>
+                      </a:solidFill>
+                      <a:prstDash val="solid"/>
+                      <a:round/>
+                      <a:headEnd type="none" w="med" len="med"/>
+                      <a:tailEnd type="none" w="med" len="med"/>
+                    </a:lnR>
+                    <a:lnT w="12700" cap="flat" cmpd="sng" algn="ctr">
+                      <a:solidFill>
+                        <a:schemeClr val="tx1"/>
+                      </a:solidFill>
+                      <a:prstDash val="solid"/>
+                      <a:round/>
+                      <a:headEnd type="none" w="med" len="med"/>
+                      <a:tailEnd type="none" w="med" len="med"/>
+                    </a:lnT>
+                    <a:lnB w="12700" cap="flat" cmpd="sng" algn="ctr">
+                      <a:solidFill>
+                        <a:schemeClr val="tx1"/>
+                      </a:solidFill>
+                      <a:prstDash val="solid"/>
+                      <a:round/>
+                      <a:headEnd type="none" w="med" len="med"/>
+                      <a:tailEnd type="none" w="med" len="med"/>
+                    </a:lnB>
+                    <a:solidFill>
+                      <a:schemeClr val="bg1"/>
+                    </a:solidFill>
+                  </a:tcPr>
+                </a:tc>
+                <a:tc>
+                  <a:txBody>
+                    <a:bodyPr/>
+                    <a:lstStyle/>
+                    <a:p>
+                      <a:r>
+                        <a:rPr kumimoji="1" lang="en-US" altLang="ja-JP" sz="1000">
+                          <a:latin typeface="Cascadia Mono" panose="020B0609020000020004" pitchFamily="49" charset="0"/>
+                          <a:ea typeface="Cascadia Mono" panose="020B0609020000020004" pitchFamily="49" charset="0"/>
+                          <a:cs typeface="Cascadia Mono" panose="020B0609020000020004" pitchFamily="49" charset="0"/>
+                        </a:rPr>
+                        <a:t>This TXT file defines the evaluation criteria used to generate </a:t>
+                      </a:r>
+                      <a:r>
+                        <a:rPr kumimoji="1" lang="en-US" altLang="ja-JP" sz="1000" b="1" i="1">
+                          <a:solidFill>
+                            <a:srgbClr val="FF0000"/>
+                          </a:solidFill>
+                          <a:latin typeface="Cascadia Mono" panose="020B0609020000020004" pitchFamily="49" charset="0"/>
+                          <a:ea typeface="Cascadia Mono" panose="020B0609020000020004" pitchFamily="49" charset="0"/>
+                          <a:cs typeface="Cascadia Mono" panose="020B0609020000020004" pitchFamily="49" charset="0"/>
+                        </a:rPr>
+                        <a:t>rubric/*.evaluation_steps.json</a:t>
+                      </a:r>
+                      <a:r>
+                        <a:rPr kumimoji="1" lang="en-US" altLang="ja-JP" sz="1000">
+                          <a:latin typeface="Cascadia Mono" panose="020B0609020000020004" pitchFamily="49" charset="0"/>
+                          <a:ea typeface="Cascadia Mono" panose="020B0609020000020004" pitchFamily="49" charset="0"/>
+                          <a:cs typeface="Cascadia Mono" panose="020B0609020000020004" pitchFamily="49" charset="0"/>
+                        </a:rPr>
+                        <a:t>.</a:t>
+                      </a:r>
+                    </a:p>
+                  </a:txBody>
+                  <a:tcPr marL="137160" marR="137160" marT="137160" marB="137160">
+                    <a:lnL w="12700" cap="flat" cmpd="sng" algn="ctr">
+                      <a:solidFill>
+                        <a:schemeClr val="tx1"/>
+                      </a:solidFill>
+                      <a:prstDash val="solid"/>
+                      <a:round/>
+                      <a:headEnd type="none" w="med" len="med"/>
+                      <a:tailEnd type="none" w="med" len="med"/>
+                    </a:lnL>
+                    <a:lnR w="12700" cap="flat" cmpd="sng" algn="ctr">
+                      <a:solidFill>
+                        <a:schemeClr val="tx1"/>
+                      </a:solidFill>
+                      <a:prstDash val="solid"/>
+                      <a:round/>
+                      <a:headEnd type="none" w="med" len="med"/>
+                      <a:tailEnd type="none" w="med" len="med"/>
+                    </a:lnR>
+                    <a:lnT w="12700" cap="flat" cmpd="sng" algn="ctr">
+                      <a:solidFill>
+                        <a:schemeClr val="tx1"/>
+                      </a:solidFill>
+                      <a:prstDash val="solid"/>
+                      <a:round/>
+                      <a:headEnd type="none" w="med" len="med"/>
+                      <a:tailEnd type="none" w="med" len="med"/>
+                    </a:lnT>
+                    <a:lnB w="12700" cap="flat" cmpd="sng" algn="ctr">
+                      <a:solidFill>
+                        <a:schemeClr val="tx1"/>
+                      </a:solidFill>
+                      <a:prstDash val="solid"/>
+                      <a:round/>
+                      <a:headEnd type="none" w="med" len="med"/>
+                      <a:tailEnd type="none" w="med" len="med"/>
+                    </a:lnB>
+                    <a:solidFill>
+                      <a:schemeClr val="bg1"/>
+                    </a:solidFill>
+                  </a:tcPr>
+                </a:tc>
+                <a:extLst>
+                  <a:ext uri="{0D108BD9-81ED-4DB2-BD59-A6C34878D82A}">
+                    <a16:rowId xmlns:a16="http://schemas.microsoft.com/office/drawing/2014/main" val="1707978084"/>
+                  </a:ext>
+                </a:extLst>
+              </a:tr>
+              <a:tr h="437987">
+                <a:tc vMerge="1">
+                  <a:txBody>
+                    <a:bodyPr/>
+                    <a:lstStyle/>
+                    <a:p>
+                      <a:endParaRPr kumimoji="1" lang="ja-JP" altLang="en-US" sz="1000">
+                        <a:latin typeface="Cascadia Mono" panose="020B0609020000020004" pitchFamily="49" charset="0"/>
+                        <a:ea typeface="BIZ UDゴシック" panose="020B0400000000000000" pitchFamily="49" charset="-128"/>
+                        <a:cs typeface="Cascadia Mono" panose="020B0609020000020004" pitchFamily="49" charset="0"/>
+                      </a:endParaRPr>
+                    </a:p>
+                  </a:txBody>
+                  <a:tcPr marL="137160" marR="137160" marT="137160" marB="137160">
+                    <a:lnL w="12700" cap="flat" cmpd="sng" algn="ctr">
+                      <a:solidFill>
+                        <a:schemeClr val="tx1"/>
+                      </a:solidFill>
+                      <a:prstDash val="solid"/>
+                      <a:round/>
+                      <a:headEnd type="none" w="med" len="med"/>
+                      <a:tailEnd type="none" w="med" len="med"/>
+                    </a:lnL>
+                    <a:lnR w="12700" cap="flat" cmpd="sng" algn="ctr">
+                      <a:solidFill>
+                        <a:schemeClr val="tx1"/>
+                      </a:solidFill>
+                      <a:prstDash val="solid"/>
+                      <a:round/>
+                      <a:headEnd type="none" w="med" len="med"/>
+                      <a:tailEnd type="none" w="med" len="med"/>
+                    </a:lnR>
+                    <a:lnT w="12700" cap="flat" cmpd="sng" algn="ctr">
+                      <a:solidFill>
+                        <a:schemeClr val="tx1"/>
+                      </a:solidFill>
+                      <a:prstDash val="solid"/>
+                      <a:round/>
+                      <a:headEnd type="none" w="med" len="med"/>
+                      <a:tailEnd type="none" w="med" len="med"/>
+                    </a:lnT>
+                    <a:lnB w="12700" cap="flat" cmpd="sng" algn="ctr">
+                      <a:solidFill>
+                        <a:schemeClr val="tx1"/>
+                      </a:solidFill>
+                      <a:prstDash val="solid"/>
+                      <a:round/>
+                      <a:headEnd type="none" w="med" len="med"/>
+                      <a:tailEnd type="none" w="med" len="med"/>
+                    </a:lnB>
+                    <a:solidFill>
+                      <a:schemeClr val="bg1"/>
+                    </a:solidFill>
+                  </a:tcPr>
+                </a:tc>
+                <a:tc>
+                  <a:txBody>
+                    <a:bodyPr/>
+                    <a:lstStyle/>
+                    <a:p>
+                      <a:r>
+                        <a:rPr kumimoji="1" lang="en-US" altLang="ja-JP" sz="1000">
+                          <a:latin typeface="Cascadia Mono" panose="020B0609020000020004" pitchFamily="49" charset="0"/>
+                          <a:ea typeface="BIZ UDゴシック" panose="020B0400000000000000" pitchFamily="49" charset="-128"/>
+                          <a:cs typeface="Cascadia Mono" panose="020B0609020000020004" pitchFamily="49" charset="0"/>
+                        </a:rPr>
+                        <a:t>*.evaluation_steps.json</a:t>
+                      </a:r>
+                      <a:endParaRPr kumimoji="1" lang="ja-JP" altLang="en-US" sz="1000">
+                        <a:latin typeface="Cascadia Mono" panose="020B0609020000020004" pitchFamily="49" charset="0"/>
+                        <a:ea typeface="BIZ UDゴシック" panose="020B0400000000000000" pitchFamily="49" charset="-128"/>
+                        <a:cs typeface="Cascadia Mono" panose="020B0609020000020004" pitchFamily="49" charset="0"/>
+                      </a:endParaRPr>
+                    </a:p>
+                  </a:txBody>
+                  <a:tcPr marL="137160" marR="137160" marT="137160" marB="137160">
+                    <a:lnL w="12700" cap="flat" cmpd="sng" algn="ctr">
+                      <a:solidFill>
+                        <a:schemeClr val="tx1"/>
+                      </a:solidFill>
+                      <a:prstDash val="solid"/>
+                      <a:round/>
+                      <a:headEnd type="none" w="med" len="med"/>
+                      <a:tailEnd type="none" w="med" len="med"/>
+                    </a:lnL>
+                    <a:lnR w="12700" cap="flat" cmpd="sng" algn="ctr">
+                      <a:solidFill>
+                        <a:schemeClr val="tx1"/>
+                      </a:solidFill>
+                      <a:prstDash val="solid"/>
+                      <a:round/>
+                      <a:headEnd type="none" w="med" len="med"/>
+                      <a:tailEnd type="none" w="med" len="med"/>
+                    </a:lnR>
+                    <a:lnT w="12700" cap="flat" cmpd="sng" algn="ctr">
+                      <a:solidFill>
+                        <a:schemeClr val="tx1"/>
+                      </a:solidFill>
+                      <a:prstDash val="solid"/>
+                      <a:round/>
+                      <a:headEnd type="none" w="med" len="med"/>
+                      <a:tailEnd type="none" w="med" len="med"/>
+                    </a:lnT>
+                    <a:lnB w="12700" cap="flat" cmpd="sng" algn="ctr">
+                      <a:solidFill>
+                        <a:schemeClr val="tx1"/>
+                      </a:solidFill>
+                      <a:prstDash val="solid"/>
+                      <a:round/>
+                      <a:headEnd type="none" w="med" len="med"/>
+                      <a:tailEnd type="none" w="med" len="med"/>
+                    </a:lnB>
+                    <a:solidFill>
+                      <a:schemeClr val="bg1"/>
+                    </a:solidFill>
+                  </a:tcPr>
+                </a:tc>
+                <a:tc>
+                  <a:txBody>
+                    <a:bodyPr/>
+                    <a:lstStyle/>
+                    <a:p>
+                      <a:pPr marL="0" marR="0" lvl="0" indent="0" algn="l" defTabSz="914400" rtl="0" eaLnBrk="1" fontAlgn="auto" latinLnBrk="0" hangingPunct="1">
+                        <a:lnSpc>
+                          <a:spcPct val="100000"/>
+                        </a:lnSpc>
+                        <a:spcBef>
+                          <a:spcPts val="0"/>
+                        </a:spcBef>
+                        <a:spcAft>
+                          <a:spcPts val="0"/>
+                        </a:spcAft>
+                        <a:buClrTx/>
+                        <a:buSzTx/>
+                        <a:buFontTx/>
+                        <a:buNone/>
+                        <a:tabLst/>
+                        <a:defRPr/>
+                      </a:pPr>
+                      <a:r>
+                        <a:rPr kumimoji="1" lang="en-US" altLang="ja-JP" sz="1000">
+                          <a:latin typeface="Cascadia Mono" panose="020B0609020000020004" pitchFamily="49" charset="0"/>
+                          <a:ea typeface="Cascadia Mono" panose="020B0609020000020004" pitchFamily="49" charset="0"/>
+                          <a:cs typeface="Cascadia Mono" panose="020B0609020000020004" pitchFamily="49" charset="0"/>
+                        </a:rPr>
+                        <a:t>This JSON file defines the steps used for LLM-as-a-Judge evaluation.</a:t>
+                      </a:r>
+                    </a:p>
+                  </a:txBody>
+                  <a:tcPr marL="137160" marR="137160" marT="137160" marB="137160">
+                    <a:lnL w="12700" cap="flat" cmpd="sng" algn="ctr">
+                      <a:solidFill>
+                        <a:schemeClr val="tx1"/>
+                      </a:solidFill>
+                      <a:prstDash val="solid"/>
+                      <a:round/>
+                      <a:headEnd type="none" w="med" len="med"/>
+                      <a:tailEnd type="none" w="med" len="med"/>
+                    </a:lnL>
+                    <a:lnR w="12700" cap="flat" cmpd="sng" algn="ctr">
+                      <a:solidFill>
+                        <a:schemeClr val="tx1"/>
+                      </a:solidFill>
+                      <a:prstDash val="solid"/>
+                      <a:round/>
+                      <a:headEnd type="none" w="med" len="med"/>
+                      <a:tailEnd type="none" w="med" len="med"/>
+                    </a:lnR>
+                    <a:lnT w="12700" cap="flat" cmpd="sng" algn="ctr">
+                      <a:solidFill>
+                        <a:schemeClr val="tx1"/>
+                      </a:solidFill>
+                      <a:prstDash val="solid"/>
+                      <a:round/>
+                      <a:headEnd type="none" w="med" len="med"/>
+                      <a:tailEnd type="none" w="med" len="med"/>
+                    </a:lnT>
+                    <a:lnB w="12700" cap="flat" cmpd="sng" algn="ctr">
+                      <a:solidFill>
+                        <a:schemeClr val="tx1"/>
+                      </a:solidFill>
+                      <a:prstDash val="solid"/>
+                      <a:round/>
+                      <a:headEnd type="none" w="med" len="med"/>
+                      <a:tailEnd type="none" w="med" len="med"/>
+                    </a:lnB>
+                    <a:solidFill>
+                      <a:schemeClr val="bg1"/>
+                    </a:solidFill>
+                  </a:tcPr>
+                </a:tc>
+                <a:extLst>
+                  <a:ext uri="{0D108BD9-81ED-4DB2-BD59-A6C34878D82A}">
+                    <a16:rowId xmlns:a16="http://schemas.microsoft.com/office/drawing/2014/main" val="410864335"/>
+                  </a:ext>
+                </a:extLst>
+              </a:tr>
+              <a:tr h="437987">
+                <a:tc>
+                  <a:txBody>
+                    <a:bodyPr/>
+                    <a:lstStyle/>
+                    <a:p>
+                      <a:r>
+                        <a:rPr kumimoji="1" lang="en-US" altLang="ja-JP" sz="1000">
+                          <a:latin typeface="Cascadia Mono" panose="020B0609020000020004" pitchFamily="49" charset="0"/>
+                          <a:ea typeface="Cascadia Mono" panose="020B0609020000020004" pitchFamily="49" charset="0"/>
+                          <a:cs typeface="Cascadia Mono" panose="020B0609020000020004" pitchFamily="49" charset="0"/>
+                        </a:rPr>
+                        <a:t>source/</a:t>
+                      </a:r>
+                      <a:endParaRPr kumimoji="1" lang="ja-JP" altLang="en-US" sz="1000">
+                        <a:latin typeface="Cascadia Mono" panose="020B0609020000020004" pitchFamily="49" charset="0"/>
+                        <a:ea typeface="BIZ UDゴシック" panose="020B0400000000000000" pitchFamily="49" charset="-128"/>
+                        <a:cs typeface="Cascadia Mono" panose="020B0609020000020004" pitchFamily="49" charset="0"/>
+                      </a:endParaRPr>
+                    </a:p>
+                  </a:txBody>
+                  <a:tcPr marL="137160" marR="137160" marT="137160" marB="137160">
+                    <a:lnL w="12700" cap="flat" cmpd="sng" algn="ctr">
+                      <a:solidFill>
+                        <a:schemeClr val="tx1"/>
+                      </a:solidFill>
+                      <a:prstDash val="solid"/>
+                      <a:round/>
+                      <a:headEnd type="none" w="med" len="med"/>
+                      <a:tailEnd type="none" w="med" len="med"/>
+                    </a:lnL>
+                    <a:lnR w="12700" cap="flat" cmpd="sng" algn="ctr">
+                      <a:solidFill>
+                        <a:schemeClr val="tx1"/>
+                      </a:solidFill>
+                      <a:prstDash val="solid"/>
+                      <a:round/>
+                      <a:headEnd type="none" w="med" len="med"/>
+                      <a:tailEnd type="none" w="med" len="med"/>
+                    </a:lnR>
+                    <a:lnT w="12700" cap="flat" cmpd="sng" algn="ctr">
+                      <a:solidFill>
+                        <a:schemeClr val="tx1"/>
+                      </a:solidFill>
+                      <a:prstDash val="solid"/>
+                      <a:round/>
+                      <a:headEnd type="none" w="med" len="med"/>
+                      <a:tailEnd type="none" w="med" len="med"/>
+                    </a:lnT>
+                    <a:lnB w="12700" cap="flat" cmpd="sng" algn="ctr">
+                      <a:solidFill>
+                        <a:schemeClr val="tx1"/>
+                      </a:solidFill>
+                      <a:prstDash val="solid"/>
+                      <a:round/>
+                      <a:headEnd type="none" w="med" len="med"/>
+                      <a:tailEnd type="none" w="med" len="med"/>
+                    </a:lnB>
+                    <a:solidFill>
+                      <a:schemeClr val="bg1"/>
+                    </a:solidFill>
+                  </a:tcPr>
+                </a:tc>
+                <a:tc>
+                  <a:txBody>
+                    <a:bodyPr/>
+                    <a:lstStyle/>
+                    <a:p>
+                      <a:r>
+                        <a:rPr kumimoji="1" lang="en-US" altLang="ja-JP" sz="1000">
+                          <a:latin typeface="Cascadia Mono" panose="020B0609020000020004" pitchFamily="49" charset="0"/>
+                          <a:ea typeface="Cascadia Mono" panose="020B0609020000020004" pitchFamily="49" charset="0"/>
+                          <a:cs typeface="Cascadia Mono" panose="020B0609020000020004" pitchFamily="49" charset="0"/>
+                        </a:rPr>
+                        <a:t>*.txt</a:t>
+                      </a:r>
+                      <a:endParaRPr kumimoji="1" lang="ja-JP" altLang="en-US" sz="1000">
+                        <a:latin typeface="Cascadia Mono" panose="020B0609020000020004" pitchFamily="49" charset="0"/>
+                        <a:ea typeface="BIZ UDゴシック" panose="020B0400000000000000" pitchFamily="49" charset="-128"/>
+                        <a:cs typeface="Cascadia Mono" panose="020B0609020000020004" pitchFamily="49" charset="0"/>
+                      </a:endParaRPr>
+                    </a:p>
+                  </a:txBody>
+                  <a:tcPr marL="137160" marR="137160" marT="137160" marB="137160">
+                    <a:lnL w="12700" cap="flat" cmpd="sng" algn="ctr">
+                      <a:solidFill>
+                        <a:schemeClr val="tx1"/>
+                      </a:solidFill>
+                      <a:prstDash val="solid"/>
+                      <a:round/>
+                      <a:headEnd type="none" w="med" len="med"/>
+                      <a:tailEnd type="none" w="med" len="med"/>
+                    </a:lnL>
+                    <a:lnR w="12700" cap="flat" cmpd="sng" algn="ctr">
+                      <a:solidFill>
+                        <a:schemeClr val="tx1"/>
+                      </a:solidFill>
+                      <a:prstDash val="solid"/>
+                      <a:round/>
+                      <a:headEnd type="none" w="med" len="med"/>
+                      <a:tailEnd type="none" w="med" len="med"/>
+                    </a:lnR>
+                    <a:lnT w="12700" cap="flat" cmpd="sng" algn="ctr">
+                      <a:solidFill>
+                        <a:schemeClr val="tx1"/>
+                      </a:solidFill>
+                      <a:prstDash val="solid"/>
+                      <a:round/>
+                      <a:headEnd type="none" w="med" len="med"/>
+                      <a:tailEnd type="none" w="med" len="med"/>
+                    </a:lnT>
+                    <a:lnB w="12700" cap="flat" cmpd="sng" algn="ctr">
+                      <a:solidFill>
+                        <a:schemeClr val="tx1"/>
+                      </a:solidFill>
+                      <a:prstDash val="solid"/>
+                      <a:round/>
+                      <a:headEnd type="none" w="med" len="med"/>
+                      <a:tailEnd type="none" w="med" len="med"/>
+                    </a:lnB>
+                    <a:solidFill>
+                      <a:schemeClr val="bg1"/>
+                    </a:solidFill>
+                  </a:tcPr>
+                </a:tc>
+                <a:tc>
+                  <a:txBody>
+                    <a:bodyPr/>
+                    <a:lstStyle/>
+                    <a:p>
+                      <a:r>
+                        <a:rPr kumimoji="1" lang="en-US" altLang="ja-JP" sz="1000">
+                          <a:latin typeface="Cascadia Mono" panose="020B0609020000020004" pitchFamily="49" charset="0"/>
+                          <a:ea typeface="Cascadia Mono" panose="020B0609020000020004" pitchFamily="49" charset="0"/>
+                          <a:cs typeface="Cascadia Mono" panose="020B0609020000020004" pitchFamily="49" charset="0"/>
+                        </a:rPr>
+                        <a:t>This TXT file contains the original text.</a:t>
+                      </a:r>
+                    </a:p>
+                  </a:txBody>
+                  <a:tcPr marL="137160" marR="137160" marT="137160" marB="137160">
+                    <a:lnL w="12700" cap="flat" cmpd="sng" algn="ctr">
+                      <a:solidFill>
+                        <a:schemeClr val="tx1"/>
+                      </a:solidFill>
+                      <a:prstDash val="solid"/>
+                      <a:round/>
+                      <a:headEnd type="none" w="med" len="med"/>
+                      <a:tailEnd type="none" w="med" len="med"/>
+                    </a:lnL>
+                    <a:lnR w="12700" cap="flat" cmpd="sng" algn="ctr">
+                      <a:solidFill>
+                        <a:schemeClr val="tx1"/>
+                      </a:solidFill>
+                      <a:prstDash val="solid"/>
+                      <a:round/>
+                      <a:headEnd type="none" w="med" len="med"/>
+                      <a:tailEnd type="none" w="med" len="med"/>
+                    </a:lnR>
+                    <a:lnT w="12700" cap="flat" cmpd="sng" algn="ctr">
+                      <a:solidFill>
+                        <a:schemeClr val="tx1"/>
+                      </a:solidFill>
+                      <a:prstDash val="solid"/>
+                      <a:round/>
+                      <a:headEnd type="none" w="med" len="med"/>
+                      <a:tailEnd type="none" w="med" len="med"/>
+                    </a:lnT>
+                    <a:lnB w="12700" cap="flat" cmpd="sng" algn="ctr">
+                      <a:solidFill>
+                        <a:schemeClr val="tx1"/>
+                      </a:solidFill>
+                      <a:prstDash val="solid"/>
+                      <a:round/>
+                      <a:headEnd type="none" w="med" len="med"/>
+                      <a:tailEnd type="none" w="med" len="med"/>
+                    </a:lnB>
+                    <a:solidFill>
+                      <a:schemeClr val="bg1"/>
+                    </a:solidFill>
+                  </a:tcPr>
+                </a:tc>
+                <a:extLst>
+                  <a:ext uri="{0D108BD9-81ED-4DB2-BD59-A6C34878D82A}">
+                    <a16:rowId xmlns:a16="http://schemas.microsoft.com/office/drawing/2014/main" val="1262082791"/>
+                  </a:ext>
+                </a:extLst>
+              </a:tr>
+              <a:tr h="437987">
+                <a:tc rowSpan="4">
+                  <a:txBody>
+                    <a:bodyPr/>
+                    <a:lstStyle/>
+                    <a:p>
+                      <a:pPr marL="0" marR="0" lvl="0" indent="0" algn="l" defTabSz="914400" rtl="0" eaLnBrk="1" fontAlgn="auto" latinLnBrk="0" hangingPunct="1">
+                        <a:lnSpc>
+                          <a:spcPct val="100000"/>
+                        </a:lnSpc>
+                        <a:spcBef>
+                          <a:spcPts val="0"/>
+                        </a:spcBef>
+                        <a:spcAft>
+                          <a:spcPts val="0"/>
+                        </a:spcAft>
+                        <a:buClrTx/>
+                        <a:buSzTx/>
+                        <a:buFontTx/>
+                        <a:buNone/>
+                        <a:tabLst/>
+                        <a:defRPr/>
+                      </a:pPr>
+                      <a:r>
+                        <a:rPr kumimoji="1" lang="en-US" altLang="ja-JP" sz="1000">
+                          <a:latin typeface="Cascadia Mono" panose="020B0609020000020004" pitchFamily="49" charset="0"/>
+                          <a:ea typeface="Cascadia Mono" panose="020B0609020000020004" pitchFamily="49" charset="0"/>
+                          <a:cs typeface="Cascadia Mono" panose="020B0609020000020004" pitchFamily="49" charset="0"/>
+                        </a:rPr>
+                        <a:t>supports/</a:t>
+                      </a:r>
+                      <a:endParaRPr kumimoji="1" lang="ja-JP" altLang="en-US" sz="1000">
+                        <a:latin typeface="Cascadia Mono" panose="020B0609020000020004" pitchFamily="49" charset="0"/>
+                        <a:ea typeface="BIZ UDゴシック" panose="020B0400000000000000" pitchFamily="49" charset="-128"/>
+                        <a:cs typeface="Cascadia Mono" panose="020B0609020000020004" pitchFamily="49" charset="0"/>
+                      </a:endParaRPr>
+                    </a:p>
+                  </a:txBody>
+                  <a:tcPr marL="137160" marR="137160" marT="137160" marB="137160">
+                    <a:lnL w="12700" cap="flat" cmpd="sng" algn="ctr">
+                      <a:solidFill>
+                        <a:schemeClr val="tx1"/>
+                      </a:solidFill>
+                      <a:prstDash val="solid"/>
+                      <a:round/>
+                      <a:headEnd type="none" w="med" len="med"/>
+                      <a:tailEnd type="none" w="med" len="med"/>
+                    </a:lnL>
+                    <a:lnR w="12700" cap="flat" cmpd="sng" algn="ctr">
+                      <a:solidFill>
+                        <a:schemeClr val="tx1"/>
+                      </a:solidFill>
+                      <a:prstDash val="solid"/>
+                      <a:round/>
+                      <a:headEnd type="none" w="med" len="med"/>
+                      <a:tailEnd type="none" w="med" len="med"/>
+                    </a:lnR>
+                    <a:lnT w="12700" cap="flat" cmpd="sng" algn="ctr">
+                      <a:solidFill>
+                        <a:schemeClr val="tx1"/>
+                      </a:solidFill>
+                      <a:prstDash val="solid"/>
+                      <a:round/>
+                      <a:headEnd type="none" w="med" len="med"/>
+                      <a:tailEnd type="none" w="med" len="med"/>
+                    </a:lnT>
+                    <a:lnB w="12700" cap="flat" cmpd="sng" algn="ctr">
+                      <a:solidFill>
+                        <a:schemeClr val="tx1"/>
+                      </a:solidFill>
+                      <a:prstDash val="solid"/>
+                      <a:round/>
+                      <a:headEnd type="none" w="med" len="med"/>
+                      <a:tailEnd type="none" w="med" len="med"/>
+                    </a:lnB>
+                    <a:solidFill>
+                      <a:schemeClr val="bg1"/>
+                    </a:solidFill>
+                  </a:tcPr>
+                </a:tc>
+                <a:tc>
+                  <a:txBody>
+                    <a:bodyPr/>
+                    <a:lstStyle/>
+                    <a:p>
+                      <a:pPr marL="0" marR="0" lvl="0" indent="0" algn="l" defTabSz="914400" rtl="0" eaLnBrk="1" fontAlgn="auto" latinLnBrk="0" hangingPunct="1">
+                        <a:lnSpc>
+                          <a:spcPct val="100000"/>
+                        </a:lnSpc>
+                        <a:spcBef>
+                          <a:spcPts val="0"/>
+                        </a:spcBef>
+                        <a:spcAft>
+                          <a:spcPts val="0"/>
+                        </a:spcAft>
+                        <a:buClrTx/>
+                        <a:buSzTx/>
+                        <a:buFontTx/>
+                        <a:buNone/>
+                        <a:tabLst/>
+                        <a:defRPr/>
+                      </a:pPr>
+                      <a:r>
+                        <a:rPr kumimoji="1" lang="en-US" altLang="ja-JP" sz="1000">
+                          <a:latin typeface="Cascadia Mono" panose="020B0609020000020004" pitchFamily="49" charset="0"/>
+                          <a:ea typeface="Cascadia Mono" panose="020B0609020000020004" pitchFamily="49" charset="0"/>
+                          <a:cs typeface="Cascadia Mono" panose="020B0609020000020004" pitchFamily="49" charset="0"/>
+                        </a:rPr>
+                        <a:t>llmj-configure.py</a:t>
+                      </a:r>
+                      <a:endParaRPr kumimoji="1" lang="ja-JP" altLang="en-US" sz="1000">
+                        <a:latin typeface="Cascadia Mono" panose="020B0609020000020004" pitchFamily="49" charset="0"/>
+                        <a:ea typeface="BIZ UDゴシック" panose="020B0400000000000000" pitchFamily="49" charset="-128"/>
+                        <a:cs typeface="Cascadia Mono" panose="020B0609020000020004" pitchFamily="49" charset="0"/>
+                      </a:endParaRPr>
+                    </a:p>
+                  </a:txBody>
+                  <a:tcPr marL="137160" marR="137160" marT="137160" marB="137160">
+                    <a:lnL w="12700" cap="flat" cmpd="sng" algn="ctr">
+                      <a:solidFill>
+                        <a:schemeClr val="tx1"/>
+                      </a:solidFill>
+                      <a:prstDash val="solid"/>
+                      <a:round/>
+                      <a:headEnd type="none" w="med" len="med"/>
+                      <a:tailEnd type="none" w="med" len="med"/>
+                    </a:lnL>
+                    <a:lnR w="12700" cap="flat" cmpd="sng" algn="ctr">
+                      <a:solidFill>
+                        <a:schemeClr val="tx1"/>
+                      </a:solidFill>
+                      <a:prstDash val="solid"/>
+                      <a:round/>
+                      <a:headEnd type="none" w="med" len="med"/>
+                      <a:tailEnd type="none" w="med" len="med"/>
+                    </a:lnR>
+                    <a:lnT w="12700" cap="flat" cmpd="sng" algn="ctr">
+                      <a:solidFill>
+                        <a:schemeClr val="tx1"/>
+                      </a:solidFill>
+                      <a:prstDash val="solid"/>
+                      <a:round/>
+                      <a:headEnd type="none" w="med" len="med"/>
+                      <a:tailEnd type="none" w="med" len="med"/>
+                    </a:lnT>
+                    <a:lnB w="12700" cap="flat" cmpd="sng" algn="ctr">
+                      <a:solidFill>
+                        <a:schemeClr val="tx1"/>
+                      </a:solidFill>
+                      <a:prstDash val="solid"/>
+                      <a:round/>
+                      <a:headEnd type="none" w="med" len="med"/>
+                      <a:tailEnd type="none" w="med" len="med"/>
+                    </a:lnB>
+                    <a:solidFill>
+                      <a:schemeClr val="bg1"/>
+                    </a:solidFill>
+                  </a:tcPr>
+                </a:tc>
+                <a:tc>
+                  <a:txBody>
+                    <a:bodyPr/>
+                    <a:lstStyle/>
+                    <a:p>
+                      <a:r>
+                        <a:rPr kumimoji="1" lang="en-US" altLang="ja-JP" sz="1000" b="0" i="0">
+                          <a:solidFill>
+                            <a:schemeClr val="tx1"/>
+                          </a:solidFill>
+                          <a:latin typeface="Cascadia Mono" panose="020B0609020000020004" pitchFamily="49" charset="0"/>
+                          <a:ea typeface="Cascadia Mono" panose="020B0609020000020004" pitchFamily="49" charset="0"/>
+                          <a:cs typeface="Cascadia Mono" panose="020B0609020000020004" pitchFamily="49" charset="0"/>
+                        </a:rPr>
+                        <a:t>It generates </a:t>
+                      </a:r>
+                      <a:r>
+                        <a:rPr kumimoji="1" lang="en-US" altLang="ja-JP" sz="1000" b="1" i="1">
+                          <a:solidFill>
+                            <a:srgbClr val="FF0000"/>
+                          </a:solidFill>
+                          <a:latin typeface="Cascadia Mono" panose="020B0609020000020004" pitchFamily="49" charset="0"/>
+                          <a:ea typeface="Cascadia Mono" panose="020B0609020000020004" pitchFamily="49" charset="0"/>
+                          <a:cs typeface="Cascadia Mono" panose="020B0609020000020004" pitchFamily="49" charset="0"/>
+                        </a:rPr>
+                        <a:t>work/rubric-stats.json</a:t>
+                      </a:r>
+                      <a:r>
+                        <a:rPr kumimoji="1" lang="en-US" altLang="ja-JP" sz="1000" b="0" i="0">
+                          <a:solidFill>
+                            <a:srgbClr val="FF0000"/>
+                          </a:solidFill>
+                          <a:latin typeface="Cascadia Mono" panose="020B0609020000020004" pitchFamily="49" charset="0"/>
+                          <a:ea typeface="Cascadia Mono" panose="020B0609020000020004" pitchFamily="49" charset="0"/>
+                          <a:cs typeface="Cascadia Mono" panose="020B0609020000020004" pitchFamily="49" charset="0"/>
+                        </a:rPr>
+                        <a:t> </a:t>
+                      </a:r>
+                      <a:r>
+                        <a:rPr kumimoji="1" lang="en-US" altLang="ja-JP" sz="1000" b="0" i="0">
+                          <a:solidFill>
+                            <a:schemeClr val="tx1"/>
+                          </a:solidFill>
+                          <a:latin typeface="Cascadia Mono" panose="020B0609020000020004" pitchFamily="49" charset="0"/>
+                          <a:ea typeface="Cascadia Mono" panose="020B0609020000020004" pitchFamily="49" charset="0"/>
+                          <a:cs typeface="Cascadia Mono" panose="020B0609020000020004" pitchFamily="49" charset="0"/>
+                        </a:rPr>
+                        <a:t>for statistical analysis of the judge results.</a:t>
+                      </a:r>
+                    </a:p>
+                  </a:txBody>
+                  <a:tcPr marL="137160" marR="137160" marT="137160" marB="137160">
+                    <a:lnL w="12700" cap="flat" cmpd="sng" algn="ctr">
+                      <a:solidFill>
+                        <a:schemeClr val="tx1"/>
+                      </a:solidFill>
+                      <a:prstDash val="solid"/>
+                      <a:round/>
+                      <a:headEnd type="none" w="med" len="med"/>
+                      <a:tailEnd type="none" w="med" len="med"/>
+                    </a:lnL>
+                    <a:lnR w="12700" cap="flat" cmpd="sng" algn="ctr">
+                      <a:solidFill>
+                        <a:schemeClr val="tx1"/>
+                      </a:solidFill>
+                      <a:prstDash val="solid"/>
+                      <a:round/>
+                      <a:headEnd type="none" w="med" len="med"/>
+                      <a:tailEnd type="none" w="med" len="med"/>
+                    </a:lnR>
+                    <a:lnT w="12700" cap="flat" cmpd="sng" algn="ctr">
+                      <a:solidFill>
+                        <a:schemeClr val="tx1"/>
+                      </a:solidFill>
+                      <a:prstDash val="solid"/>
+                      <a:round/>
+                      <a:headEnd type="none" w="med" len="med"/>
+                      <a:tailEnd type="none" w="med" len="med"/>
+                    </a:lnT>
+                    <a:lnB w="12700" cap="flat" cmpd="sng" algn="ctr">
+                      <a:solidFill>
+                        <a:schemeClr val="tx1"/>
+                      </a:solidFill>
+                      <a:prstDash val="solid"/>
+                      <a:round/>
+                      <a:headEnd type="none" w="med" len="med"/>
+                      <a:tailEnd type="none" w="med" len="med"/>
+                    </a:lnB>
+                    <a:solidFill>
+                      <a:schemeClr val="bg1"/>
+                    </a:solidFill>
+                  </a:tcPr>
+                </a:tc>
+                <a:extLst>
+                  <a:ext uri="{0D108BD9-81ED-4DB2-BD59-A6C34878D82A}">
+                    <a16:rowId xmlns:a16="http://schemas.microsoft.com/office/drawing/2014/main" val="2339504222"/>
+                  </a:ext>
+                </a:extLst>
+              </a:tr>
+              <a:tr h="437987">
+                <a:tc vMerge="1">
+                  <a:txBody>
+                    <a:bodyPr/>
+                    <a:lstStyle/>
+                    <a:p>
+                      <a:endParaRPr kumimoji="1" lang="ja-JP" altLang="en-US"/>
+                    </a:p>
+                  </a:txBody>
+                  <a:tcPr/>
+                </a:tc>
+                <a:tc>
+                  <a:txBody>
+                    <a:bodyPr/>
+                    <a:lstStyle/>
+                    <a:p>
+                      <a:pPr marL="0" marR="0" lvl="0" indent="0" algn="l" defTabSz="914400" rtl="0" eaLnBrk="1" fontAlgn="auto" latinLnBrk="0" hangingPunct="1">
+                        <a:lnSpc>
+                          <a:spcPct val="100000"/>
+                        </a:lnSpc>
+                        <a:spcBef>
+                          <a:spcPts val="0"/>
+                        </a:spcBef>
+                        <a:spcAft>
+                          <a:spcPts val="0"/>
+                        </a:spcAft>
+                        <a:buClrTx/>
+                        <a:buSzTx/>
+                        <a:buFontTx/>
+                        <a:buNone/>
+                        <a:tabLst/>
+                        <a:defRPr/>
+                      </a:pPr>
+                      <a:r>
+                        <a:rPr kumimoji="1" lang="en-US" altLang="ja-JP" sz="1000">
+                          <a:latin typeface="Cascadia Mono" panose="020B0609020000020004" pitchFamily="49" charset="0"/>
+                          <a:ea typeface="Cascadia Mono" panose="020B0609020000020004" pitchFamily="49" charset="0"/>
+                          <a:cs typeface="Cascadia Mono" panose="020B0609020000020004" pitchFamily="49" charset="0"/>
+                        </a:rPr>
+                        <a:t>llmj-fake-source.py</a:t>
+                      </a:r>
+                      <a:endParaRPr kumimoji="1" lang="ja-JP" altLang="en-US" sz="1000">
+                        <a:latin typeface="Cascadia Mono" panose="020B0609020000020004" pitchFamily="49" charset="0"/>
+                        <a:ea typeface="BIZ UDゴシック" panose="020B0400000000000000" pitchFamily="49" charset="-128"/>
+                        <a:cs typeface="Cascadia Mono" panose="020B0609020000020004" pitchFamily="49" charset="0"/>
+                      </a:endParaRPr>
+                    </a:p>
+                  </a:txBody>
+                  <a:tcPr marL="137160" marR="137160" marT="137160" marB="137160">
+                    <a:lnL w="12700" cap="flat" cmpd="sng" algn="ctr">
+                      <a:solidFill>
+                        <a:schemeClr val="tx1"/>
+                      </a:solidFill>
+                      <a:prstDash val="solid"/>
+                      <a:round/>
+                      <a:headEnd type="none" w="med" len="med"/>
+                      <a:tailEnd type="none" w="med" len="med"/>
+                    </a:lnL>
+                    <a:lnR w="12700" cap="flat" cmpd="sng" algn="ctr">
+                      <a:solidFill>
+                        <a:schemeClr val="tx1"/>
+                      </a:solidFill>
+                      <a:prstDash val="solid"/>
+                      <a:round/>
+                      <a:headEnd type="none" w="med" len="med"/>
+                      <a:tailEnd type="none" w="med" len="med"/>
+                    </a:lnR>
+                    <a:lnT w="12700" cap="flat" cmpd="sng" algn="ctr">
+                      <a:solidFill>
+                        <a:schemeClr val="tx1"/>
+                      </a:solidFill>
+                      <a:prstDash val="solid"/>
+                      <a:round/>
+                      <a:headEnd type="none" w="med" len="med"/>
+                      <a:tailEnd type="none" w="med" len="med"/>
+                    </a:lnT>
+                    <a:lnB w="12700" cap="flat" cmpd="sng" algn="ctr">
+                      <a:solidFill>
+                        <a:schemeClr val="tx1"/>
+                      </a:solidFill>
+                      <a:prstDash val="solid"/>
+                      <a:round/>
+                      <a:headEnd type="none" w="med" len="med"/>
+                      <a:tailEnd type="none" w="med" len="med"/>
+                    </a:lnB>
+                    <a:solidFill>
+                      <a:schemeClr val="bg1"/>
+                    </a:solidFill>
+                  </a:tcPr>
+                </a:tc>
+                <a:tc>
+                  <a:txBody>
+                    <a:bodyPr/>
+                    <a:lstStyle/>
+                    <a:p>
+                      <a:r>
+                        <a:rPr kumimoji="1" lang="en-US" altLang="ja-JP" sz="1000" b="0" i="0">
+                          <a:solidFill>
+                            <a:schemeClr val="tx1"/>
+                          </a:solidFill>
+                          <a:latin typeface="Cascadia Mono" panose="020B0609020000020004" pitchFamily="49" charset="0"/>
+                          <a:ea typeface="Cascadia Mono" panose="020B0609020000020004" pitchFamily="49" charset="0"/>
+                          <a:cs typeface="Cascadia Mono" panose="020B0609020000020004" pitchFamily="49" charset="0"/>
+                        </a:rPr>
+                        <a:t>It generates a large number of TXT files </a:t>
+                      </a:r>
+                      <a:r>
+                        <a:rPr kumimoji="1" lang="en-US" altLang="ja-JP" sz="1000" b="1" i="1">
+                          <a:solidFill>
+                            <a:srgbClr val="FF0000"/>
+                          </a:solidFill>
+                          <a:latin typeface="Cascadia Mono" panose="020B0609020000020004" pitchFamily="49" charset="0"/>
+                          <a:ea typeface="Cascadia Mono" panose="020B0609020000020004" pitchFamily="49" charset="0"/>
+                          <a:cs typeface="Cascadia Mono" panose="020B0609020000020004" pitchFamily="49" charset="0"/>
+                        </a:rPr>
+                        <a:t>under source/</a:t>
+                      </a:r>
+                      <a:r>
+                        <a:rPr kumimoji="1" lang="en-US" altLang="ja-JP" sz="1000" b="0" i="0">
+                          <a:solidFill>
+                            <a:schemeClr val="tx1"/>
+                          </a:solidFill>
+                          <a:latin typeface="Cascadia Mono" panose="020B0609020000020004" pitchFamily="49" charset="0"/>
+                          <a:ea typeface="Cascadia Mono" panose="020B0609020000020004" pitchFamily="49" charset="0"/>
+                          <a:cs typeface="Cascadia Mono" panose="020B0609020000020004" pitchFamily="49" charset="0"/>
+                        </a:rPr>
+                        <a:t>. Please use them as input data for quality verification.</a:t>
+                      </a:r>
+                    </a:p>
+                  </a:txBody>
+                  <a:tcPr marL="137160" marR="137160" marT="137160" marB="137160">
+                    <a:lnL w="12700" cap="flat" cmpd="sng" algn="ctr">
+                      <a:solidFill>
+                        <a:schemeClr val="tx1"/>
+                      </a:solidFill>
+                      <a:prstDash val="solid"/>
+                      <a:round/>
+                      <a:headEnd type="none" w="med" len="med"/>
+                      <a:tailEnd type="none" w="med" len="med"/>
+                    </a:lnL>
+                    <a:lnR w="12700" cap="flat" cmpd="sng" algn="ctr">
+                      <a:solidFill>
+                        <a:schemeClr val="tx1"/>
+                      </a:solidFill>
+                      <a:prstDash val="solid"/>
+                      <a:round/>
+                      <a:headEnd type="none" w="med" len="med"/>
+                      <a:tailEnd type="none" w="med" len="med"/>
+                    </a:lnR>
+                    <a:lnT w="12700" cap="flat" cmpd="sng" algn="ctr">
+                      <a:solidFill>
+                        <a:schemeClr val="tx1"/>
+                      </a:solidFill>
+                      <a:prstDash val="solid"/>
+                      <a:round/>
+                      <a:headEnd type="none" w="med" len="med"/>
+                      <a:tailEnd type="none" w="med" len="med"/>
+                    </a:lnT>
+                    <a:lnB w="12700" cap="flat" cmpd="sng" algn="ctr">
+                      <a:solidFill>
+                        <a:schemeClr val="tx1"/>
+                      </a:solidFill>
+                      <a:prstDash val="solid"/>
+                      <a:round/>
+                      <a:headEnd type="none" w="med" len="med"/>
+                      <a:tailEnd type="none" w="med" len="med"/>
+                    </a:lnB>
+                    <a:solidFill>
+                      <a:schemeClr val="bg1"/>
+                    </a:solidFill>
+                  </a:tcPr>
+                </a:tc>
+                <a:extLst>
+                  <a:ext uri="{0D108BD9-81ED-4DB2-BD59-A6C34878D82A}">
+                    <a16:rowId xmlns:a16="http://schemas.microsoft.com/office/drawing/2014/main" val="2065486968"/>
+                  </a:ext>
+                </a:extLst>
+              </a:tr>
+              <a:tr h="594411">
+                <a:tc vMerge="1">
+                  <a:txBody>
+                    <a:bodyPr/>
+                    <a:lstStyle/>
+                    <a:p>
+                      <a:endParaRPr kumimoji="1" lang="ja-JP" altLang="en-US" sz="1000">
+                        <a:latin typeface="Cascadia Code SemiBold" panose="020B0609020000020004" pitchFamily="49" charset="0"/>
+                        <a:ea typeface="BIZ UDゴシック" panose="020B0400000000000000" pitchFamily="49" charset="-128"/>
+                        <a:cs typeface="Cascadia Code SemiBold" panose="020B0609020000020004" pitchFamily="49" charset="0"/>
+                      </a:endParaRPr>
+                    </a:p>
+                  </a:txBody>
+                  <a:tcPr marL="137160" marR="137160" marT="137160" marB="137160">
+                    <a:lnL w="12700" cap="flat" cmpd="sng" algn="ctr">
+                      <a:solidFill>
+                        <a:schemeClr val="tx1"/>
+                      </a:solidFill>
+                      <a:prstDash val="solid"/>
+                      <a:round/>
+                      <a:headEnd type="none" w="med" len="med"/>
+                      <a:tailEnd type="none" w="med" len="med"/>
+                    </a:lnL>
+                    <a:lnR w="12700" cap="flat" cmpd="sng" algn="ctr">
+                      <a:solidFill>
+                        <a:schemeClr val="tx1"/>
+                      </a:solidFill>
+                      <a:prstDash val="solid"/>
+                      <a:round/>
+                      <a:headEnd type="none" w="med" len="med"/>
+                      <a:tailEnd type="none" w="med" len="med"/>
+                    </a:lnR>
+                    <a:lnT w="12700" cap="flat" cmpd="sng" algn="ctr">
+                      <a:solidFill>
+                        <a:schemeClr val="tx1"/>
+                      </a:solidFill>
+                      <a:prstDash val="solid"/>
+                      <a:round/>
+                      <a:headEnd type="none" w="med" len="med"/>
+                      <a:tailEnd type="none" w="med" len="med"/>
+                    </a:lnT>
+                    <a:lnB w="12700" cap="flat" cmpd="sng" algn="ctr">
+                      <a:solidFill>
+                        <a:schemeClr val="tx1"/>
+                      </a:solidFill>
+                      <a:prstDash val="solid"/>
+                      <a:round/>
+                      <a:headEnd type="none" w="med" len="med"/>
+                      <a:tailEnd type="none" w="med" len="med"/>
+                    </a:lnB>
+                    <a:solidFill>
+                      <a:schemeClr val="bg1"/>
+                    </a:solidFill>
+                  </a:tcPr>
+                </a:tc>
+                <a:tc>
+                  <a:txBody>
+                    <a:bodyPr/>
+                    <a:lstStyle/>
+                    <a:p>
+                      <a:r>
+                        <a:rPr kumimoji="1" lang="en-US" altLang="ja-JP" sz="1000">
+                          <a:latin typeface="Cascadia Mono" panose="020B0609020000020004" pitchFamily="49" charset="0"/>
+                          <a:ea typeface="Cascadia Mono" panose="020B0609020000020004" pitchFamily="49" charset="0"/>
+                          <a:cs typeface="Cascadia Mono" panose="020B0609020000020004" pitchFamily="49" charset="0"/>
+                        </a:rPr>
+                        <a:t>llmj-initial.py</a:t>
+                      </a:r>
+                      <a:endParaRPr kumimoji="1" lang="ja-JP" altLang="en-US" sz="1000">
+                        <a:latin typeface="Cascadia Mono" panose="020B0609020000020004" pitchFamily="49" charset="0"/>
+                        <a:ea typeface="BIZ UDゴシック" panose="020B0400000000000000" pitchFamily="49" charset="-128"/>
+                        <a:cs typeface="Cascadia Mono" panose="020B0609020000020004" pitchFamily="49" charset="0"/>
+                      </a:endParaRPr>
+                    </a:p>
+                  </a:txBody>
+                  <a:tcPr marL="137160" marR="137160" marT="137160" marB="137160">
+                    <a:lnL w="12700" cap="flat" cmpd="sng" algn="ctr">
+                      <a:solidFill>
+                        <a:schemeClr val="tx1"/>
+                      </a:solidFill>
+                      <a:prstDash val="solid"/>
+                      <a:round/>
+                      <a:headEnd type="none" w="med" len="med"/>
+                      <a:tailEnd type="none" w="med" len="med"/>
+                    </a:lnL>
+                    <a:lnR w="12700" cap="flat" cmpd="sng" algn="ctr">
+                      <a:solidFill>
+                        <a:schemeClr val="tx1"/>
+                      </a:solidFill>
+                      <a:prstDash val="solid"/>
+                      <a:round/>
+                      <a:headEnd type="none" w="med" len="med"/>
+                      <a:tailEnd type="none" w="med" len="med"/>
+                    </a:lnR>
+                    <a:lnT w="12700" cap="flat" cmpd="sng" algn="ctr">
+                      <a:solidFill>
+                        <a:schemeClr val="tx1"/>
+                      </a:solidFill>
+                      <a:prstDash val="solid"/>
+                      <a:round/>
+                      <a:headEnd type="none" w="med" len="med"/>
+                      <a:tailEnd type="none" w="med" len="med"/>
+                    </a:lnT>
+                    <a:lnB w="12700" cap="flat" cmpd="sng" algn="ctr">
+                      <a:solidFill>
+                        <a:schemeClr val="tx1"/>
+                      </a:solidFill>
+                      <a:prstDash val="solid"/>
+                      <a:round/>
+                      <a:headEnd type="none" w="med" len="med"/>
+                      <a:tailEnd type="none" w="med" len="med"/>
+                    </a:lnB>
+                    <a:solidFill>
+                      <a:schemeClr val="bg1"/>
+                    </a:solidFill>
+                  </a:tcPr>
+                </a:tc>
+                <a:tc>
+                  <a:txBody>
+                    <a:bodyPr/>
+                    <a:lstStyle/>
+                    <a:p>
+                      <a:r>
+                        <a:rPr kumimoji="1" lang="en-US" altLang="ja-JP" sz="1000">
+                          <a:latin typeface="Cascadia Mono" panose="020B0609020000020004" pitchFamily="49" charset="0"/>
+                          <a:ea typeface="Cascadia Mono" panose="020B0609020000020004" pitchFamily="49" charset="0"/>
+                          <a:cs typeface="Cascadia Mono" panose="020B0609020000020004" pitchFamily="49" charset="0"/>
+                        </a:rPr>
+                        <a:t>This SCRIPT generates prompt templates from </a:t>
+                      </a:r>
+                      <a:r>
+                        <a:rPr kumimoji="1" lang="en-US" altLang="ja-JP" sz="1000" b="1" i="1">
+                          <a:solidFill>
+                            <a:srgbClr val="FF0000"/>
+                          </a:solidFill>
+                          <a:latin typeface="Cascadia Mono" panose="020B0609020000020004" pitchFamily="49" charset="0"/>
+                          <a:ea typeface="Cascadia Mono" panose="020B0609020000020004" pitchFamily="49" charset="0"/>
+                          <a:cs typeface="Cascadia Mono" panose="020B0609020000020004" pitchFamily="49" charset="0"/>
+                        </a:rPr>
+                        <a:t>rubric/*.criteria.txt</a:t>
+                      </a:r>
+                      <a:r>
+                        <a:rPr kumimoji="1" lang="en-US" altLang="ja-JP" sz="1000">
+                          <a:latin typeface="Cascadia Mono" panose="020B0609020000020004" pitchFamily="49" charset="0"/>
+                          <a:ea typeface="Cascadia Mono" panose="020B0609020000020004" pitchFamily="49" charset="0"/>
+                          <a:cs typeface="Cascadia Mono" panose="020B0609020000020004" pitchFamily="49" charset="0"/>
+                        </a:rPr>
+                        <a:t> and writes them to </a:t>
+                      </a:r>
+                      <a:r>
+                        <a:rPr kumimoji="1" lang="en-US" altLang="ja-JP" sz="1000" b="1" i="1">
+                          <a:solidFill>
+                            <a:srgbClr val="FF0000"/>
+                          </a:solidFill>
+                          <a:latin typeface="Cascadia Mono" panose="020B0609020000020004" pitchFamily="49" charset="0"/>
+                          <a:ea typeface="Cascadia Mono" panose="020B0609020000020004" pitchFamily="49" charset="0"/>
+                          <a:cs typeface="Cascadia Mono" panose="020B0609020000020004" pitchFamily="49" charset="0"/>
+                        </a:rPr>
+                        <a:t>work/*.txt</a:t>
+                      </a:r>
+                      <a:r>
+                        <a:rPr kumimoji="1" lang="en-US" altLang="ja-JP" sz="1000">
+                          <a:latin typeface="Cascadia Mono" panose="020B0609020000020004" pitchFamily="49" charset="0"/>
+                          <a:ea typeface="Cascadia Mono" panose="020B0609020000020004" pitchFamily="49" charset="0"/>
+                          <a:cs typeface="Cascadia Mono" panose="020B0609020000020004" pitchFamily="49" charset="0"/>
+                        </a:rPr>
+                        <a:t>. These prompts serve as a baseline for human tuning.</a:t>
+                      </a:r>
+                    </a:p>
+                  </a:txBody>
+                  <a:tcPr marL="137160" marR="137160" marT="137160" marB="137160">
+                    <a:lnL w="12700" cap="flat" cmpd="sng" algn="ctr">
+                      <a:solidFill>
+                        <a:schemeClr val="tx1"/>
+                      </a:solidFill>
+                      <a:prstDash val="solid"/>
+                      <a:round/>
+                      <a:headEnd type="none" w="med" len="med"/>
+                      <a:tailEnd type="none" w="med" len="med"/>
+                    </a:lnL>
+                    <a:lnR w="12700" cap="flat" cmpd="sng" algn="ctr">
+                      <a:solidFill>
+                        <a:schemeClr val="tx1"/>
+                      </a:solidFill>
+                      <a:prstDash val="solid"/>
+                      <a:round/>
+                      <a:headEnd type="none" w="med" len="med"/>
+                      <a:tailEnd type="none" w="med" len="med"/>
+                    </a:lnR>
+                    <a:lnT w="12700" cap="flat" cmpd="sng" algn="ctr">
+                      <a:solidFill>
+                        <a:schemeClr val="tx1"/>
+                      </a:solidFill>
+                      <a:prstDash val="solid"/>
+                      <a:round/>
+                      <a:headEnd type="none" w="med" len="med"/>
+                      <a:tailEnd type="none" w="med" len="med"/>
+                    </a:lnT>
+                    <a:lnB w="12700" cap="flat" cmpd="sng" algn="ctr">
+                      <a:solidFill>
+                        <a:schemeClr val="tx1"/>
+                      </a:solidFill>
+                      <a:prstDash val="solid"/>
+                      <a:round/>
+                      <a:headEnd type="none" w="med" len="med"/>
+                      <a:tailEnd type="none" w="med" len="med"/>
+                    </a:lnB>
+                    <a:solidFill>
+                      <a:schemeClr val="bg1"/>
+                    </a:solidFill>
+                  </a:tcPr>
+                </a:tc>
+                <a:extLst>
+                  <a:ext uri="{0D108BD9-81ED-4DB2-BD59-A6C34878D82A}">
+                    <a16:rowId xmlns:a16="http://schemas.microsoft.com/office/drawing/2014/main" val="3817967045"/>
+                  </a:ext>
+                </a:extLst>
+              </a:tr>
+              <a:tr h="594411">
+                <a:tc vMerge="1">
+                  <a:txBody>
+                    <a:bodyPr/>
+                    <a:lstStyle/>
+                    <a:p>
+                      <a:pPr marL="0" marR="0" lvl="0" indent="0" algn="l" defTabSz="914400" rtl="0" eaLnBrk="1" fontAlgn="auto" latinLnBrk="0" hangingPunct="1">
+                        <a:lnSpc>
+                          <a:spcPct val="100000"/>
+                        </a:lnSpc>
+                        <a:spcBef>
+                          <a:spcPts val="0"/>
+                        </a:spcBef>
+                        <a:spcAft>
+                          <a:spcPts val="0"/>
+                        </a:spcAft>
+                        <a:buClrTx/>
+                        <a:buSzTx/>
+                        <a:buFontTx/>
+                        <a:buNone/>
+                        <a:tabLst/>
+                        <a:defRPr/>
+                      </a:pPr>
+                      <a:endParaRPr kumimoji="1" lang="ja-JP" altLang="en-US" sz="1000">
+                        <a:latin typeface="Cascadia Code SemiBold" panose="020B0609020000020004" pitchFamily="49" charset="0"/>
+                        <a:ea typeface="BIZ UDゴシック" panose="020B0400000000000000" pitchFamily="49" charset="-128"/>
+                        <a:cs typeface="Cascadia Code SemiBold" panose="020B0609020000020004" pitchFamily="49" charset="0"/>
+                      </a:endParaRPr>
+                    </a:p>
+                  </a:txBody>
+                  <a:tcPr marL="137160" marR="137160" marT="137160" marB="137160">
+                    <a:lnL w="12700" cap="flat" cmpd="sng" algn="ctr">
+                      <a:solidFill>
+                        <a:schemeClr val="tx1"/>
+                      </a:solidFill>
+                      <a:prstDash val="solid"/>
+                      <a:round/>
+                      <a:headEnd type="none" w="med" len="med"/>
+                      <a:tailEnd type="none" w="med" len="med"/>
+                    </a:lnL>
+                    <a:lnR w="12700" cap="flat" cmpd="sng" algn="ctr">
+                      <a:solidFill>
+                        <a:schemeClr val="tx1"/>
+                      </a:solidFill>
+                      <a:prstDash val="solid"/>
+                      <a:round/>
+                      <a:headEnd type="none" w="med" len="med"/>
+                      <a:tailEnd type="none" w="med" len="med"/>
+                    </a:lnR>
+                    <a:lnT w="12700" cap="flat" cmpd="sng" algn="ctr">
+                      <a:solidFill>
+                        <a:schemeClr val="tx1"/>
+                      </a:solidFill>
+                      <a:prstDash val="solid"/>
+                      <a:round/>
+                      <a:headEnd type="none" w="med" len="med"/>
+                      <a:tailEnd type="none" w="med" len="med"/>
+                    </a:lnT>
+                    <a:lnB w="12700" cap="flat" cmpd="sng" algn="ctr">
+                      <a:solidFill>
+                        <a:schemeClr val="tx1"/>
+                      </a:solidFill>
+                      <a:prstDash val="solid"/>
+                      <a:round/>
+                      <a:headEnd type="none" w="med" len="med"/>
+                      <a:tailEnd type="none" w="med" len="med"/>
+                    </a:lnB>
+                    <a:solidFill>
+                      <a:schemeClr val="bg1"/>
+                    </a:solidFill>
+                  </a:tcPr>
+                </a:tc>
+                <a:tc>
+                  <a:txBody>
+                    <a:bodyPr/>
+                    <a:lstStyle/>
+                    <a:p>
+                      <a:pPr marL="0" marR="0" lvl="0" indent="0" algn="l" defTabSz="914400" rtl="0" eaLnBrk="1" fontAlgn="auto" latinLnBrk="0" hangingPunct="1">
+                        <a:lnSpc>
+                          <a:spcPct val="100000"/>
+                        </a:lnSpc>
+                        <a:spcBef>
+                          <a:spcPts val="0"/>
+                        </a:spcBef>
+                        <a:spcAft>
+                          <a:spcPts val="0"/>
+                        </a:spcAft>
+                        <a:buClrTx/>
+                        <a:buSzTx/>
+                        <a:buFontTx/>
+                        <a:buNone/>
+                        <a:tabLst/>
+                        <a:defRPr/>
+                      </a:pPr>
+                      <a:r>
+                        <a:rPr kumimoji="1" lang="en-US" altLang="ja-JP" sz="1000">
+                          <a:latin typeface="Cascadia Mono" panose="020B0609020000020004" pitchFamily="49" charset="0"/>
+                          <a:ea typeface="Cascadia Mono" panose="020B0609020000020004" pitchFamily="49" charset="0"/>
+                          <a:cs typeface="Cascadia Mono" panose="020B0609020000020004" pitchFamily="49" charset="0"/>
+                        </a:rPr>
+                        <a:t>llmj-rubric-review.py</a:t>
+                      </a:r>
+                      <a:endParaRPr kumimoji="1" lang="ja-JP" altLang="en-US" sz="1000">
+                        <a:latin typeface="Cascadia Mono" panose="020B0609020000020004" pitchFamily="49" charset="0"/>
+                        <a:ea typeface="BIZ UDゴシック" panose="020B0400000000000000" pitchFamily="49" charset="-128"/>
+                        <a:cs typeface="Cascadia Mono" panose="020B0609020000020004" pitchFamily="49" charset="0"/>
+                      </a:endParaRPr>
+                    </a:p>
+                  </a:txBody>
+                  <a:tcPr marL="137160" marR="137160" marT="137160" marB="137160">
+                    <a:lnL w="12700" cap="flat" cmpd="sng" algn="ctr">
+                      <a:solidFill>
+                        <a:schemeClr val="tx1"/>
+                      </a:solidFill>
+                      <a:prstDash val="solid"/>
+                      <a:round/>
+                      <a:headEnd type="none" w="med" len="med"/>
+                      <a:tailEnd type="none" w="med" len="med"/>
+                    </a:lnL>
+                    <a:lnR w="12700" cap="flat" cmpd="sng" algn="ctr">
+                      <a:solidFill>
+                        <a:schemeClr val="tx1"/>
+                      </a:solidFill>
+                      <a:prstDash val="solid"/>
+                      <a:round/>
+                      <a:headEnd type="none" w="med" len="med"/>
+                      <a:tailEnd type="none" w="med" len="med"/>
+                    </a:lnR>
+                    <a:lnT w="12700" cap="flat" cmpd="sng" algn="ctr">
+                      <a:solidFill>
+                        <a:schemeClr val="tx1"/>
+                      </a:solidFill>
+                      <a:prstDash val="solid"/>
+                      <a:round/>
+                      <a:headEnd type="none" w="med" len="med"/>
+                      <a:tailEnd type="none" w="med" len="med"/>
+                    </a:lnT>
+                    <a:lnB w="12700" cap="flat" cmpd="sng" algn="ctr">
+                      <a:solidFill>
+                        <a:schemeClr val="tx1"/>
+                      </a:solidFill>
+                      <a:prstDash val="solid"/>
+                      <a:round/>
+                      <a:headEnd type="none" w="med" len="med"/>
+                      <a:tailEnd type="none" w="med" len="med"/>
+                    </a:lnB>
+                    <a:solidFill>
+                      <a:schemeClr val="bg1"/>
+                    </a:solidFill>
+                  </a:tcPr>
+                </a:tc>
+                <a:tc>
+                  <a:txBody>
+                    <a:bodyPr/>
+                    <a:lstStyle/>
+                    <a:p>
+                      <a:pPr marL="0" marR="0" lvl="0" indent="0" algn="l" defTabSz="914400" rtl="0" eaLnBrk="1" fontAlgn="auto" latinLnBrk="0" hangingPunct="1">
+                        <a:lnSpc>
+                          <a:spcPct val="100000"/>
+                        </a:lnSpc>
+                        <a:spcBef>
+                          <a:spcPts val="0"/>
+                        </a:spcBef>
+                        <a:spcAft>
+                          <a:spcPts val="0"/>
+                        </a:spcAft>
+                        <a:buClrTx/>
+                        <a:buSzTx/>
+                        <a:buFontTx/>
+                        <a:buNone/>
+                        <a:tabLst/>
+                        <a:defRPr/>
+                      </a:pPr>
+                      <a:r>
+                        <a:rPr kumimoji="1" lang="en-US" altLang="ja-JP" sz="1000">
+                          <a:latin typeface="Cascadia Mono" panose="020B0609020000020004" pitchFamily="49" charset="0"/>
+                          <a:ea typeface="Cascadia Mono" panose="020B0609020000020004" pitchFamily="49" charset="0"/>
+                          <a:cs typeface="Cascadia Mono" panose="020B0609020000020004" pitchFamily="49" charset="0"/>
+                        </a:rPr>
+                        <a:t>This SCRIPT provides improvement suggestions for the </a:t>
+                      </a:r>
+                      <a:r>
+                        <a:rPr kumimoji="1" lang="en-US" altLang="ja-JP" sz="1000" b="1" i="1">
+                          <a:solidFill>
+                            <a:srgbClr val="FF0000"/>
+                          </a:solidFill>
+                          <a:latin typeface="Cascadia Mono" panose="020B0609020000020004" pitchFamily="49" charset="0"/>
+                          <a:ea typeface="Cascadia Mono" panose="020B0609020000020004" pitchFamily="49" charset="0"/>
+                          <a:cs typeface="Cascadia Mono" panose="020B0609020000020004" pitchFamily="49" charset="0"/>
+                        </a:rPr>
+                        <a:t>rubric/*.criteria.txt</a:t>
+                      </a:r>
+                      <a:r>
+                        <a:rPr kumimoji="1" lang="en-US" altLang="ja-JP" sz="1000">
+                          <a:latin typeface="Cascadia Mono" panose="020B0609020000020004" pitchFamily="49" charset="0"/>
+                          <a:ea typeface="Cascadia Mono" panose="020B0609020000020004" pitchFamily="49" charset="0"/>
+                          <a:cs typeface="Cascadia Mono" panose="020B0609020000020004" pitchFamily="49" charset="0"/>
+                        </a:rPr>
+                        <a:t> or for specific gold data in </a:t>
+                      </a:r>
+                      <a:r>
+                        <a:rPr kumimoji="1" lang="en-US" altLang="ja-JP" sz="1000" b="1" i="1">
+                          <a:solidFill>
+                            <a:srgbClr val="FF0000"/>
+                          </a:solidFill>
+                          <a:latin typeface="Cascadia Mono" panose="020B0609020000020004" pitchFamily="49" charset="0"/>
+                          <a:ea typeface="Cascadia Mono" panose="020B0609020000020004" pitchFamily="49" charset="0"/>
+                          <a:cs typeface="Cascadia Mono" panose="020B0609020000020004" pitchFamily="49" charset="0"/>
+                        </a:rPr>
+                        <a:t>work/*.work.xlsx </a:t>
+                      </a:r>
+                      <a:r>
+                        <a:rPr kumimoji="1" lang="en-US" altLang="ja-JP" sz="1000">
+                          <a:latin typeface="Cascadia Mono" panose="020B0609020000020004" pitchFamily="49" charset="0"/>
+                          <a:ea typeface="Cascadia Mono" panose="020B0609020000020004" pitchFamily="49" charset="0"/>
+                          <a:cs typeface="Cascadia Mono" panose="020B0609020000020004" pitchFamily="49" charset="0"/>
+                        </a:rPr>
+                        <a:t>based on the evaluation results of the gold data.</a:t>
+                      </a:r>
+                    </a:p>
+                  </a:txBody>
+                  <a:tcPr marL="137160" marR="137160" marT="137160" marB="137160">
+                    <a:lnL w="12700" cap="flat" cmpd="sng" algn="ctr">
+                      <a:solidFill>
+                        <a:schemeClr val="tx1"/>
+                      </a:solidFill>
+                      <a:prstDash val="solid"/>
+                      <a:round/>
+                      <a:headEnd type="none" w="med" len="med"/>
+                      <a:tailEnd type="none" w="med" len="med"/>
+                    </a:lnL>
+                    <a:lnR w="12700" cap="flat" cmpd="sng" algn="ctr">
+                      <a:solidFill>
+                        <a:schemeClr val="tx1"/>
+                      </a:solidFill>
+                      <a:prstDash val="solid"/>
+                      <a:round/>
+                      <a:headEnd type="none" w="med" len="med"/>
+                      <a:tailEnd type="none" w="med" len="med"/>
+                    </a:lnR>
+                    <a:lnT w="12700" cap="flat" cmpd="sng" algn="ctr">
+                      <a:solidFill>
+                        <a:schemeClr val="tx1"/>
+                      </a:solidFill>
+                      <a:prstDash val="solid"/>
+                      <a:round/>
+                      <a:headEnd type="none" w="med" len="med"/>
+                      <a:tailEnd type="none" w="med" len="med"/>
+                    </a:lnT>
+                    <a:lnB w="12700" cap="flat" cmpd="sng" algn="ctr">
+                      <a:solidFill>
+                        <a:schemeClr val="tx1"/>
+                      </a:solidFill>
+                      <a:prstDash val="solid"/>
+                      <a:round/>
+                      <a:headEnd type="none" w="med" len="med"/>
+                      <a:tailEnd type="none" w="med" len="med"/>
+                    </a:lnB>
+                    <a:solidFill>
+                      <a:schemeClr val="bg1"/>
+                    </a:solidFill>
+                  </a:tcPr>
+                </a:tc>
+                <a:extLst>
+                  <a:ext uri="{0D108BD9-81ED-4DB2-BD59-A6C34878D82A}">
+                    <a16:rowId xmlns:a16="http://schemas.microsoft.com/office/drawing/2014/main" val="65308053"/>
+                  </a:ext>
+                </a:extLst>
+              </a:tr>
+              <a:tr h="437987">
+                <a:tc>
+                  <a:txBody>
+                    <a:bodyPr/>
+                    <a:lstStyle/>
+                    <a:p>
+                      <a:pPr marL="0" marR="0" lvl="0" indent="0" algn="l" defTabSz="914400" rtl="0" eaLnBrk="1" fontAlgn="auto" latinLnBrk="0" hangingPunct="1">
+                        <a:lnSpc>
+                          <a:spcPct val="100000"/>
+                        </a:lnSpc>
+                        <a:spcBef>
+                          <a:spcPts val="0"/>
+                        </a:spcBef>
+                        <a:spcAft>
+                          <a:spcPts val="0"/>
+                        </a:spcAft>
+                        <a:buClrTx/>
+                        <a:buSzTx/>
+                        <a:buFontTx/>
+                        <a:buNone/>
+                        <a:tabLst/>
+                        <a:defRPr/>
+                      </a:pPr>
+                      <a:r>
+                        <a:rPr kumimoji="1" lang="en-US" altLang="ja-JP" sz="1000">
+                          <a:latin typeface="Cascadia Mono" panose="020B0609020000020004" pitchFamily="49" charset="0"/>
+                          <a:ea typeface="Cascadia Mono" panose="020B0609020000020004" pitchFamily="49" charset="0"/>
+                          <a:cs typeface="Cascadia Mono" panose="020B0609020000020004" pitchFamily="49" charset="0"/>
+                        </a:rPr>
+                        <a:t>supports/</a:t>
+                      </a:r>
+                      <a:endParaRPr kumimoji="1" lang="ja-JP" altLang="en-US" sz="1000">
+                        <a:latin typeface="Cascadia Mono" panose="020B0609020000020004" pitchFamily="49" charset="0"/>
+                        <a:ea typeface="BIZ UDゴシック" panose="020B0400000000000000" pitchFamily="49" charset="-128"/>
+                        <a:cs typeface="Cascadia Mono" panose="020B0609020000020004" pitchFamily="49" charset="0"/>
+                      </a:endParaRPr>
+                    </a:p>
+                  </a:txBody>
+                  <a:tcPr marL="137160" marR="137160" marT="137160" marB="137160">
+                    <a:lnL w="12700" cap="flat" cmpd="sng" algn="ctr">
+                      <a:solidFill>
+                        <a:schemeClr val="tx1"/>
+                      </a:solidFill>
+                      <a:prstDash val="solid"/>
+                      <a:round/>
+                      <a:headEnd type="none" w="med" len="med"/>
+                      <a:tailEnd type="none" w="med" len="med"/>
+                    </a:lnL>
+                    <a:lnR w="12700" cap="flat" cmpd="sng" algn="ctr">
+                      <a:solidFill>
+                        <a:schemeClr val="tx1"/>
+                      </a:solidFill>
+                      <a:prstDash val="solid"/>
+                      <a:round/>
+                      <a:headEnd type="none" w="med" len="med"/>
+                      <a:tailEnd type="none" w="med" len="med"/>
+                    </a:lnR>
+                    <a:lnT w="12700" cap="flat" cmpd="sng" algn="ctr">
+                      <a:solidFill>
+                        <a:schemeClr val="tx1"/>
+                      </a:solidFill>
+                      <a:prstDash val="solid"/>
+                      <a:round/>
+                      <a:headEnd type="none" w="med" len="med"/>
+                      <a:tailEnd type="none" w="med" len="med"/>
+                    </a:lnT>
+                    <a:lnB w="12700" cap="flat" cmpd="sng" algn="ctr">
+                      <a:solidFill>
+                        <a:schemeClr val="tx1"/>
+                      </a:solidFill>
+                      <a:prstDash val="solid"/>
+                      <a:round/>
+                      <a:headEnd type="none" w="med" len="med"/>
+                      <a:tailEnd type="none" w="med" len="med"/>
+                    </a:lnB>
+                    <a:solidFill>
+                      <a:schemeClr val="bg1"/>
+                    </a:solidFill>
+                  </a:tcPr>
+                </a:tc>
+                <a:tc>
+                  <a:txBody>
+                    <a:bodyPr/>
+                    <a:lstStyle/>
+                    <a:p>
+                      <a:pPr marL="0" marR="0" lvl="0" indent="0" algn="l" defTabSz="914400" rtl="0" eaLnBrk="1" fontAlgn="auto" latinLnBrk="0" hangingPunct="1">
+                        <a:lnSpc>
+                          <a:spcPct val="100000"/>
+                        </a:lnSpc>
+                        <a:spcBef>
+                          <a:spcPts val="0"/>
+                        </a:spcBef>
+                        <a:spcAft>
+                          <a:spcPts val="0"/>
+                        </a:spcAft>
+                        <a:buClrTx/>
+                        <a:buSzTx/>
+                        <a:buFontTx/>
+                        <a:buNone/>
+                        <a:tabLst/>
+                        <a:defRPr/>
+                      </a:pPr>
+                      <a:r>
+                        <a:rPr kumimoji="1" lang="en-US" altLang="ja-JP" sz="1000">
+                          <a:latin typeface="Cascadia Mono" panose="020B0609020000020004" pitchFamily="49" charset="0"/>
+                          <a:ea typeface="Cascadia Mono" panose="020B0609020000020004" pitchFamily="49" charset="0"/>
+                          <a:cs typeface="Cascadia Mono" panose="020B0609020000020004" pitchFamily="49" charset="0"/>
+                        </a:rPr>
+                        <a:t>template-*</a:t>
+                      </a:r>
+                      <a:endParaRPr kumimoji="1" lang="ja-JP" altLang="en-US" sz="1000">
+                        <a:latin typeface="Cascadia Mono" panose="020B0609020000020004" pitchFamily="49" charset="0"/>
+                        <a:ea typeface="BIZ UDゴシック" panose="020B0400000000000000" pitchFamily="49" charset="-128"/>
+                        <a:cs typeface="Cascadia Mono" panose="020B0609020000020004" pitchFamily="49" charset="0"/>
+                      </a:endParaRPr>
+                    </a:p>
+                  </a:txBody>
+                  <a:tcPr marL="137160" marR="137160" marT="137160" marB="137160">
+                    <a:lnL w="12700" cap="flat" cmpd="sng" algn="ctr">
+                      <a:solidFill>
+                        <a:schemeClr val="tx1"/>
+                      </a:solidFill>
+                      <a:prstDash val="solid"/>
+                      <a:round/>
+                      <a:headEnd type="none" w="med" len="med"/>
+                      <a:tailEnd type="none" w="med" len="med"/>
+                    </a:lnL>
+                    <a:lnR w="12700" cap="flat" cmpd="sng" algn="ctr">
+                      <a:solidFill>
+                        <a:schemeClr val="tx1"/>
+                      </a:solidFill>
+                      <a:prstDash val="solid"/>
+                      <a:round/>
+                      <a:headEnd type="none" w="med" len="med"/>
+                      <a:tailEnd type="none" w="med" len="med"/>
+                    </a:lnR>
+                    <a:lnT w="12700" cap="flat" cmpd="sng" algn="ctr">
+                      <a:solidFill>
+                        <a:schemeClr val="tx1"/>
+                      </a:solidFill>
+                      <a:prstDash val="solid"/>
+                      <a:round/>
+                      <a:headEnd type="none" w="med" len="med"/>
+                      <a:tailEnd type="none" w="med" len="med"/>
+                    </a:lnT>
+                    <a:lnB w="12700" cap="flat" cmpd="sng" algn="ctr">
+                      <a:solidFill>
+                        <a:schemeClr val="tx1"/>
+                      </a:solidFill>
+                      <a:prstDash val="solid"/>
+                      <a:round/>
+                      <a:headEnd type="none" w="med" len="med"/>
+                      <a:tailEnd type="none" w="med" len="med"/>
+                    </a:lnB>
+                    <a:solidFill>
+                      <a:schemeClr val="bg1"/>
+                    </a:solidFill>
+                  </a:tcPr>
+                </a:tc>
+                <a:tc>
+                  <a:txBody>
+                    <a:bodyPr/>
+                    <a:lstStyle/>
+                    <a:p>
+                      <a:r>
+                        <a:rPr kumimoji="1" lang="en-US" altLang="ja-JP" sz="1000">
+                          <a:latin typeface="Cascadia Mono" panose="020B0609020000020004" pitchFamily="49" charset="0"/>
+                          <a:ea typeface="Cascadia Mono" panose="020B0609020000020004" pitchFamily="49" charset="0"/>
+                          <a:cs typeface="Cascadia Mono" panose="020B0609020000020004" pitchFamily="49" charset="0"/>
+                        </a:rPr>
+                        <a:t>These templates are used by </a:t>
+                      </a:r>
+                      <a:r>
+                        <a:rPr kumimoji="1" lang="en-US" altLang="ja-JP" sz="1000" b="1" i="1">
+                          <a:solidFill>
+                            <a:srgbClr val="FF0000"/>
+                          </a:solidFill>
+                          <a:latin typeface="Cascadia Mono" panose="020B0609020000020004" pitchFamily="49" charset="0"/>
+                          <a:ea typeface="Cascadia Mono" panose="020B0609020000020004" pitchFamily="49" charset="0"/>
+                          <a:cs typeface="Cascadia Mono" panose="020B0609020000020004" pitchFamily="49" charset="0"/>
+                        </a:rPr>
+                        <a:t>*.py</a:t>
+                      </a:r>
+                      <a:r>
+                        <a:rPr kumimoji="1" lang="en-US" altLang="ja-JP" sz="1000">
+                          <a:latin typeface="Cascadia Mono" panose="020B0609020000020004" pitchFamily="49" charset="0"/>
+                          <a:ea typeface="Cascadia Mono" panose="020B0609020000020004" pitchFamily="49" charset="0"/>
+                          <a:cs typeface="Cascadia Mono" panose="020B0609020000020004" pitchFamily="49" charset="0"/>
+                        </a:rPr>
+                        <a:t> scripts.</a:t>
+                      </a:r>
+                    </a:p>
+                  </a:txBody>
+                  <a:tcPr marL="137160" marR="137160" marT="137160" marB="137160">
+                    <a:lnL w="12700" cap="flat" cmpd="sng" algn="ctr">
+                      <a:solidFill>
+                        <a:schemeClr val="tx1"/>
+                      </a:solidFill>
+                      <a:prstDash val="solid"/>
+                      <a:round/>
+                      <a:headEnd type="none" w="med" len="med"/>
+                      <a:tailEnd type="none" w="med" len="med"/>
+                    </a:lnL>
+                    <a:lnR w="12700" cap="flat" cmpd="sng" algn="ctr">
+                      <a:solidFill>
+                        <a:schemeClr val="tx1"/>
+                      </a:solidFill>
+                      <a:prstDash val="solid"/>
+                      <a:round/>
+                      <a:headEnd type="none" w="med" len="med"/>
+                      <a:tailEnd type="none" w="med" len="med"/>
+                    </a:lnR>
+                    <a:lnT w="12700" cap="flat" cmpd="sng" algn="ctr">
+                      <a:solidFill>
+                        <a:schemeClr val="tx1"/>
+                      </a:solidFill>
+                      <a:prstDash val="solid"/>
+                      <a:round/>
+                      <a:headEnd type="none" w="med" len="med"/>
+                      <a:tailEnd type="none" w="med" len="med"/>
+                    </a:lnT>
+                    <a:lnB w="12700" cap="flat" cmpd="sng" algn="ctr">
+                      <a:solidFill>
+                        <a:schemeClr val="tx1"/>
+                      </a:solidFill>
+                      <a:prstDash val="solid"/>
+                      <a:round/>
+                      <a:headEnd type="none" w="med" len="med"/>
+                      <a:tailEnd type="none" w="med" len="med"/>
+                    </a:lnB>
+                    <a:solidFill>
+                      <a:schemeClr val="bg1"/>
+                    </a:solidFill>
+                  </a:tcPr>
+                </a:tc>
+                <a:extLst>
+                  <a:ext uri="{0D108BD9-81ED-4DB2-BD59-A6C34878D82A}">
+                    <a16:rowId xmlns:a16="http://schemas.microsoft.com/office/drawing/2014/main" val="1259418972"/>
+                  </a:ext>
+                </a:extLst>
+              </a:tr>
+              <a:tr h="437987">
+                <a:tc>
+                  <a:txBody>
+                    <a:bodyPr/>
+                    <a:lstStyle/>
+                    <a:p>
+                      <a:r>
+                        <a:rPr kumimoji="1" lang="en-US" altLang="ja-JP" sz="1000">
+                          <a:latin typeface="Cascadia Mono" panose="020B0609020000020004" pitchFamily="49" charset="0"/>
+                          <a:ea typeface="Cascadia Mono" panose="020B0609020000020004" pitchFamily="49" charset="0"/>
+                          <a:cs typeface="Cascadia Mono" panose="020B0609020000020004" pitchFamily="49" charset="0"/>
+                        </a:rPr>
+                        <a:t>work/</a:t>
+                      </a:r>
+                      <a:endParaRPr kumimoji="1" lang="ja-JP" altLang="en-US" sz="1000">
+                        <a:latin typeface="Cascadia Mono" panose="020B0609020000020004" pitchFamily="49" charset="0"/>
+                        <a:ea typeface="BIZ UDゴシック" panose="020B0400000000000000" pitchFamily="49" charset="-128"/>
+                        <a:cs typeface="Cascadia Mono" panose="020B0609020000020004" pitchFamily="49" charset="0"/>
+                      </a:endParaRPr>
+                    </a:p>
+                  </a:txBody>
+                  <a:tcPr marL="137160" marR="137160" marT="137160" marB="137160">
+                    <a:lnL w="12700" cap="flat" cmpd="sng" algn="ctr">
+                      <a:solidFill>
+                        <a:schemeClr val="tx1"/>
+                      </a:solidFill>
+                      <a:prstDash val="solid"/>
+                      <a:round/>
+                      <a:headEnd type="none" w="med" len="med"/>
+                      <a:tailEnd type="none" w="med" len="med"/>
+                    </a:lnL>
+                    <a:lnR w="12700" cap="flat" cmpd="sng" algn="ctr">
+                      <a:solidFill>
+                        <a:schemeClr val="tx1"/>
+                      </a:solidFill>
+                      <a:prstDash val="solid"/>
+                      <a:round/>
+                      <a:headEnd type="none" w="med" len="med"/>
+                      <a:tailEnd type="none" w="med" len="med"/>
+                    </a:lnR>
+                    <a:lnT w="12700" cap="flat" cmpd="sng" algn="ctr">
+                      <a:solidFill>
+                        <a:schemeClr val="tx1"/>
+                      </a:solidFill>
+                      <a:prstDash val="solid"/>
+                      <a:round/>
+                      <a:headEnd type="none" w="med" len="med"/>
+                      <a:tailEnd type="none" w="med" len="med"/>
+                    </a:lnT>
+                    <a:lnB w="12700" cap="flat" cmpd="sng" algn="ctr">
+                      <a:solidFill>
+                        <a:schemeClr val="tx1"/>
+                      </a:solidFill>
+                      <a:prstDash val="solid"/>
+                      <a:round/>
+                      <a:headEnd type="none" w="med" len="med"/>
+                      <a:tailEnd type="none" w="med" len="med"/>
+                    </a:lnB>
+                    <a:solidFill>
+                      <a:schemeClr val="bg1"/>
+                    </a:solidFill>
+                  </a:tcPr>
+                </a:tc>
+                <a:tc>
+                  <a:txBody>
+                    <a:bodyPr/>
+                    <a:lstStyle/>
+                    <a:p>
+                      <a:r>
+                        <a:rPr kumimoji="1" lang="en-US" altLang="ja-JP" sz="1000">
+                          <a:latin typeface="Cascadia Mono" panose="020B0609020000020004" pitchFamily="49" charset="0"/>
+                          <a:ea typeface="Cascadia Mono" panose="020B0609020000020004" pitchFamily="49" charset="0"/>
+                          <a:cs typeface="Cascadia Mono" panose="020B0609020000020004" pitchFamily="49" charset="0"/>
+                        </a:rPr>
+                        <a:t>*</a:t>
+                      </a:r>
+                      <a:endParaRPr kumimoji="1" lang="ja-JP" altLang="en-US" sz="1000">
+                        <a:latin typeface="Cascadia Mono" panose="020B0609020000020004" pitchFamily="49" charset="0"/>
+                        <a:ea typeface="BIZ UDゴシック" panose="020B0400000000000000" pitchFamily="49" charset="-128"/>
+                        <a:cs typeface="Cascadia Mono" panose="020B0609020000020004" pitchFamily="49" charset="0"/>
+                      </a:endParaRPr>
+                    </a:p>
+                  </a:txBody>
+                  <a:tcPr marL="137160" marR="137160" marT="137160" marB="137160">
+                    <a:lnL w="12700" cap="flat" cmpd="sng" algn="ctr">
+                      <a:solidFill>
+                        <a:schemeClr val="tx1"/>
+                      </a:solidFill>
+                      <a:prstDash val="solid"/>
+                      <a:round/>
+                      <a:headEnd type="none" w="med" len="med"/>
+                      <a:tailEnd type="none" w="med" len="med"/>
+                    </a:lnL>
+                    <a:lnR w="12700" cap="flat" cmpd="sng" algn="ctr">
+                      <a:solidFill>
+                        <a:schemeClr val="tx1"/>
+                      </a:solidFill>
+                      <a:prstDash val="solid"/>
+                      <a:round/>
+                      <a:headEnd type="none" w="med" len="med"/>
+                      <a:tailEnd type="none" w="med" len="med"/>
+                    </a:lnR>
+                    <a:lnT w="12700" cap="flat" cmpd="sng" algn="ctr">
+                      <a:solidFill>
+                        <a:schemeClr val="tx1"/>
+                      </a:solidFill>
+                      <a:prstDash val="solid"/>
+                      <a:round/>
+                      <a:headEnd type="none" w="med" len="med"/>
+                      <a:tailEnd type="none" w="med" len="med"/>
+                    </a:lnT>
+                    <a:lnB w="12700" cap="flat" cmpd="sng" algn="ctr">
+                      <a:solidFill>
+                        <a:schemeClr val="tx1"/>
+                      </a:solidFill>
+                      <a:prstDash val="solid"/>
+                      <a:round/>
+                      <a:headEnd type="none" w="med" len="med"/>
+                      <a:tailEnd type="none" w="med" len="med"/>
+                    </a:lnB>
+                    <a:solidFill>
+                      <a:schemeClr val="bg1"/>
+                    </a:solidFill>
+                  </a:tcPr>
+                </a:tc>
+                <a:tc>
+                  <a:txBody>
+                    <a:bodyPr/>
+                    <a:lstStyle/>
+                    <a:p>
+                      <a:r>
+                        <a:rPr kumimoji="1" lang="en-US" altLang="ja-JP" sz="1000">
+                          <a:latin typeface="Cascadia Mono" panose="020B0609020000020004" pitchFamily="49" charset="0"/>
+                          <a:ea typeface="Cascadia Mono" panose="020B0609020000020004" pitchFamily="49" charset="0"/>
+                          <a:cs typeface="Cascadia Mono" panose="020B0609020000020004" pitchFamily="49" charset="0"/>
+                        </a:rPr>
+                        <a:t>This directory contains generated outputs such as </a:t>
+                      </a:r>
+                      <a:r>
+                        <a:rPr kumimoji="1" lang="en-US" altLang="ja-JP" sz="1000" b="1" i="1">
+                          <a:solidFill>
+                            <a:srgbClr val="FF0000"/>
+                          </a:solidFill>
+                          <a:latin typeface="Cascadia Mono" panose="020B0609020000020004" pitchFamily="49" charset="0"/>
+                          <a:ea typeface="Cascadia Mono" panose="020B0609020000020004" pitchFamily="49" charset="0"/>
+                          <a:cs typeface="Cascadia Mono" panose="020B0609020000020004" pitchFamily="49" charset="0"/>
+                        </a:rPr>
+                        <a:t>*.txt</a:t>
+                      </a:r>
+                      <a:r>
+                        <a:rPr kumimoji="1" lang="en-US" altLang="ja-JP" sz="1000">
+                          <a:latin typeface="Cascadia Mono" panose="020B0609020000020004" pitchFamily="49" charset="0"/>
+                          <a:ea typeface="Cascadia Mono" panose="020B0609020000020004" pitchFamily="49" charset="0"/>
+                          <a:cs typeface="Cascadia Mono" panose="020B0609020000020004" pitchFamily="49" charset="0"/>
+                        </a:rPr>
+                        <a:t>, </a:t>
+                      </a:r>
+                      <a:r>
+                        <a:rPr kumimoji="1" lang="en-US" altLang="ja-JP" sz="1000" b="1" i="1">
+                          <a:solidFill>
+                            <a:srgbClr val="FF0000"/>
+                          </a:solidFill>
+                          <a:latin typeface="Cascadia Mono" panose="020B0609020000020004" pitchFamily="49" charset="0"/>
+                          <a:ea typeface="Cascadia Mono" panose="020B0609020000020004" pitchFamily="49" charset="0"/>
+                          <a:cs typeface="Cascadia Mono" panose="020B0609020000020004" pitchFamily="49" charset="0"/>
+                        </a:rPr>
+                        <a:t>*.work.xlsx</a:t>
+                      </a:r>
+                      <a:r>
+                        <a:rPr kumimoji="1" lang="en-US" altLang="ja-JP" sz="1000">
+                          <a:latin typeface="Cascadia Mono" panose="020B0609020000020004" pitchFamily="49" charset="0"/>
+                          <a:ea typeface="Cascadia Mono" panose="020B0609020000020004" pitchFamily="49" charset="0"/>
+                          <a:cs typeface="Cascadia Mono" panose="020B0609020000020004" pitchFamily="49" charset="0"/>
+                        </a:rPr>
+                        <a:t>, and </a:t>
+                      </a:r>
+                      <a:r>
+                        <a:rPr kumimoji="1" lang="en-US" altLang="ja-JP" sz="1000" b="1" i="1">
+                          <a:solidFill>
+                            <a:srgbClr val="FF0000"/>
+                          </a:solidFill>
+                          <a:latin typeface="Cascadia Mono" panose="020B0609020000020004" pitchFamily="49" charset="0"/>
+                          <a:ea typeface="Cascadia Mono" panose="020B0609020000020004" pitchFamily="49" charset="0"/>
+                          <a:cs typeface="Cascadia Mono" panose="020B0609020000020004" pitchFamily="49" charset="0"/>
+                        </a:rPr>
+                        <a:t>report.html</a:t>
+                      </a:r>
+                      <a:r>
+                        <a:rPr kumimoji="1" lang="en-US" altLang="ja-JP" sz="1000">
+                          <a:latin typeface="Cascadia Mono" panose="020B0609020000020004" pitchFamily="49" charset="0"/>
+                          <a:ea typeface="Cascadia Mono" panose="020B0609020000020004" pitchFamily="49" charset="0"/>
+                          <a:cs typeface="Cascadia Mono" panose="020B0609020000020004" pitchFamily="49" charset="0"/>
+                        </a:rPr>
+                        <a:t>.</a:t>
+                      </a:r>
+                    </a:p>
+                  </a:txBody>
+                  <a:tcPr marL="137160" marR="137160" marT="137160" marB="137160">
+                    <a:lnL w="12700" cap="flat" cmpd="sng" algn="ctr">
+                      <a:solidFill>
+                        <a:schemeClr val="tx1"/>
+                      </a:solidFill>
+                      <a:prstDash val="solid"/>
+                      <a:round/>
+                      <a:headEnd type="none" w="med" len="med"/>
+                      <a:tailEnd type="none" w="med" len="med"/>
+                    </a:lnL>
+                    <a:lnR w="12700" cap="flat" cmpd="sng" algn="ctr">
+                      <a:solidFill>
+                        <a:schemeClr val="tx1"/>
+                      </a:solidFill>
+                      <a:prstDash val="solid"/>
+                      <a:round/>
+                      <a:headEnd type="none" w="med" len="med"/>
+                      <a:tailEnd type="none" w="med" len="med"/>
+                    </a:lnR>
+                    <a:lnT w="12700" cap="flat" cmpd="sng" algn="ctr">
+                      <a:solidFill>
+                        <a:schemeClr val="tx1"/>
+                      </a:solidFill>
+                      <a:prstDash val="solid"/>
+                      <a:round/>
+                      <a:headEnd type="none" w="med" len="med"/>
+                      <a:tailEnd type="none" w="med" len="med"/>
+                    </a:lnT>
+                    <a:lnB w="12700" cap="flat" cmpd="sng" algn="ctr">
+                      <a:solidFill>
+                        <a:schemeClr val="tx1"/>
+                      </a:solidFill>
+                      <a:prstDash val="solid"/>
+                      <a:round/>
+                      <a:headEnd type="none" w="med" len="med"/>
+                      <a:tailEnd type="none" w="med" len="med"/>
+                    </a:lnB>
+                    <a:solidFill>
+                      <a:schemeClr val="bg1"/>
+                    </a:solidFill>
+                  </a:tcPr>
+                </a:tc>
+                <a:extLst>
+                  <a:ext uri="{0D108BD9-81ED-4DB2-BD59-A6C34878D82A}">
+                    <a16:rowId xmlns:a16="http://schemas.microsoft.com/office/drawing/2014/main" val="3804432217"/>
+                  </a:ext>
+                </a:extLst>
+              </a:tr>
+            </a:tbl>
+          </a:graphicData>
+        </a:graphic>
+      </p:graphicFrame>
+    </p:spTree>
+    <p:extLst>
+      <p:ext uri="{BB962C8B-B14F-4D97-AF65-F5344CB8AC3E}">
+        <p14:creationId xmlns:p14="http://schemas.microsoft.com/office/powerpoint/2010/main" val="2888961243"/>
+      </p:ext>
+    </p:extLst>
+  </p:cSld>
+  <p:clrMapOvr>
+    <a:masterClrMapping/>
+  </p:clrMapOvr>
+</p:sldLayout>
+</file>
+
 <file path=ppt/slideMasters/slideMaster1.xml><?xml version="1.0" encoding="utf-8"?>
 <p:sldMaster xmlns:a="http://schemas.openxmlformats.org/drawingml/2006/main" xmlns:r="http://schemas.openxmlformats.org/officeDocument/2006/relationships" xmlns:p="http://schemas.openxmlformats.org/presentationml/2006/main">
   <p:cSld>
@@ -16750,6 +19958,7 @@
     <p:sldLayoutId id="2147483657" r:id="rId3"/>
     <p:sldLayoutId id="2147483651" r:id="rId4"/>
     <p:sldLayoutId id="2147483652" r:id="rId5"/>
+    <p:sldLayoutId id="2147483658" r:id="rId6"/>
   </p:sldLayoutIdLst>
   <p:txStyles>
     <p:titleStyle>
@@ -17072,7 +20281,7 @@
         <p:cNvPr id="1" name="">
           <a:extLst>
             <a:ext uri="{FF2B5EF4-FFF2-40B4-BE49-F238E27FC236}">
-              <a16:creationId xmlns:a16="http://schemas.microsoft.com/office/drawing/2014/main" id="{DD149B1D-0226-78BC-F63A-E99F13C93A5B}"/>
+              <a16:creationId xmlns:a16="http://schemas.microsoft.com/office/drawing/2014/main" id="{95EFC61F-A9C7-6D93-D8EA-1C6F7367B928}"/>
             </a:ext>
           </a:extLst>
         </p:cNvPr>
@@ -17089,10 +20298,10 @@
       </p:grpSpPr>
       <p:sp>
         <p:nvSpPr>
-          <p:cNvPr id="18" name="フリーフォーム: 図形 17">
+          <p:cNvPr id="12" name="フリーフォーム: 図形 11">
             <a:extLst>
               <a:ext uri="{FF2B5EF4-FFF2-40B4-BE49-F238E27FC236}">
-                <a16:creationId xmlns:a16="http://schemas.microsoft.com/office/drawing/2014/main" id="{38FA1461-DE1D-2EC9-AB51-AC518350623D}"/>
+                <a16:creationId xmlns:a16="http://schemas.microsoft.com/office/drawing/2014/main" id="{C8C4F1CA-8AA7-19F4-A717-64F51061BAA3}"/>
               </a:ext>
             </a:extLst>
           </p:cNvPr>
@@ -17107,38 +20316,46 @@
           <a:custGeom>
             <a:avLst/>
             <a:gdLst>
-              <a:gd name="csX0" fmla="*/ 1231075 w 12192000"/>
-              <a:gd name="csY0" fmla="*/ 3570514 h 6858000"/>
-              <a:gd name="csX1" fmla="*/ 1231075 w 12192000"/>
-              <a:gd name="csY1" fmla="*/ 5147951 h 6858000"/>
-              <a:gd name="csX2" fmla="*/ 1231075 w 12192000"/>
-              <a:gd name="csY2" fmla="*/ 5737760 h 6858000"/>
-              <a:gd name="csX3" fmla="*/ 2284021 w 12192000"/>
-              <a:gd name="csY3" fmla="*/ 5737760 h 6858000"/>
-              <a:gd name="csX4" fmla="*/ 10949049 w 12192000"/>
-              <a:gd name="csY4" fmla="*/ 5737760 h 6858000"/>
-              <a:gd name="csX5" fmla="*/ 10949049 w 12192000"/>
-              <a:gd name="csY5" fmla="*/ 5147951 h 6858000"/>
-              <a:gd name="csX6" fmla="*/ 2284021 w 12192000"/>
-              <a:gd name="csY6" fmla="*/ 5147951 h 6858000"/>
-              <a:gd name="csX7" fmla="*/ 2284021 w 12192000"/>
-              <a:gd name="csY7" fmla="*/ 3570514 h 6858000"/>
-              <a:gd name="csX8" fmla="*/ 1231075 w 12192000"/>
-              <a:gd name="csY8" fmla="*/ 2553194 h 6858000"/>
-              <a:gd name="csX9" fmla="*/ 1231075 w 12192000"/>
-              <a:gd name="csY9" fmla="*/ 3143002 h 6858000"/>
-              <a:gd name="csX10" fmla="*/ 10949049 w 12192000"/>
-              <a:gd name="csY10" fmla="*/ 3143002 h 6858000"/>
-              <a:gd name="csX11" fmla="*/ 10949049 w 12192000"/>
-              <a:gd name="csY11" fmla="*/ 2553194 h 6858000"/>
-              <a:gd name="csX12" fmla="*/ 0 w 12192000"/>
-              <a:gd name="csY12" fmla="*/ 0 h 6858000"/>
-              <a:gd name="csX13" fmla="*/ 12192000 w 12192000"/>
-              <a:gd name="csY13" fmla="*/ 0 h 6858000"/>
-              <a:gd name="csX14" fmla="*/ 12192000 w 12192000"/>
-              <a:gd name="csY14" fmla="*/ 6858000 h 6858000"/>
-              <a:gd name="csX15" fmla="*/ 0 w 12192000"/>
-              <a:gd name="csY15" fmla="*/ 6858000 h 6858000"/>
+              <a:gd name="csX0" fmla="*/ 121920 w 12192000"/>
+              <a:gd name="csY0" fmla="*/ 3788226 h 6858000"/>
+              <a:gd name="csX1" fmla="*/ 121920 w 12192000"/>
+              <a:gd name="csY1" fmla="*/ 5860867 h 6858000"/>
+              <a:gd name="csX2" fmla="*/ 853441 w 12192000"/>
+              <a:gd name="csY2" fmla="*/ 5860867 h 6858000"/>
+              <a:gd name="csX3" fmla="*/ 853441 w 12192000"/>
+              <a:gd name="csY3" fmla="*/ 5860868 h 6858000"/>
+              <a:gd name="csX4" fmla="*/ 12070081 w 12192000"/>
+              <a:gd name="csY4" fmla="*/ 5860868 h 6858000"/>
+              <a:gd name="csX5" fmla="*/ 12070081 w 12192000"/>
+              <a:gd name="csY5" fmla="*/ 5251268 h 6858000"/>
+              <a:gd name="csX6" fmla="*/ 1149531 w 12192000"/>
+              <a:gd name="csY6" fmla="*/ 5251268 h 6858000"/>
+              <a:gd name="csX7" fmla="*/ 1149531 w 12192000"/>
+              <a:gd name="csY7" fmla="*/ 3788226 h 6858000"/>
+              <a:gd name="csX8" fmla="*/ 121919 w 12192000"/>
+              <a:gd name="csY8" fmla="*/ 2464526 h 6858000"/>
+              <a:gd name="csX9" fmla="*/ 121919 w 12192000"/>
+              <a:gd name="csY9" fmla="*/ 3352800 h 6858000"/>
+              <a:gd name="csX10" fmla="*/ 1149530 w 12192000"/>
+              <a:gd name="csY10" fmla="*/ 3352800 h 6858000"/>
+              <a:gd name="csX11" fmla="*/ 1149530 w 12192000"/>
+              <a:gd name="csY11" fmla="*/ 2917371 h 6858000"/>
+              <a:gd name="csX12" fmla="*/ 12070079 w 12192000"/>
+              <a:gd name="csY12" fmla="*/ 2917371 h 6858000"/>
+              <a:gd name="csX13" fmla="*/ 12070079 w 12192000"/>
+              <a:gd name="csY13" fmla="*/ 2464526 h 6858000"/>
+              <a:gd name="csX14" fmla="*/ 1149530 w 12192000"/>
+              <a:gd name="csY14" fmla="*/ 2464526 h 6858000"/>
+              <a:gd name="csX15" fmla="*/ 923108 w 12192000"/>
+              <a:gd name="csY15" fmla="*/ 2464526 h 6858000"/>
+              <a:gd name="csX16" fmla="*/ 0 w 12192000"/>
+              <a:gd name="csY16" fmla="*/ 0 h 6858000"/>
+              <a:gd name="csX17" fmla="*/ 12192000 w 12192000"/>
+              <a:gd name="csY17" fmla="*/ 0 h 6858000"/>
+              <a:gd name="csX18" fmla="*/ 12192000 w 12192000"/>
+              <a:gd name="csY18" fmla="*/ 6858000 h 6858000"/>
+              <a:gd name="csX19" fmla="*/ 0 w 12192000"/>
+              <a:gd name="csY19" fmla="*/ 6858000 h 6858000"/>
             </a:gdLst>
             <a:ahLst/>
             <a:cxnLst>
@@ -17190,46 +20407,70 @@
               <a:cxn ang="0">
                 <a:pos x="csX15" y="csY15"/>
               </a:cxn>
+              <a:cxn ang="0">
+                <a:pos x="csX16" y="csY16"/>
+              </a:cxn>
+              <a:cxn ang="0">
+                <a:pos x="csX17" y="csY17"/>
+              </a:cxn>
+              <a:cxn ang="0">
+                <a:pos x="csX18" y="csY18"/>
+              </a:cxn>
+              <a:cxn ang="0">
+                <a:pos x="csX19" y="csY19"/>
+              </a:cxn>
             </a:cxnLst>
             <a:rect l="l" t="t" r="r" b="b"/>
             <a:pathLst>
               <a:path w="12192000" h="6858000">
                 <a:moveTo>
-                  <a:pt x="1231075" y="3570514"/>
+                  <a:pt x="121920" y="3788226"/>
                 </a:moveTo>
                 <a:lnTo>
-                  <a:pt x="1231075" y="5147951"/>
+                  <a:pt x="121920" y="5860867"/>
                 </a:lnTo>
                 <a:lnTo>
-                  <a:pt x="1231075" y="5737760"/>
+                  <a:pt x="853441" y="5860867"/>
                 </a:lnTo>
                 <a:lnTo>
-                  <a:pt x="2284021" y="5737760"/>
+                  <a:pt x="853441" y="5860868"/>
                 </a:lnTo>
                 <a:lnTo>
-                  <a:pt x="10949049" y="5737760"/>
+                  <a:pt x="12070081" y="5860868"/>
                 </a:lnTo>
                 <a:lnTo>
-                  <a:pt x="10949049" y="5147951"/>
+                  <a:pt x="12070081" y="5251268"/>
                 </a:lnTo>
                 <a:lnTo>
-                  <a:pt x="2284021" y="5147951"/>
+                  <a:pt x="1149531" y="5251268"/>
                 </a:lnTo>
                 <a:lnTo>
-                  <a:pt x="2284021" y="3570514"/>
+                  <a:pt x="1149531" y="3788226"/>
                 </a:lnTo>
                 <a:close/>
                 <a:moveTo>
-                  <a:pt x="1231075" y="2553194"/>
+                  <a:pt x="121919" y="2464526"/>
                 </a:moveTo>
                 <a:lnTo>
-                  <a:pt x="1231075" y="3143002"/>
+                  <a:pt x="121919" y="3352800"/>
                 </a:lnTo>
                 <a:lnTo>
-                  <a:pt x="10949049" y="3143002"/>
+                  <a:pt x="1149530" y="3352800"/>
                 </a:lnTo>
                 <a:lnTo>
-                  <a:pt x="10949049" y="2553194"/>
+                  <a:pt x="1149530" y="2917371"/>
+                </a:lnTo>
+                <a:lnTo>
+                  <a:pt x="12070079" y="2917371"/>
+                </a:lnTo>
+                <a:lnTo>
+                  <a:pt x="12070079" y="2464526"/>
+                </a:lnTo>
+                <a:lnTo>
+                  <a:pt x="1149530" y="2464526"/>
+                </a:lnTo>
+                <a:lnTo>
+                  <a:pt x="923108" y="2464526"/>
                 </a:lnTo>
                 <a:close/>
                 <a:moveTo>
@@ -17287,7 +20528,7 @@
     </p:spTree>
     <p:extLst>
       <p:ext uri="{BB962C8B-B14F-4D97-AF65-F5344CB8AC3E}">
-        <p14:creationId xmlns:p14="http://schemas.microsoft.com/office/powerpoint/2010/main" val="98695772"/>
+        <p14:creationId xmlns:p14="http://schemas.microsoft.com/office/powerpoint/2010/main" val="2058391817"/>
       </p:ext>
     </p:extLst>
   </p:cSld>
@@ -17512,7 +20753,7 @@
         <p:cNvPr id="1" name="">
           <a:extLst>
             <a:ext uri="{FF2B5EF4-FFF2-40B4-BE49-F238E27FC236}">
-              <a16:creationId xmlns:a16="http://schemas.microsoft.com/office/drawing/2014/main" id="{FC744924-6947-8E94-FFA1-FD3D5779D0C6}"/>
+              <a16:creationId xmlns:a16="http://schemas.microsoft.com/office/drawing/2014/main" id="{647F548F-1883-2EE8-E3A9-C2D5094EAB5F}"/>
             </a:ext>
           </a:extLst>
         </p:cNvPr>
@@ -17532,7 +20773,7 @@
           <p:cNvPr id="9" name="フリーフォーム: 図形 8">
             <a:extLst>
               <a:ext uri="{FF2B5EF4-FFF2-40B4-BE49-F238E27FC236}">
-                <a16:creationId xmlns:a16="http://schemas.microsoft.com/office/drawing/2014/main" id="{36AF6CF6-704F-499F-C9C3-C9F96E3DC0AF}"/>
+                <a16:creationId xmlns:a16="http://schemas.microsoft.com/office/drawing/2014/main" id="{D6F9620D-901A-1518-7F22-7EA925F2F25A}"/>
               </a:ext>
             </a:extLst>
           </p:cNvPr>
@@ -17547,22 +20788,22 @@
           <a:custGeom>
             <a:avLst/>
             <a:gdLst>
-              <a:gd name="csX0" fmla="*/ 1231075 w 12192000"/>
-              <a:gd name="csY0" fmla="*/ 3570513 h 6858000"/>
-              <a:gd name="csX1" fmla="*/ 1231075 w 12192000"/>
-              <a:gd name="csY1" fmla="*/ 3570514 h 6858000"/>
-              <a:gd name="csX2" fmla="*/ 1231075 w 12192000"/>
-              <a:gd name="csY2" fmla="*/ 3998026 h 6858000"/>
-              <a:gd name="csX3" fmla="*/ 1231075 w 12192000"/>
-              <a:gd name="csY3" fmla="*/ 5737760 h 6858000"/>
-              <a:gd name="csX4" fmla="*/ 2284021 w 12192000"/>
-              <a:gd name="csY4" fmla="*/ 5737760 h 6858000"/>
-              <a:gd name="csX5" fmla="*/ 2284021 w 12192000"/>
-              <a:gd name="csY5" fmla="*/ 3998026 h 6858000"/>
-              <a:gd name="csX6" fmla="*/ 10949049 w 12192000"/>
-              <a:gd name="csY6" fmla="*/ 3998026 h 6858000"/>
-              <a:gd name="csX7" fmla="*/ 10949049 w 12192000"/>
-              <a:gd name="csY7" fmla="*/ 3570513 h 6858000"/>
+              <a:gd name="csX0" fmla="*/ 775062 w 12192000"/>
+              <a:gd name="csY0" fmla="*/ 3788225 h 6858000"/>
+              <a:gd name="csX1" fmla="*/ 775062 w 12192000"/>
+              <a:gd name="csY1" fmla="*/ 3788226 h 6858000"/>
+              <a:gd name="csX2" fmla="*/ 121919 w 12192000"/>
+              <a:gd name="csY2" fmla="*/ 3788226 h 6858000"/>
+              <a:gd name="csX3" fmla="*/ 121919 w 12192000"/>
+              <a:gd name="csY3" fmla="*/ 5860867 h 6858000"/>
+              <a:gd name="csX4" fmla="*/ 1149530 w 12192000"/>
+              <a:gd name="csY4" fmla="*/ 5860867 h 6858000"/>
+              <a:gd name="csX5" fmla="*/ 1149530 w 12192000"/>
+              <a:gd name="csY5" fmla="*/ 4241070 h 6858000"/>
+              <a:gd name="csX6" fmla="*/ 12070079 w 12192000"/>
+              <a:gd name="csY6" fmla="*/ 4241070 h 6858000"/>
+              <a:gd name="csX7" fmla="*/ 12070079 w 12192000"/>
+              <a:gd name="csY7" fmla="*/ 3788225 h 6858000"/>
               <a:gd name="csX8" fmla="*/ 0 w 12192000"/>
               <a:gd name="csY8" fmla="*/ 0 h 6858000"/>
               <a:gd name="csX9" fmla="*/ 12192000 w 12192000"/>
@@ -17615,28 +20856,28 @@
             <a:pathLst>
               <a:path w="12192000" h="6858000">
                 <a:moveTo>
-                  <a:pt x="1231075" y="3570513"/>
+                  <a:pt x="775062" y="3788225"/>
                 </a:moveTo>
                 <a:lnTo>
-                  <a:pt x="1231075" y="3570514"/>
+                  <a:pt x="775062" y="3788226"/>
                 </a:lnTo>
                 <a:lnTo>
-                  <a:pt x="1231075" y="3998026"/>
+                  <a:pt x="121919" y="3788226"/>
                 </a:lnTo>
                 <a:lnTo>
-                  <a:pt x="1231075" y="5737760"/>
+                  <a:pt x="121919" y="5860867"/>
                 </a:lnTo>
                 <a:lnTo>
-                  <a:pt x="2284021" y="5737760"/>
+                  <a:pt x="1149530" y="5860867"/>
                 </a:lnTo>
                 <a:lnTo>
-                  <a:pt x="2284021" y="3998026"/>
+                  <a:pt x="1149530" y="4241070"/>
                 </a:lnTo>
                 <a:lnTo>
-                  <a:pt x="10949049" y="3998026"/>
+                  <a:pt x="12070079" y="4241070"/>
                 </a:lnTo>
                 <a:lnTo>
-                  <a:pt x="10949049" y="3570513"/>
+                  <a:pt x="12070079" y="3788225"/>
                 </a:lnTo>
                 <a:close/>
                 <a:moveTo>
@@ -17705,7 +20946,7 @@
         </p:nvGrpSpPr>
         <p:grpSpPr>
           <a:xfrm>
-            <a:off x="718434" y="4308089"/>
+            <a:off x="2329520" y="4421300"/>
             <a:ext cx="1614399" cy="722865"/>
             <a:chOff x="2328672" y="1310640"/>
             <a:chExt cx="3267456" cy="1463040"/>
@@ -17757,8 +20998,8 @@
               </a:xfrm>
               <a:prstGeom prst="cloudCallout">
                 <a:avLst>
-                  <a:gd name="adj1" fmla="val 35504"/>
-                  <a:gd name="adj2" fmla="val -95076"/>
+                  <a:gd name="adj1" fmla="val -21667"/>
+                  <a:gd name="adj2" fmla="val -87520"/>
                 </a:avLst>
               </a:prstGeom>
               <a:solidFill>
@@ -18036,7 +21277,7 @@
     </p:spTree>
     <p:extLst>
       <p:ext uri="{BB962C8B-B14F-4D97-AF65-F5344CB8AC3E}">
-        <p14:creationId xmlns:p14="http://schemas.microsoft.com/office/powerpoint/2010/main" val="2276484096"/>
+        <p14:creationId xmlns:p14="http://schemas.microsoft.com/office/powerpoint/2010/main" val="1599584968"/>
       </p:ext>
     </p:extLst>
   </p:cSld>
@@ -18972,7 +22213,7 @@
         <p:cNvPr id="1" name="">
           <a:extLst>
             <a:ext uri="{FF2B5EF4-FFF2-40B4-BE49-F238E27FC236}">
-              <a16:creationId xmlns:a16="http://schemas.microsoft.com/office/drawing/2014/main" id="{5F05E020-9B95-4DE0-C6CF-ADBA6BAF3B2B}"/>
+              <a16:creationId xmlns:a16="http://schemas.microsoft.com/office/drawing/2014/main" id="{EEC940C5-D211-EDA8-BC9F-2642309864E2}"/>
             </a:ext>
           </a:extLst>
         </p:cNvPr>
@@ -18992,7 +22233,7 @@
           <p:cNvPr id="6" name="フリーフォーム: 図形 5">
             <a:extLst>
               <a:ext uri="{FF2B5EF4-FFF2-40B4-BE49-F238E27FC236}">
-                <a16:creationId xmlns:a16="http://schemas.microsoft.com/office/drawing/2014/main" id="{E0BBFBD1-FA64-29D2-675B-C11EE9ECAA96}"/>
+                <a16:creationId xmlns:a16="http://schemas.microsoft.com/office/drawing/2014/main" id="{CBEE2062-6A60-A4A3-906F-F6E3AD54C2C7}"/>
               </a:ext>
             </a:extLst>
           </p:cNvPr>
@@ -19007,14 +22248,14 @@
           <a:custGeom>
             <a:avLst/>
             <a:gdLst>
-              <a:gd name="csX0" fmla="*/ 1231075 w 12192000"/>
-              <a:gd name="csY0" fmla="*/ 1559626 h 6858000"/>
-              <a:gd name="csX1" fmla="*/ 1231075 w 12192000"/>
-              <a:gd name="csY1" fmla="*/ 1975262 h 6858000"/>
-              <a:gd name="csX2" fmla="*/ 10949049 w 12192000"/>
-              <a:gd name="csY2" fmla="*/ 1975262 h 6858000"/>
-              <a:gd name="csX3" fmla="*/ 10949049 w 12192000"/>
-              <a:gd name="csY3" fmla="*/ 1559626 h 6858000"/>
+              <a:gd name="csX0" fmla="*/ 121921 w 12192000"/>
+              <a:gd name="csY0" fmla="*/ 1436911 h 6858000"/>
+              <a:gd name="csX1" fmla="*/ 121921 w 12192000"/>
+              <a:gd name="csY1" fmla="*/ 1889756 h 6858000"/>
+              <a:gd name="csX2" fmla="*/ 12070081 w 12192000"/>
+              <a:gd name="csY2" fmla="*/ 1889756 h 6858000"/>
+              <a:gd name="csX3" fmla="*/ 12070081 w 12192000"/>
+              <a:gd name="csY3" fmla="*/ 1436911 h 6858000"/>
               <a:gd name="csX4" fmla="*/ 0 w 12192000"/>
               <a:gd name="csY4" fmla="*/ 0 h 6858000"/>
               <a:gd name="csX5" fmla="*/ 12192000 w 12192000"/>
@@ -19055,16 +22296,16 @@
             <a:pathLst>
               <a:path w="12192000" h="6858000">
                 <a:moveTo>
-                  <a:pt x="1231075" y="1559626"/>
+                  <a:pt x="121921" y="1436911"/>
                 </a:moveTo>
                 <a:lnTo>
-                  <a:pt x="1231075" y="1975262"/>
+                  <a:pt x="121921" y="1889756"/>
                 </a:lnTo>
                 <a:lnTo>
-                  <a:pt x="10949049" y="1975262"/>
+                  <a:pt x="12070081" y="1889756"/>
                 </a:lnTo>
                 <a:lnTo>
-                  <a:pt x="10949049" y="1559626"/>
+                  <a:pt x="12070081" y="1436911"/>
                 </a:lnTo>
                 <a:close/>
                 <a:moveTo>
@@ -19122,7 +22363,7 @@
     </p:spTree>
     <p:extLst>
       <p:ext uri="{BB962C8B-B14F-4D97-AF65-F5344CB8AC3E}">
-        <p14:creationId xmlns:p14="http://schemas.microsoft.com/office/powerpoint/2010/main" val="134148486"/>
+        <p14:creationId xmlns:p14="http://schemas.microsoft.com/office/powerpoint/2010/main" val="3856971346"/>
       </p:ext>
     </p:extLst>
   </p:cSld>
@@ -19508,7 +22749,7 @@
         <p:cNvPr id="1" name="">
           <a:extLst>
             <a:ext uri="{FF2B5EF4-FFF2-40B4-BE49-F238E27FC236}">
-              <a16:creationId xmlns:a16="http://schemas.microsoft.com/office/drawing/2014/main" id="{E419AA2F-95BE-A431-59E5-BB390BF826D7}"/>
+              <a16:creationId xmlns:a16="http://schemas.microsoft.com/office/drawing/2014/main" id="{A6303580-B9D6-8873-CC92-535586811836}"/>
             </a:ext>
           </a:extLst>
         </p:cNvPr>
@@ -19525,10 +22766,10 @@
       </p:grpSpPr>
       <p:sp>
         <p:nvSpPr>
-          <p:cNvPr id="5" name="フリーフォーム: 図形 4">
+          <p:cNvPr id="10" name="フリーフォーム: 図形 9">
             <a:extLst>
               <a:ext uri="{FF2B5EF4-FFF2-40B4-BE49-F238E27FC236}">
-                <a16:creationId xmlns:a16="http://schemas.microsoft.com/office/drawing/2014/main" id="{959C94B8-7D7B-77A8-3B1F-31784949CD78}"/>
+                <a16:creationId xmlns:a16="http://schemas.microsoft.com/office/drawing/2014/main" id="{6605648E-BDBB-9F90-7AAF-88CF85EEDAFB}"/>
               </a:ext>
             </a:extLst>
           </p:cNvPr>
@@ -19543,22 +22784,38 @@
           <a:custGeom>
             <a:avLst/>
             <a:gdLst>
-              <a:gd name="csX0" fmla="*/ 1231075 w 12192000"/>
-              <a:gd name="csY0" fmla="*/ 1975262 h 6858000"/>
-              <a:gd name="csX1" fmla="*/ 1231075 w 12192000"/>
-              <a:gd name="csY1" fmla="*/ 2549236 h 6858000"/>
-              <a:gd name="csX2" fmla="*/ 10949049 w 12192000"/>
-              <a:gd name="csY2" fmla="*/ 2549236 h 6858000"/>
-              <a:gd name="csX3" fmla="*/ 10949049 w 12192000"/>
-              <a:gd name="csY3" fmla="*/ 1975262 h 6858000"/>
-              <a:gd name="csX4" fmla="*/ 0 w 12192000"/>
-              <a:gd name="csY4" fmla="*/ 0 h 6858000"/>
-              <a:gd name="csX5" fmla="*/ 12192000 w 12192000"/>
-              <a:gd name="csY5" fmla="*/ 0 h 6858000"/>
-              <a:gd name="csX6" fmla="*/ 12192000 w 12192000"/>
-              <a:gd name="csY6" fmla="*/ 6858000 h 6858000"/>
-              <a:gd name="csX7" fmla="*/ 0 w 12192000"/>
-              <a:gd name="csY7" fmla="*/ 6858000 h 6858000"/>
+              <a:gd name="csX0" fmla="*/ 121920 w 12192000"/>
+              <a:gd name="csY0" fmla="*/ 1889760 h 6858000"/>
+              <a:gd name="csX1" fmla="*/ 121920 w 12192000"/>
+              <a:gd name="csY1" fmla="*/ 3352800 h 6858000"/>
+              <a:gd name="csX2" fmla="*/ 809897 w 12192000"/>
+              <a:gd name="csY2" fmla="*/ 3352800 h 6858000"/>
+              <a:gd name="csX3" fmla="*/ 1149531 w 12192000"/>
+              <a:gd name="csY3" fmla="*/ 3352800 h 6858000"/>
+              <a:gd name="csX4" fmla="*/ 12070081 w 12192000"/>
+              <a:gd name="csY4" fmla="*/ 3352800 h 6858000"/>
+              <a:gd name="csX5" fmla="*/ 12070081 w 12192000"/>
+              <a:gd name="csY5" fmla="*/ 2899955 h 6858000"/>
+              <a:gd name="csX6" fmla="*/ 1149531 w 12192000"/>
+              <a:gd name="csY6" fmla="*/ 2899955 h 6858000"/>
+              <a:gd name="csX7" fmla="*/ 1149531 w 12192000"/>
+              <a:gd name="csY7" fmla="*/ 2464521 h 6858000"/>
+              <a:gd name="csX8" fmla="*/ 12070081 w 12192000"/>
+              <a:gd name="csY8" fmla="*/ 2464521 h 6858000"/>
+              <a:gd name="csX9" fmla="*/ 12070081 w 12192000"/>
+              <a:gd name="csY9" fmla="*/ 1889760 h 6858000"/>
+              <a:gd name="csX10" fmla="*/ 1149531 w 12192000"/>
+              <a:gd name="csY10" fmla="*/ 1889760 h 6858000"/>
+              <a:gd name="csX11" fmla="*/ 809897 w 12192000"/>
+              <a:gd name="csY11" fmla="*/ 1889760 h 6858000"/>
+              <a:gd name="csX12" fmla="*/ 0 w 12192000"/>
+              <a:gd name="csY12" fmla="*/ 0 h 6858000"/>
+              <a:gd name="csX13" fmla="*/ 12192000 w 12192000"/>
+              <a:gd name="csY13" fmla="*/ 0 h 6858000"/>
+              <a:gd name="csX14" fmla="*/ 12192000 w 12192000"/>
+              <a:gd name="csY14" fmla="*/ 6858000 h 6858000"/>
+              <a:gd name="csX15" fmla="*/ 0 w 12192000"/>
+              <a:gd name="csY15" fmla="*/ 6858000 h 6858000"/>
             </a:gdLst>
             <a:ahLst/>
             <a:cxnLst>
@@ -19586,21 +22843,69 @@
               <a:cxn ang="0">
                 <a:pos x="csX7" y="csY7"/>
               </a:cxn>
+              <a:cxn ang="0">
+                <a:pos x="csX8" y="csY8"/>
+              </a:cxn>
+              <a:cxn ang="0">
+                <a:pos x="csX9" y="csY9"/>
+              </a:cxn>
+              <a:cxn ang="0">
+                <a:pos x="csX10" y="csY10"/>
+              </a:cxn>
+              <a:cxn ang="0">
+                <a:pos x="csX11" y="csY11"/>
+              </a:cxn>
+              <a:cxn ang="0">
+                <a:pos x="csX12" y="csY12"/>
+              </a:cxn>
+              <a:cxn ang="0">
+                <a:pos x="csX13" y="csY13"/>
+              </a:cxn>
+              <a:cxn ang="0">
+                <a:pos x="csX14" y="csY14"/>
+              </a:cxn>
+              <a:cxn ang="0">
+                <a:pos x="csX15" y="csY15"/>
+              </a:cxn>
             </a:cxnLst>
             <a:rect l="l" t="t" r="r" b="b"/>
             <a:pathLst>
               <a:path w="12192000" h="6858000">
                 <a:moveTo>
-                  <a:pt x="1231075" y="1975262"/>
+                  <a:pt x="121920" y="1889760"/>
                 </a:moveTo>
                 <a:lnTo>
-                  <a:pt x="1231075" y="2549236"/>
+                  <a:pt x="121920" y="3352800"/>
                 </a:lnTo>
                 <a:lnTo>
-                  <a:pt x="10949049" y="2549236"/>
+                  <a:pt x="809897" y="3352800"/>
                 </a:lnTo>
                 <a:lnTo>
-                  <a:pt x="10949049" y="1975262"/>
+                  <a:pt x="1149531" y="3352800"/>
+                </a:lnTo>
+                <a:lnTo>
+                  <a:pt x="12070081" y="3352800"/>
+                </a:lnTo>
+                <a:lnTo>
+                  <a:pt x="12070081" y="2899955"/>
+                </a:lnTo>
+                <a:lnTo>
+                  <a:pt x="1149531" y="2899955"/>
+                </a:lnTo>
+                <a:lnTo>
+                  <a:pt x="1149531" y="2464521"/>
+                </a:lnTo>
+                <a:lnTo>
+                  <a:pt x="12070081" y="2464521"/>
+                </a:lnTo>
+                <a:lnTo>
+                  <a:pt x="12070081" y="1889760"/>
+                </a:lnTo>
+                <a:lnTo>
+                  <a:pt x="1149531" y="1889760"/>
+                </a:lnTo>
+                <a:lnTo>
+                  <a:pt x="809897" y="1889760"/>
                 </a:lnTo>
                 <a:close/>
                 <a:moveTo>
@@ -19658,7 +22963,7 @@
     </p:spTree>
     <p:extLst>
       <p:ext uri="{BB962C8B-B14F-4D97-AF65-F5344CB8AC3E}">
-        <p14:creationId xmlns:p14="http://schemas.microsoft.com/office/powerpoint/2010/main" val="1067268177"/>
+        <p14:creationId xmlns:p14="http://schemas.microsoft.com/office/powerpoint/2010/main" val="1494081883"/>
       </p:ext>
     </p:extLst>
   </p:cSld>
@@ -19688,7 +22993,7 @@
     </p:spTree>
     <p:extLst>
       <p:ext uri="{BB962C8B-B14F-4D97-AF65-F5344CB8AC3E}">
-        <p14:creationId xmlns:p14="http://schemas.microsoft.com/office/powerpoint/2010/main" val="773515612"/>
+        <p14:creationId xmlns:p14="http://schemas.microsoft.com/office/powerpoint/2010/main" val="3075218458"/>
       </p:ext>
     </p:extLst>
   </p:cSld>
@@ -19998,7 +23303,7 @@
         <p:cNvPr id="1" name="">
           <a:extLst>
             <a:ext uri="{FF2B5EF4-FFF2-40B4-BE49-F238E27FC236}">
-              <a16:creationId xmlns:a16="http://schemas.microsoft.com/office/drawing/2014/main" id="{4724B2FA-CAE3-073D-3914-16FA43C146F6}"/>
+              <a16:creationId xmlns:a16="http://schemas.microsoft.com/office/drawing/2014/main" id="{EC08846A-D3FB-CD26-D78C-C796BDF9FAF4}"/>
             </a:ext>
           </a:extLst>
         </p:cNvPr>
@@ -20015,10 +23320,10 @@
       </p:grpSpPr>
       <p:sp>
         <p:nvSpPr>
-          <p:cNvPr id="5" name="フリーフォーム: 図形 4">
+          <p:cNvPr id="7" name="フリーフォーム: 図形 6">
             <a:extLst>
               <a:ext uri="{FF2B5EF4-FFF2-40B4-BE49-F238E27FC236}">
-                <a16:creationId xmlns:a16="http://schemas.microsoft.com/office/drawing/2014/main" id="{F148968B-C55B-0F29-3148-82B87B564A55}"/>
+                <a16:creationId xmlns:a16="http://schemas.microsoft.com/office/drawing/2014/main" id="{9F93DB41-FE19-C187-BF7C-9F7CA6F33DD5}"/>
               </a:ext>
             </a:extLst>
           </p:cNvPr>
@@ -20033,22 +23338,30 @@
           <a:custGeom>
             <a:avLst/>
             <a:gdLst>
-              <a:gd name="csX0" fmla="*/ 1231075 w 12192000"/>
-              <a:gd name="csY0" fmla="*/ 2561112 h 6858000"/>
-              <a:gd name="csX1" fmla="*/ 1231075 w 12192000"/>
-              <a:gd name="csY1" fmla="*/ 3139044 h 6858000"/>
-              <a:gd name="csX2" fmla="*/ 10949049 w 12192000"/>
-              <a:gd name="csY2" fmla="*/ 3139044 h 6858000"/>
-              <a:gd name="csX3" fmla="*/ 10949049 w 12192000"/>
-              <a:gd name="csY3" fmla="*/ 2561112 h 6858000"/>
-              <a:gd name="csX4" fmla="*/ 0 w 12192000"/>
-              <a:gd name="csY4" fmla="*/ 0 h 6858000"/>
-              <a:gd name="csX5" fmla="*/ 12192000 w 12192000"/>
-              <a:gd name="csY5" fmla="*/ 0 h 6858000"/>
-              <a:gd name="csX6" fmla="*/ 12192000 w 12192000"/>
-              <a:gd name="csY6" fmla="*/ 6858000 h 6858000"/>
-              <a:gd name="csX7" fmla="*/ 0 w 12192000"/>
-              <a:gd name="csY7" fmla="*/ 6858000 h 6858000"/>
+              <a:gd name="csX0" fmla="*/ 121919 w 12192000"/>
+              <a:gd name="csY0" fmla="*/ 2464526 h 6858000"/>
+              <a:gd name="csX1" fmla="*/ 121919 w 12192000"/>
+              <a:gd name="csY1" fmla="*/ 3352800 h 6858000"/>
+              <a:gd name="csX2" fmla="*/ 1149530 w 12192000"/>
+              <a:gd name="csY2" fmla="*/ 3352800 h 6858000"/>
+              <a:gd name="csX3" fmla="*/ 1149530 w 12192000"/>
+              <a:gd name="csY3" fmla="*/ 2917371 h 6858000"/>
+              <a:gd name="csX4" fmla="*/ 12070079 w 12192000"/>
+              <a:gd name="csY4" fmla="*/ 2917371 h 6858000"/>
+              <a:gd name="csX5" fmla="*/ 12070079 w 12192000"/>
+              <a:gd name="csY5" fmla="*/ 2464526 h 6858000"/>
+              <a:gd name="csX6" fmla="*/ 1149530 w 12192000"/>
+              <a:gd name="csY6" fmla="*/ 2464526 h 6858000"/>
+              <a:gd name="csX7" fmla="*/ 905690 w 12192000"/>
+              <a:gd name="csY7" fmla="*/ 2464526 h 6858000"/>
+              <a:gd name="csX8" fmla="*/ 0 w 12192000"/>
+              <a:gd name="csY8" fmla="*/ 0 h 6858000"/>
+              <a:gd name="csX9" fmla="*/ 12192000 w 12192000"/>
+              <a:gd name="csY9" fmla="*/ 0 h 6858000"/>
+              <a:gd name="csX10" fmla="*/ 12192000 w 12192000"/>
+              <a:gd name="csY10" fmla="*/ 6858000 h 6858000"/>
+              <a:gd name="csX11" fmla="*/ 0 w 12192000"/>
+              <a:gd name="csY11" fmla="*/ 6858000 h 6858000"/>
             </a:gdLst>
             <a:ahLst/>
             <a:cxnLst>
@@ -20076,21 +23389,45 @@
               <a:cxn ang="0">
                 <a:pos x="csX7" y="csY7"/>
               </a:cxn>
+              <a:cxn ang="0">
+                <a:pos x="csX8" y="csY8"/>
+              </a:cxn>
+              <a:cxn ang="0">
+                <a:pos x="csX9" y="csY9"/>
+              </a:cxn>
+              <a:cxn ang="0">
+                <a:pos x="csX10" y="csY10"/>
+              </a:cxn>
+              <a:cxn ang="0">
+                <a:pos x="csX11" y="csY11"/>
+              </a:cxn>
             </a:cxnLst>
             <a:rect l="l" t="t" r="r" b="b"/>
             <a:pathLst>
               <a:path w="12192000" h="6858000">
                 <a:moveTo>
-                  <a:pt x="1231075" y="2561112"/>
+                  <a:pt x="121919" y="2464526"/>
                 </a:moveTo>
                 <a:lnTo>
-                  <a:pt x="1231075" y="3139044"/>
+                  <a:pt x="121919" y="3352800"/>
                 </a:lnTo>
                 <a:lnTo>
-                  <a:pt x="10949049" y="3139044"/>
+                  <a:pt x="1149530" y="3352800"/>
                 </a:lnTo>
                 <a:lnTo>
-                  <a:pt x="10949049" y="2561112"/>
+                  <a:pt x="1149530" y="2917371"/>
+                </a:lnTo>
+                <a:lnTo>
+                  <a:pt x="12070079" y="2917371"/>
+                </a:lnTo>
+                <a:lnTo>
+                  <a:pt x="12070079" y="2464526"/>
+                </a:lnTo>
+                <a:lnTo>
+                  <a:pt x="1149530" y="2464526"/>
+                </a:lnTo>
+                <a:lnTo>
+                  <a:pt x="905690" y="2464526"/>
                 </a:lnTo>
                 <a:close/>
                 <a:moveTo>
@@ -20148,7 +23485,7 @@
     </p:spTree>
     <p:extLst>
       <p:ext uri="{BB962C8B-B14F-4D97-AF65-F5344CB8AC3E}">
-        <p14:creationId xmlns:p14="http://schemas.microsoft.com/office/powerpoint/2010/main" val="1026212266"/>
+        <p14:creationId xmlns:p14="http://schemas.microsoft.com/office/powerpoint/2010/main" val="999516072"/>
       </p:ext>
     </p:extLst>
   </p:cSld>
@@ -20903,7 +24240,7 @@
         <p:cNvPr id="1" name="">
           <a:extLst>
             <a:ext uri="{FF2B5EF4-FFF2-40B4-BE49-F238E27FC236}">
-              <a16:creationId xmlns:a16="http://schemas.microsoft.com/office/drawing/2014/main" id="{DF8C9F35-6A47-053D-A9B4-9DF3785186E3}"/>
+              <a16:creationId xmlns:a16="http://schemas.microsoft.com/office/drawing/2014/main" id="{6A5BA00A-FCB0-217A-2F6F-AD9DB630A3E5}"/>
             </a:ext>
           </a:extLst>
         </p:cNvPr>
@@ -20920,10 +24257,10 @@
       </p:grpSpPr>
       <p:sp>
         <p:nvSpPr>
-          <p:cNvPr id="9" name="フリーフォーム: 図形 8">
+          <p:cNvPr id="10" name="フリーフォーム: 図形 9">
             <a:extLst>
               <a:ext uri="{FF2B5EF4-FFF2-40B4-BE49-F238E27FC236}">
-                <a16:creationId xmlns:a16="http://schemas.microsoft.com/office/drawing/2014/main" id="{41D468F9-87EE-D228-E052-73858281BF7D}"/>
+                <a16:creationId xmlns:a16="http://schemas.microsoft.com/office/drawing/2014/main" id="{F3795B1A-F94B-DE0A-495E-0DEF2E30E746}"/>
               </a:ext>
             </a:extLst>
           </p:cNvPr>
@@ -20938,34 +24275,30 @@
           <a:custGeom>
             <a:avLst/>
             <a:gdLst>
-              <a:gd name="csX0" fmla="*/ 1231075 w 12192000"/>
-              <a:gd name="csY0" fmla="*/ 3570514 h 6858000"/>
-              <a:gd name="csX1" fmla="*/ 1231075 w 12192000"/>
-              <a:gd name="csY1" fmla="*/ 4571999 h 6858000"/>
-              <a:gd name="csX2" fmla="*/ 1231075 w 12192000"/>
-              <a:gd name="csY2" fmla="*/ 5145972 h 6858000"/>
-              <a:gd name="csX3" fmla="*/ 1231075 w 12192000"/>
-              <a:gd name="csY3" fmla="*/ 5737760 h 6858000"/>
-              <a:gd name="csX4" fmla="*/ 2284021 w 12192000"/>
-              <a:gd name="csY4" fmla="*/ 5737760 h 6858000"/>
-              <a:gd name="csX5" fmla="*/ 2284021 w 12192000"/>
-              <a:gd name="csY5" fmla="*/ 5145972 h 6858000"/>
-              <a:gd name="csX6" fmla="*/ 10949049 w 12192000"/>
-              <a:gd name="csY6" fmla="*/ 5145972 h 6858000"/>
-              <a:gd name="csX7" fmla="*/ 10949049 w 12192000"/>
-              <a:gd name="csY7" fmla="*/ 4571999 h 6858000"/>
-              <a:gd name="csX8" fmla="*/ 2284021 w 12192000"/>
-              <a:gd name="csY8" fmla="*/ 4571999 h 6858000"/>
-              <a:gd name="csX9" fmla="*/ 2284021 w 12192000"/>
-              <a:gd name="csY9" fmla="*/ 3570514 h 6858000"/>
-              <a:gd name="csX10" fmla="*/ 0 w 12192000"/>
-              <a:gd name="csY10" fmla="*/ 0 h 6858000"/>
-              <a:gd name="csX11" fmla="*/ 12192000 w 12192000"/>
-              <a:gd name="csY11" fmla="*/ 0 h 6858000"/>
-              <a:gd name="csX12" fmla="*/ 12192000 w 12192000"/>
-              <a:gd name="csY12" fmla="*/ 6858000 h 6858000"/>
-              <a:gd name="csX13" fmla="*/ 0 w 12192000"/>
-              <a:gd name="csY13" fmla="*/ 6858000 h 6858000"/>
+              <a:gd name="csX0" fmla="*/ 121920 w 12192000"/>
+              <a:gd name="csY0" fmla="*/ 3788227 h 6858000"/>
+              <a:gd name="csX1" fmla="*/ 121920 w 12192000"/>
+              <a:gd name="csY1" fmla="*/ 5860868 h 6858000"/>
+              <a:gd name="csX2" fmla="*/ 1149531 w 12192000"/>
+              <a:gd name="csY2" fmla="*/ 5860868 h 6858000"/>
+              <a:gd name="csX3" fmla="*/ 1149531 w 12192000"/>
+              <a:gd name="csY3" fmla="*/ 5268687 h 6858000"/>
+              <a:gd name="csX4" fmla="*/ 12070081 w 12192000"/>
+              <a:gd name="csY4" fmla="*/ 5268687 h 6858000"/>
+              <a:gd name="csX5" fmla="*/ 12070081 w 12192000"/>
+              <a:gd name="csY5" fmla="*/ 4659087 h 6858000"/>
+              <a:gd name="csX6" fmla="*/ 1149531 w 12192000"/>
+              <a:gd name="csY6" fmla="*/ 4659087 h 6858000"/>
+              <a:gd name="csX7" fmla="*/ 1149531 w 12192000"/>
+              <a:gd name="csY7" fmla="*/ 3788227 h 6858000"/>
+              <a:gd name="csX8" fmla="*/ 0 w 12192000"/>
+              <a:gd name="csY8" fmla="*/ 0 h 6858000"/>
+              <a:gd name="csX9" fmla="*/ 12192000 w 12192000"/>
+              <a:gd name="csY9" fmla="*/ 0 h 6858000"/>
+              <a:gd name="csX10" fmla="*/ 12192000 w 12192000"/>
+              <a:gd name="csY10" fmla="*/ 6858000 h 6858000"/>
+              <a:gd name="csX11" fmla="*/ 0 w 12192000"/>
+              <a:gd name="csY11" fmla="*/ 6858000 h 6858000"/>
             </a:gdLst>
             <a:ahLst/>
             <a:cxnLst>
@@ -21005,45 +24338,33 @@
               <a:cxn ang="0">
                 <a:pos x="csX11" y="csY11"/>
               </a:cxn>
-              <a:cxn ang="0">
-                <a:pos x="csX12" y="csY12"/>
-              </a:cxn>
-              <a:cxn ang="0">
-                <a:pos x="csX13" y="csY13"/>
-              </a:cxn>
             </a:cxnLst>
             <a:rect l="l" t="t" r="r" b="b"/>
             <a:pathLst>
               <a:path w="12192000" h="6858000">
                 <a:moveTo>
-                  <a:pt x="1231075" y="3570514"/>
+                  <a:pt x="121920" y="3788227"/>
                 </a:moveTo>
                 <a:lnTo>
-                  <a:pt x="1231075" y="4571999"/>
+                  <a:pt x="121920" y="5860868"/>
                 </a:lnTo>
                 <a:lnTo>
-                  <a:pt x="1231075" y="5145972"/>
+                  <a:pt x="1149531" y="5860868"/>
                 </a:lnTo>
                 <a:lnTo>
-                  <a:pt x="1231075" y="5737760"/>
+                  <a:pt x="1149531" y="5268687"/>
                 </a:lnTo>
                 <a:lnTo>
-                  <a:pt x="2284021" y="5737760"/>
+                  <a:pt x="12070081" y="5268687"/>
                 </a:lnTo>
                 <a:lnTo>
-                  <a:pt x="2284021" y="5145972"/>
+                  <a:pt x="12070081" y="4659087"/>
                 </a:lnTo>
                 <a:lnTo>
-                  <a:pt x="10949049" y="5145972"/>
+                  <a:pt x="1149531" y="4659087"/>
                 </a:lnTo>
                 <a:lnTo>
-                  <a:pt x="10949049" y="4571999"/>
-                </a:lnTo>
-                <a:lnTo>
-                  <a:pt x="2284021" y="4571999"/>
-                </a:lnTo>
-                <a:lnTo>
-                  <a:pt x="2284021" y="3570514"/>
+                  <a:pt x="1149531" y="3788227"/>
                 </a:lnTo>
                 <a:close/>
                 <a:moveTo>
@@ -21100,10 +24421,10 @@
       </p:sp>
       <p:grpSp>
         <p:nvGrpSpPr>
-          <p:cNvPr id="10" name="グループ化 9">
+          <p:cNvPr id="11" name="グループ化 10">
             <a:extLst>
               <a:ext uri="{FF2B5EF4-FFF2-40B4-BE49-F238E27FC236}">
-                <a16:creationId xmlns:a16="http://schemas.microsoft.com/office/drawing/2014/main" id="{4D01BDE8-E4CC-EA9E-98F3-6D61EA5D89D3}"/>
+                <a16:creationId xmlns:a16="http://schemas.microsoft.com/office/drawing/2014/main" id="{4458B3FA-DD5F-7E65-3D02-B66BE681EA03}"/>
               </a:ext>
             </a:extLst>
           </p:cNvPr>
@@ -21112,7 +24433,7 @@
         </p:nvGrpSpPr>
         <p:grpSpPr>
           <a:xfrm>
-            <a:off x="383898" y="4223340"/>
+            <a:off x="2181475" y="5457620"/>
             <a:ext cx="1614399" cy="722865"/>
             <a:chOff x="2328672" y="1310640"/>
             <a:chExt cx="3267456" cy="1463040"/>
@@ -21127,10 +24448,10 @@
         </p:grpSpPr>
         <p:grpSp>
           <p:nvGrpSpPr>
-            <p:cNvPr id="11" name="グループ化 10">
+            <p:cNvPr id="12" name="グループ化 11">
               <a:extLst>
                 <a:ext uri="{FF2B5EF4-FFF2-40B4-BE49-F238E27FC236}">
-                  <a16:creationId xmlns:a16="http://schemas.microsoft.com/office/drawing/2014/main" id="{9C0BC293-A11F-46B5-1BF1-282433EB5713}"/>
+                  <a16:creationId xmlns:a16="http://schemas.microsoft.com/office/drawing/2014/main" id="{E41D383B-0D1B-A49A-4A42-20E5BF6202DB}"/>
                 </a:ext>
               </a:extLst>
             </p:cNvPr>
@@ -21147,10 +24468,10 @@
           </p:grpSpPr>
           <p:sp>
             <p:nvSpPr>
-              <p:cNvPr id="13" name="思考の吹き出し: 雲形 12">
+              <p:cNvPr id="14" name="思考の吹き出し: 雲形 13">
                 <a:extLst>
                   <a:ext uri="{FF2B5EF4-FFF2-40B4-BE49-F238E27FC236}">
-                    <a16:creationId xmlns:a16="http://schemas.microsoft.com/office/drawing/2014/main" id="{27FF92D8-B7E7-EFB8-7106-5F487D72DBBB}"/>
+                    <a16:creationId xmlns:a16="http://schemas.microsoft.com/office/drawing/2014/main" id="{46FE8C73-F6EE-726E-7C5D-F91D0468D34F}"/>
                   </a:ext>
                 </a:extLst>
               </p:cNvPr>
@@ -21164,8 +24485,8 @@
               </a:xfrm>
               <a:prstGeom prst="cloudCallout">
                 <a:avLst>
-                  <a:gd name="adj1" fmla="val 74292"/>
-                  <a:gd name="adj2" fmla="val 3572"/>
+                  <a:gd name="adj1" fmla="val -21667"/>
+                  <a:gd name="adj2" fmla="val -87520"/>
                 </a:avLst>
               </a:prstGeom>
               <a:solidFill>
@@ -21207,10 +24528,10 @@
           </p:sp>
           <p:sp>
             <p:nvSpPr>
-              <p:cNvPr id="14" name="正方形/長方形 13">
+              <p:cNvPr id="15" name="正方形/長方形 14">
                 <a:extLst>
                   <a:ext uri="{FF2B5EF4-FFF2-40B4-BE49-F238E27FC236}">
-                    <a16:creationId xmlns:a16="http://schemas.microsoft.com/office/drawing/2014/main" id="{F8D90C52-E3BE-463F-7552-90613F6F50EC}"/>
+                    <a16:creationId xmlns:a16="http://schemas.microsoft.com/office/drawing/2014/main" id="{13597ACE-9AD8-56F9-3508-391FF01F017A}"/>
                   </a:ext>
                 </a:extLst>
               </p:cNvPr>
@@ -21262,10 +24583,10 @@
           </p:sp>
           <p:sp>
             <p:nvSpPr>
-              <p:cNvPr id="15" name="正方形/長方形 14">
+              <p:cNvPr id="16" name="正方形/長方形 15">
                 <a:extLst>
                   <a:ext uri="{FF2B5EF4-FFF2-40B4-BE49-F238E27FC236}">
-                    <a16:creationId xmlns:a16="http://schemas.microsoft.com/office/drawing/2014/main" id="{9B670A6D-390F-FFCB-A014-8A7340BBC905}"/>
+                    <a16:creationId xmlns:a16="http://schemas.microsoft.com/office/drawing/2014/main" id="{581811C4-C0E0-EC59-2668-BF31AA0B50F5}"/>
                   </a:ext>
                 </a:extLst>
               </p:cNvPr>
@@ -21317,10 +24638,10 @@
           </p:sp>
           <p:sp>
             <p:nvSpPr>
-              <p:cNvPr id="16" name="正方形/長方形 15">
+              <p:cNvPr id="17" name="正方形/長方形 16">
                 <a:extLst>
                   <a:ext uri="{FF2B5EF4-FFF2-40B4-BE49-F238E27FC236}">
-                    <a16:creationId xmlns:a16="http://schemas.microsoft.com/office/drawing/2014/main" id="{285D2E3E-DBF3-49AA-524B-203A67B813BC}"/>
+                    <a16:creationId xmlns:a16="http://schemas.microsoft.com/office/drawing/2014/main" id="{50854E96-5E54-8F33-97EB-829FEEC460C3}"/>
                   </a:ext>
                 </a:extLst>
               </p:cNvPr>
@@ -21373,10 +24694,10 @@
         </p:grpSp>
         <p:sp>
           <p:nvSpPr>
-            <p:cNvPr id="12" name="正方形/長方形 11">
+            <p:cNvPr id="13" name="正方形/長方形 12">
               <a:extLst>
                 <a:ext uri="{FF2B5EF4-FFF2-40B4-BE49-F238E27FC236}">
-                  <a16:creationId xmlns:a16="http://schemas.microsoft.com/office/drawing/2014/main" id="{B478CC21-3279-796E-3986-ED59388EB786}"/>
+                  <a16:creationId xmlns:a16="http://schemas.microsoft.com/office/drawing/2014/main" id="{D648335D-87F0-644B-F9C2-460404AEBF18}"/>
                 </a:ext>
               </a:extLst>
             </p:cNvPr>
@@ -21443,7 +24764,7 @@
     </p:spTree>
     <p:extLst>
       <p:ext uri="{BB962C8B-B14F-4D97-AF65-F5344CB8AC3E}">
-        <p14:creationId xmlns:p14="http://schemas.microsoft.com/office/powerpoint/2010/main" val="1453194258"/>
+        <p14:creationId xmlns:p14="http://schemas.microsoft.com/office/powerpoint/2010/main" val="744893108"/>
       </p:ext>
     </p:extLst>
   </p:cSld>

</xml_diff>